<commit_message>
Fixed some bugs and tweaked some numbers
</commit_message>
<xml_diff>
--- a/Poster.pptx
+++ b/Poster.pptx
@@ -277,7 +277,7 @@
           <a:p>
             <a:fld id="{72EA7947-E287-4738-8C82-07CE4F01EF03}" type="datetime2">
               <a:rPr lang="en-US" smtClean="0"/>
-              <a:t>Sunday, March 15, 2026</a:t>
+              <a:t>Friday, March 20, 2026</a:t>
             </a:fld>
             <a:endParaRPr lang="en-US" dirty="0"/>
           </a:p>
@@ -1313,7 +1313,7 @@
           <a:p>
             <a:fld id="{EE2EBD84-71F4-4271-8C46-0D47C0A9B12E}" type="datetime2">
               <a:rPr lang="en-US" smtClean="0"/>
-              <a:t>Sunday, March 15, 2026</a:t>
+              <a:t>Friday, March 20, 2026</a:t>
             </a:fld>
             <a:endParaRPr lang="en-US"/>
           </a:p>
@@ -1524,7 +1524,7 @@
           <a:p>
             <a:fld id="{ABAE0CE1-F450-4107-B2CB-17B18F8A3F4A}" type="datetime2">
               <a:rPr lang="en-US" smtClean="0"/>
-              <a:t>Sunday, March 15, 2026</a:t>
+              <a:t>Friday, March 20, 2026</a:t>
             </a:fld>
             <a:endParaRPr lang="en-US"/>
           </a:p>
@@ -2189,7 +2189,7 @@
           <a:p>
             <a:fld id="{6FE8C025-CD7A-4966-867E-81CF82B15267}" type="datetime2">
               <a:rPr lang="en-US" smtClean="0"/>
-              <a:t>Sunday, March 15, 2026</a:t>
+              <a:t>Friday, March 20, 2026</a:t>
             </a:fld>
             <a:endParaRPr lang="en-US"/>
           </a:p>
@@ -2809,7 +2809,7 @@
           <a:p>
             <a:fld id="{FE809929-0719-4517-94D6-FDF7F99E70F6}" type="datetime2">
               <a:rPr lang="en-US" smtClean="0"/>
-              <a:t>Sunday, March 15, 2026</a:t>
+              <a:t>Friday, March 20, 2026</a:t>
             </a:fld>
             <a:endParaRPr lang="en-US"/>
           </a:p>
@@ -3927,7 +3927,7 @@
           <a:p>
             <a:fld id="{20E95673-5512-4AAA-9AEB-E00C61EC65D5}" type="datetime2">
               <a:rPr lang="en-US" smtClean="0"/>
-              <a:t>Sunday, March 15, 2026</a:t>
+              <a:t>Friday, March 20, 2026</a:t>
             </a:fld>
             <a:endParaRPr lang="en-US"/>
           </a:p>
@@ -4474,7 +4474,7 @@
           <a:p>
             <a:fld id="{C13138FA-2E87-4873-8BBA-13E447C9A99A}" type="datetime2">
               <a:rPr lang="en-US" smtClean="0"/>
-              <a:t>Sunday, March 15, 2026</a:t>
+              <a:t>Friday, March 20, 2026</a:t>
             </a:fld>
             <a:endParaRPr lang="en-US"/>
           </a:p>
@@ -4635,7 +4635,7 @@
           <a:p>
             <a:fld id="{D75BB40A-97BD-4BFB-B639-0BFF95FDE8B7}" type="datetime2">
               <a:rPr lang="en-US" smtClean="0"/>
-              <a:t>Sunday, March 15, 2026</a:t>
+              <a:t>Friday, March 20, 2026</a:t>
             </a:fld>
             <a:endParaRPr lang="en-US"/>
           </a:p>
@@ -5670,7 +5670,7 @@
           <a:p>
             <a:fld id="{9EE9E0E3-ECF6-4CFE-8698-AEFEBCECC3C0}" type="datetime2">
               <a:rPr lang="en-US" smtClean="0"/>
-              <a:t>Sunday, March 15, 2026</a:t>
+              <a:t>Friday, March 20, 2026</a:t>
             </a:fld>
             <a:endParaRPr lang="en-US"/>
           </a:p>
@@ -6316,7 +6316,7 @@
           <a:p>
             <a:fld id="{251462FC-960E-4740-921F-B36862979F21}" type="datetime2">
               <a:rPr lang="en-US" smtClean="0"/>
-              <a:t>Sunday, March 15, 2026</a:t>
+              <a:t>Friday, March 20, 2026</a:t>
             </a:fld>
             <a:endParaRPr lang="en-US"/>
           </a:p>
@@ -7080,7 +7080,7 @@
           <a:p>
             <a:fld id="{E50BC9E2-CB44-4C05-9BB5-496C18A241E0}" type="datetime2">
               <a:rPr lang="en-US" smtClean="0"/>
-              <a:t>Sunday, March 15, 2026</a:t>
+              <a:t>Friday, March 20, 2026</a:t>
             </a:fld>
             <a:endParaRPr lang="en-US"/>
           </a:p>
@@ -7333,7 +7333,7 @@
           <a:p>
             <a:fld id="{246CB39B-5F4C-4A7E-9BE3-AAFD45576D16}" type="datetime2">
               <a:rPr lang="en-US" smtClean="0"/>
-              <a:t>Sunday, March 15, 2026</a:t>
+              <a:t>Friday, March 20, 2026</a:t>
             </a:fld>
             <a:endParaRPr lang="en-US" dirty="0"/>
           </a:p>

</xml_diff>

<commit_message>
Finished lighting and started poster improvements
</commit_message>
<xml_diff>
--- a/Poster.pptx
+++ b/Poster.pptx
@@ -277,7 +277,7 @@
           <a:p>
             <a:fld id="{72EA7947-E287-4738-8C82-07CE4F01EF03}" type="datetime2">
               <a:rPr lang="en-US" smtClean="0"/>
-              <a:t>Friday, March 20, 2026</a:t>
+              <a:t>Monday, March 30, 2026</a:t>
             </a:fld>
             <a:endParaRPr lang="en-US" dirty="0"/>
           </a:p>
@@ -1313,7 +1313,7 @@
           <a:p>
             <a:fld id="{EE2EBD84-71F4-4271-8C46-0D47C0A9B12E}" type="datetime2">
               <a:rPr lang="en-US" smtClean="0"/>
-              <a:t>Friday, March 20, 2026</a:t>
+              <a:t>Monday, March 30, 2026</a:t>
             </a:fld>
             <a:endParaRPr lang="en-US"/>
           </a:p>
@@ -1524,7 +1524,7 @@
           <a:p>
             <a:fld id="{ABAE0CE1-F450-4107-B2CB-17B18F8A3F4A}" type="datetime2">
               <a:rPr lang="en-US" smtClean="0"/>
-              <a:t>Friday, March 20, 2026</a:t>
+              <a:t>Monday, March 30, 2026</a:t>
             </a:fld>
             <a:endParaRPr lang="en-US"/>
           </a:p>
@@ -2189,7 +2189,7 @@
           <a:p>
             <a:fld id="{6FE8C025-CD7A-4966-867E-81CF82B15267}" type="datetime2">
               <a:rPr lang="en-US" smtClean="0"/>
-              <a:t>Friday, March 20, 2026</a:t>
+              <a:t>Monday, March 30, 2026</a:t>
             </a:fld>
             <a:endParaRPr lang="en-US"/>
           </a:p>
@@ -2809,7 +2809,7 @@
           <a:p>
             <a:fld id="{FE809929-0719-4517-94D6-FDF7F99E70F6}" type="datetime2">
               <a:rPr lang="en-US" smtClean="0"/>
-              <a:t>Friday, March 20, 2026</a:t>
+              <a:t>Monday, March 30, 2026</a:t>
             </a:fld>
             <a:endParaRPr lang="en-US"/>
           </a:p>
@@ -3927,7 +3927,7 @@
           <a:p>
             <a:fld id="{20E95673-5512-4AAA-9AEB-E00C61EC65D5}" type="datetime2">
               <a:rPr lang="en-US" smtClean="0"/>
-              <a:t>Friday, March 20, 2026</a:t>
+              <a:t>Monday, March 30, 2026</a:t>
             </a:fld>
             <a:endParaRPr lang="en-US"/>
           </a:p>
@@ -4474,7 +4474,7 @@
           <a:p>
             <a:fld id="{C13138FA-2E87-4873-8BBA-13E447C9A99A}" type="datetime2">
               <a:rPr lang="en-US" smtClean="0"/>
-              <a:t>Friday, March 20, 2026</a:t>
+              <a:t>Monday, March 30, 2026</a:t>
             </a:fld>
             <a:endParaRPr lang="en-US"/>
           </a:p>
@@ -4635,7 +4635,7 @@
           <a:p>
             <a:fld id="{D75BB40A-97BD-4BFB-B639-0BFF95FDE8B7}" type="datetime2">
               <a:rPr lang="en-US" smtClean="0"/>
-              <a:t>Friday, March 20, 2026</a:t>
+              <a:t>Monday, March 30, 2026</a:t>
             </a:fld>
             <a:endParaRPr lang="en-US"/>
           </a:p>
@@ -5670,7 +5670,7 @@
           <a:p>
             <a:fld id="{9EE9E0E3-ECF6-4CFE-8698-AEFEBCECC3C0}" type="datetime2">
               <a:rPr lang="en-US" smtClean="0"/>
-              <a:t>Friday, March 20, 2026</a:t>
+              <a:t>Monday, March 30, 2026</a:t>
             </a:fld>
             <a:endParaRPr lang="en-US"/>
           </a:p>
@@ -6316,7 +6316,7 @@
           <a:p>
             <a:fld id="{251462FC-960E-4740-921F-B36862979F21}" type="datetime2">
               <a:rPr lang="en-US" smtClean="0"/>
-              <a:t>Friday, March 20, 2026</a:t>
+              <a:t>Monday, March 30, 2026</a:t>
             </a:fld>
             <a:endParaRPr lang="en-US"/>
           </a:p>
@@ -7080,7 +7080,7 @@
           <a:p>
             <a:fld id="{E50BC9E2-CB44-4C05-9BB5-496C18A241E0}" type="datetime2">
               <a:rPr lang="en-US" smtClean="0"/>
-              <a:t>Friday, March 20, 2026</a:t>
+              <a:t>Monday, March 30, 2026</a:t>
             </a:fld>
             <a:endParaRPr lang="en-US"/>
           </a:p>
@@ -7333,7 +7333,7 @@
           <a:p>
             <a:fld id="{246CB39B-5F4C-4A7E-9BE3-AAFD45576D16}" type="datetime2">
               <a:rPr lang="en-US" smtClean="0"/>
-              <a:t>Friday, March 20, 2026</a:t>
+              <a:t>Monday, March 30, 2026</a:t>
             </a:fld>
             <a:endParaRPr lang="en-US" dirty="0"/>
           </a:p>
@@ -7869,58 +7869,6 @@
           </a:p>
         </p:txBody>
       </p:sp>
-      <p:pic>
-        <p:nvPicPr>
-          <p:cNvPr id="5" name="Picture 4">
-            <a:extLst>
-              <a:ext uri="{FF2B5EF4-FFF2-40B4-BE49-F238E27FC236}">
-                <a16:creationId xmlns:a16="http://schemas.microsoft.com/office/drawing/2014/main" id="{370A0985-9ECE-3E73-D95D-C7FFED529923}"/>
-              </a:ext>
-            </a:extLst>
-          </p:cNvPr>
-          <p:cNvPicPr>
-            <a:picLocks noChangeAspect="1"/>
-          </p:cNvPicPr>
-          <p:nvPr/>
-        </p:nvPicPr>
-        <p:blipFill>
-          <a:blip r:embed="rId2"/>
-          <a:srcRect l="6" t="4550" r="-7" b="7040"/>
-          <a:stretch>
-            <a:fillRect/>
-          </a:stretch>
-        </p:blipFill>
-        <p:spPr>
-          <a:xfrm>
-            <a:off x="-1" y="0"/>
-            <a:ext cx="12191980" cy="5990792"/>
-          </a:xfrm>
-          <a:custGeom>
-            <a:avLst/>
-            <a:gdLst/>
-            <a:ahLst/>
-            <a:cxnLst/>
-            <a:rect l="l" t="t" r="r" b="b"/>
-            <a:pathLst>
-              <a:path w="12192000" h="4774564">
-                <a:moveTo>
-                  <a:pt x="0" y="0"/>
-                </a:moveTo>
-                <a:lnTo>
-                  <a:pt x="12192000" y="0"/>
-                </a:lnTo>
-                <a:lnTo>
-                  <a:pt x="12192000" y="4774564"/>
-                </a:lnTo>
-                <a:lnTo>
-                  <a:pt x="0" y="4774564"/>
-                </a:lnTo>
-                <a:close/>
-              </a:path>
-            </a:pathLst>
-          </a:custGeom>
-        </p:spPr>
-      </p:pic>
       <p:sp>
         <p:nvSpPr>
           <p:cNvPr id="2" name="Title 1">
@@ -7963,7 +7911,7 @@
             </a:br>
             <a:r>
               <a:rPr lang="en-GB" sz="1800" dirty="0">
-                <a:hlinkClick r:id="rId3"/>
+                <a:hlinkClick r:id="rId2"/>
               </a:rPr>
               <a:t>michael.hooper@students.Plymouth.ac.uk</a:t>
             </a:r>
@@ -8068,7 +8016,7 @@
           <p:nvPr/>
         </p:nvPicPr>
         <p:blipFill>
-          <a:blip r:embed="rId4"/>
+          <a:blip r:embed="rId3"/>
           <a:stretch>
             <a:fillRect/>
           </a:stretch>
@@ -8098,7 +8046,7 @@
           <p:nvPr/>
         </p:nvPicPr>
         <p:blipFill>
-          <a:blip r:embed="rId5"/>
+          <a:blip r:embed="rId4"/>
           <a:stretch>
             <a:fillRect/>
           </a:stretch>
@@ -8128,7 +8076,7 @@
           <p:nvPr/>
         </p:nvPicPr>
         <p:blipFill>
-          <a:blip r:embed="rId6"/>
+          <a:blip r:embed="rId5"/>
           <a:stretch>
             <a:fillRect/>
           </a:stretch>
@@ -8143,12 +8091,163 @@
           </a:prstGeom>
         </p:spPr>
       </p:pic>
+      <p:pic>
+        <p:nvPicPr>
+          <p:cNvPr id="12" name="Picture 11">
+            <a:extLst>
+              <a:ext uri="{FF2B5EF4-FFF2-40B4-BE49-F238E27FC236}">
+                <a16:creationId xmlns:a16="http://schemas.microsoft.com/office/drawing/2014/main" id="{5790FD15-1416-D5DD-7D31-5ED12D97098E}"/>
+              </a:ext>
+            </a:extLst>
+          </p:cNvPr>
+          <p:cNvPicPr>
+            <a:picLocks noChangeAspect="1"/>
+          </p:cNvPicPr>
+          <p:nvPr/>
+        </p:nvPicPr>
+        <p:blipFill>
+          <a:blip r:embed="rId6"/>
+          <a:srcRect t="12296"/>
+          <a:stretch>
+            <a:fillRect/>
+          </a:stretch>
+        </p:blipFill>
+        <p:spPr>
+          <a:xfrm>
+            <a:off x="0" y="0"/>
+            <a:ext cx="12192000" cy="5990792"/>
+          </a:xfrm>
+          <a:prstGeom prst="rect">
+            <a:avLst/>
+          </a:prstGeom>
+        </p:spPr>
+      </p:pic>
+      <p:pic>
+        <p:nvPicPr>
+          <p:cNvPr id="16" name="Picture 15">
+            <a:extLst>
+              <a:ext uri="{FF2B5EF4-FFF2-40B4-BE49-F238E27FC236}">
+                <a16:creationId xmlns:a16="http://schemas.microsoft.com/office/drawing/2014/main" id="{23FE44DE-BC03-61CC-5886-3CA9273730E3}"/>
+              </a:ext>
+            </a:extLst>
+          </p:cNvPr>
+          <p:cNvPicPr>
+            <a:picLocks noChangeAspect="1"/>
+          </p:cNvPicPr>
+          <p:nvPr/>
+        </p:nvPicPr>
+        <p:blipFill>
+          <a:blip r:embed="rId7"/>
+          <a:stretch>
+            <a:fillRect/>
+          </a:stretch>
+        </p:blipFill>
+        <p:spPr>
+          <a:xfrm>
+            <a:off x="-1" y="0"/>
+            <a:ext cx="818969" cy="1400173"/>
+          </a:xfrm>
+          <a:prstGeom prst="rect">
+            <a:avLst/>
+          </a:prstGeom>
+        </p:spPr>
+      </p:pic>
+      <p:pic>
+        <p:nvPicPr>
+          <p:cNvPr id="20" name="Picture 19">
+            <a:extLst>
+              <a:ext uri="{FF2B5EF4-FFF2-40B4-BE49-F238E27FC236}">
+                <a16:creationId xmlns:a16="http://schemas.microsoft.com/office/drawing/2014/main" id="{F73AA51E-4923-CDD1-4133-F1184B21179B}"/>
+              </a:ext>
+            </a:extLst>
+          </p:cNvPr>
+          <p:cNvPicPr>
+            <a:picLocks noChangeAspect="1"/>
+          </p:cNvPicPr>
+          <p:nvPr/>
+        </p:nvPicPr>
+        <p:blipFill>
+          <a:blip r:embed="rId8"/>
+          <a:stretch>
+            <a:fillRect/>
+          </a:stretch>
+        </p:blipFill>
+        <p:spPr>
+          <a:xfrm>
+            <a:off x="0" y="1398369"/>
+            <a:ext cx="818968" cy="1414237"/>
+          </a:xfrm>
+          <a:prstGeom prst="rect">
+            <a:avLst/>
+          </a:prstGeom>
+        </p:spPr>
+      </p:pic>
+      <p:pic>
+        <p:nvPicPr>
+          <p:cNvPr id="27" name="Picture 26">
+            <a:extLst>
+              <a:ext uri="{FF2B5EF4-FFF2-40B4-BE49-F238E27FC236}">
+                <a16:creationId xmlns:a16="http://schemas.microsoft.com/office/drawing/2014/main" id="{1205FD5D-DED8-455E-54BB-2BC28036D3CF}"/>
+              </a:ext>
+            </a:extLst>
+          </p:cNvPr>
+          <p:cNvPicPr>
+            <a:picLocks noChangeAspect="1"/>
+          </p:cNvPicPr>
+          <p:nvPr/>
+        </p:nvPicPr>
+        <p:blipFill>
+          <a:blip r:embed="rId9"/>
+          <a:stretch>
+            <a:fillRect/>
+          </a:stretch>
+        </p:blipFill>
+        <p:spPr>
+          <a:xfrm>
+            <a:off x="0" y="2812606"/>
+            <a:ext cx="818968" cy="1400171"/>
+          </a:xfrm>
+          <a:prstGeom prst="rect">
+            <a:avLst/>
+          </a:prstGeom>
+        </p:spPr>
+      </p:pic>
+      <p:pic>
+        <p:nvPicPr>
+          <p:cNvPr id="29" name="Picture 28">
+            <a:extLst>
+              <a:ext uri="{FF2B5EF4-FFF2-40B4-BE49-F238E27FC236}">
+                <a16:creationId xmlns:a16="http://schemas.microsoft.com/office/drawing/2014/main" id="{660CCF62-1E69-B08F-9E7C-D8E4C6662605}"/>
+              </a:ext>
+            </a:extLst>
+          </p:cNvPr>
+          <p:cNvPicPr>
+            <a:picLocks noChangeAspect="1"/>
+          </p:cNvPicPr>
+          <p:nvPr/>
+        </p:nvPicPr>
+        <p:blipFill>
+          <a:blip r:embed="rId10"/>
+          <a:stretch>
+            <a:fillRect/>
+          </a:stretch>
+        </p:blipFill>
+        <p:spPr>
+          <a:xfrm>
+            <a:off x="1" y="4210975"/>
+            <a:ext cx="820530" cy="1400171"/>
+          </a:xfrm>
+          <a:prstGeom prst="rect">
+            <a:avLst/>
+          </a:prstGeom>
+        </p:spPr>
+      </p:pic>
       <p:sp>
         <p:nvSpPr>
-          <p:cNvPr id="8" name="Rectangle 7">
-            <a:extLst>
-              <a:ext uri="{FF2B5EF4-FFF2-40B4-BE49-F238E27FC236}">
-                <a16:creationId xmlns:a16="http://schemas.microsoft.com/office/drawing/2014/main" id="{03778013-A7D2-D1A0-2F06-949B5D76E063}"/>
+          <p:cNvPr id="30" name="Rectangle 29">
+            <a:extLst>
+              <a:ext uri="{FF2B5EF4-FFF2-40B4-BE49-F238E27FC236}">
+                <a16:creationId xmlns:a16="http://schemas.microsoft.com/office/drawing/2014/main" id="{8382977B-C19A-52B0-757B-D1D7D14217C6}"/>
               </a:ext>
             </a:extLst>
           </p:cNvPr>
@@ -8157,8 +8256,8 @@
         </p:nvSpPr>
         <p:spPr>
           <a:xfrm>
-            <a:off x="1" y="-1"/>
-            <a:ext cx="8703734" cy="999067"/>
+            <a:off x="2659380" y="1217394"/>
+            <a:ext cx="6865620" cy="1161739"/>
           </a:xfrm>
           <a:prstGeom prst="rect">
             <a:avLst/>
@@ -8168,6 +8267,13 @@
               <a:alpha val="50196"/>
             </a:srgbClr>
           </a:solidFill>
+          <a:ln>
+            <a:solidFill>
+              <a:srgbClr val="000000">
+                <a:alpha val="50196"/>
+              </a:srgbClr>
+            </a:solidFill>
+          </a:ln>
         </p:spPr>
         <p:style>
           <a:lnRef idx="2">
@@ -8196,10 +8302,10 @@
       </p:sp>
       <p:sp>
         <p:nvSpPr>
-          <p:cNvPr id="11" name="TextBox 10">
-            <a:extLst>
-              <a:ext uri="{FF2B5EF4-FFF2-40B4-BE49-F238E27FC236}">
-                <a16:creationId xmlns:a16="http://schemas.microsoft.com/office/drawing/2014/main" id="{33991C12-BB00-AD99-4E18-2D0D1468CE5A}"/>
+          <p:cNvPr id="31" name="TextBox 30">
+            <a:extLst>
+              <a:ext uri="{FF2B5EF4-FFF2-40B4-BE49-F238E27FC236}">
+                <a16:creationId xmlns:a16="http://schemas.microsoft.com/office/drawing/2014/main" id="{2C344758-EA4E-2405-7EDC-A98EA2682C86}"/>
               </a:ext>
             </a:extLst>
           </p:cNvPr>
@@ -8208,8 +8314,8 @@
         </p:nvSpPr>
         <p:spPr>
           <a:xfrm>
-            <a:off x="0" y="-1"/>
-            <a:ext cx="8703734" cy="923330"/>
+            <a:off x="2659378" y="1210733"/>
+            <a:ext cx="6865621" cy="1107996"/>
           </a:xfrm>
           <a:prstGeom prst="rect">
             <a:avLst/>
@@ -8224,406 +8330,15 @@
           <a:p>
             <a:pPr algn="ctr"/>
             <a:r>
-              <a:rPr lang="en-GB" sz="5400" dirty="0">
-                <a:latin typeface="Zain Fishing Hooks" panose="02000503000000000000" pitchFamily="2" charset="0"/>
-              </a:rPr>
-              <a:t>Hook Line and Slinger</a:t>
+              <a:rPr lang="en-GB" u="sng" dirty="0"/>
+              <a:t>Summary</a:t>
             </a:r>
           </a:p>
-        </p:txBody>
-      </p:sp>
-      <p:sp>
-        <p:nvSpPr>
-          <p:cNvPr id="3" name="Rectangle 2">
-            <a:extLst>
-              <a:ext uri="{FF2B5EF4-FFF2-40B4-BE49-F238E27FC236}">
-                <a16:creationId xmlns:a16="http://schemas.microsoft.com/office/drawing/2014/main" id="{57E600F4-1615-1AC0-0AA6-84DD6422511C}"/>
-              </a:ext>
-            </a:extLst>
-          </p:cNvPr>
-          <p:cNvSpPr/>
-          <p:nvPr/>
-        </p:nvSpPr>
-        <p:spPr>
-          <a:xfrm>
-            <a:off x="0" y="4549675"/>
-            <a:ext cx="12192000" cy="1441116"/>
-          </a:xfrm>
-          <a:prstGeom prst="rect">
-            <a:avLst/>
-          </a:prstGeom>
-          <a:solidFill>
-            <a:srgbClr val="000000">
-              <a:alpha val="50196"/>
-            </a:srgbClr>
-          </a:solidFill>
-        </p:spPr>
-        <p:style>
-          <a:lnRef idx="2">
-            <a:schemeClr val="accent6"/>
-          </a:lnRef>
-          <a:fillRef idx="1">
-            <a:schemeClr val="lt1"/>
-          </a:fillRef>
-          <a:effectRef idx="0">
-            <a:schemeClr val="accent6"/>
-          </a:effectRef>
-          <a:fontRef idx="minor">
-            <a:schemeClr val="dk1"/>
-          </a:fontRef>
-        </p:style>
-        <p:txBody>
-          <a:bodyPr rtlCol="0" anchor="ctr"/>
-          <a:lstStyle/>
-          <a:p>
-            <a:pPr algn="ctr"/>
-            <a:endParaRPr lang="en-GB"/>
-          </a:p>
-        </p:txBody>
-      </p:sp>
-      <p:sp>
-        <p:nvSpPr>
-          <p:cNvPr id="4" name="TextBox 3">
-            <a:extLst>
-              <a:ext uri="{FF2B5EF4-FFF2-40B4-BE49-F238E27FC236}">
-                <a16:creationId xmlns:a16="http://schemas.microsoft.com/office/drawing/2014/main" id="{FF3E92D2-E628-C402-8984-B005332B5029}"/>
-              </a:ext>
-            </a:extLst>
-          </p:cNvPr>
-          <p:cNvSpPr txBox="1"/>
-          <p:nvPr/>
-        </p:nvSpPr>
-        <p:spPr>
-          <a:xfrm>
-            <a:off x="-43" y="4549677"/>
-            <a:ext cx="12192022" cy="2308324"/>
-          </a:xfrm>
-          <a:prstGeom prst="rect">
-            <a:avLst/>
-          </a:prstGeom>
-          <a:noFill/>
-          <a:ln>
-            <a:solidFill>
-              <a:srgbClr val="000000"/>
-            </a:solidFill>
-          </a:ln>
-        </p:spPr>
-        <p:txBody>
-          <a:bodyPr wrap="square" numCol="3" rtlCol="0">
-            <a:spAutoFit/>
-          </a:bodyPr>
-          <a:lstStyle/>
-          <a:p>
-            <a:pPr marL="285750" indent="-285750" algn="ctr">
-              <a:buFont typeface="Arial" panose="020B0604020202020204" pitchFamily="34" charset="0"/>
-              <a:buChar char="•"/>
-            </a:pPr>
-            <a:r>
-              <a:rPr lang="en-GB" dirty="0"/>
-              <a:t>Hook, Line and Slinger is a 2d action platformer where you play as a fisherman and sushi chef trying to find the most exotic fish for his restaurant.</a:t>
-            </a:r>
-          </a:p>
-          <a:p>
-            <a:endParaRPr lang="en-GB" dirty="0"/>
-          </a:p>
-          <a:p>
-            <a:endParaRPr lang="en-GB" dirty="0"/>
-          </a:p>
-          <a:p>
-            <a:endParaRPr lang="en-GB" dirty="0"/>
-          </a:p>
-          <a:p>
-            <a:endParaRPr lang="en-GB" dirty="0"/>
-          </a:p>
-          <a:p>
-            <a:pPr marL="285750" indent="-285750" algn="ctr">
-              <a:buFont typeface="Arial" panose="020B0604020202020204" pitchFamily="34" charset="0"/>
-              <a:buChar char="•"/>
-            </a:pPr>
-            <a:r>
-              <a:rPr lang="en-GB" dirty="0"/>
-              <a:t>Swing through levels with your trusty grappling hook and collect new and unique types of bait to catch all kinds of fish.</a:t>
-            </a:r>
-          </a:p>
-          <a:p>
-            <a:endParaRPr lang="en-GB" dirty="0"/>
-          </a:p>
-          <a:p>
-            <a:endParaRPr lang="en-GB" dirty="0"/>
-          </a:p>
-          <a:p>
-            <a:endParaRPr lang="en-GB" dirty="0"/>
-          </a:p>
-          <a:p>
-            <a:endParaRPr lang="en-GB" dirty="0"/>
-          </a:p>
-          <a:p>
-            <a:pPr marL="285750" indent="-285750" algn="ctr">
-              <a:buFont typeface="Arial" panose="020B0604020202020204" pitchFamily="34" charset="0"/>
-              <a:buChar char="•"/>
-            </a:pPr>
-            <a:r>
-              <a:rPr lang="en-GB" dirty="0"/>
-              <a:t>Explore multiple environments before defeating challenging bosses, all while trying to improve your time.</a:t>
-            </a:r>
-          </a:p>
-        </p:txBody>
-      </p:sp>
-      <p:sp>
-        <p:nvSpPr>
-          <p:cNvPr id="13" name="Rectangle 12">
-            <a:extLst>
-              <a:ext uri="{FF2B5EF4-FFF2-40B4-BE49-F238E27FC236}">
-                <a16:creationId xmlns:a16="http://schemas.microsoft.com/office/drawing/2014/main" id="{14E5BBD9-5DDE-1870-CC3D-B30780B82737}"/>
-              </a:ext>
-            </a:extLst>
-          </p:cNvPr>
-          <p:cNvSpPr/>
-          <p:nvPr/>
-        </p:nvSpPr>
-        <p:spPr>
-          <a:xfrm>
-            <a:off x="8703734" y="0"/>
-            <a:ext cx="3488266" cy="4549674"/>
-          </a:xfrm>
-          <a:prstGeom prst="rect">
-            <a:avLst/>
-          </a:prstGeom>
-          <a:solidFill>
-            <a:srgbClr val="000000"/>
-          </a:solidFill>
-        </p:spPr>
-        <p:style>
-          <a:lnRef idx="2">
-            <a:schemeClr val="dk1">
-              <a:shade val="15000"/>
-            </a:schemeClr>
-          </a:lnRef>
-          <a:fillRef idx="1">
-            <a:schemeClr val="dk1"/>
-          </a:fillRef>
-          <a:effectRef idx="0">
-            <a:schemeClr val="dk1"/>
-          </a:effectRef>
-          <a:fontRef idx="minor">
-            <a:schemeClr val="lt1"/>
-          </a:fontRef>
-        </p:style>
-        <p:txBody>
-          <a:bodyPr rtlCol="0" anchor="ctr"/>
-          <a:lstStyle/>
-          <a:p>
-            <a:pPr algn="ctr"/>
-            <a:endParaRPr lang="en-GB"/>
-          </a:p>
-        </p:txBody>
-      </p:sp>
-      <p:sp>
-        <p:nvSpPr>
-          <p:cNvPr id="14" name="TextBox 13">
-            <a:extLst>
-              <a:ext uri="{FF2B5EF4-FFF2-40B4-BE49-F238E27FC236}">
-                <a16:creationId xmlns:a16="http://schemas.microsoft.com/office/drawing/2014/main" id="{8F2DF85C-9C61-0239-6B97-C4077AFFDAB8}"/>
-              </a:ext>
-            </a:extLst>
-          </p:cNvPr>
-          <p:cNvSpPr txBox="1"/>
-          <p:nvPr/>
-        </p:nvSpPr>
-        <p:spPr>
-          <a:xfrm>
-            <a:off x="8703702" y="-2"/>
-            <a:ext cx="3488266" cy="461665"/>
-          </a:xfrm>
-          <a:prstGeom prst="rect">
-            <a:avLst/>
-          </a:prstGeom>
-          <a:noFill/>
-        </p:spPr>
-        <p:txBody>
-          <a:bodyPr wrap="square" rtlCol="0">
-            <a:spAutoFit/>
-          </a:bodyPr>
-          <a:lstStyle/>
           <a:p>
             <a:pPr algn="ctr"/>
             <a:r>
-              <a:rPr lang="en-GB" sz="2400" dirty="0"/>
-              <a:t>Different kinds of bait</a:t>
-            </a:r>
-          </a:p>
-        </p:txBody>
-      </p:sp>
-      <p:pic>
-        <p:nvPicPr>
-          <p:cNvPr id="21" name="Picture 20">
-            <a:extLst>
-              <a:ext uri="{FF2B5EF4-FFF2-40B4-BE49-F238E27FC236}">
-                <a16:creationId xmlns:a16="http://schemas.microsoft.com/office/drawing/2014/main" id="{28E494BB-99B3-D7D3-211B-7CFC5980777D}"/>
-              </a:ext>
-            </a:extLst>
-          </p:cNvPr>
-          <p:cNvPicPr>
-            <a:picLocks noChangeAspect="1"/>
-          </p:cNvPicPr>
-          <p:nvPr/>
-        </p:nvPicPr>
-        <p:blipFill>
-          <a:blip r:embed="rId7"/>
-          <a:stretch>
-            <a:fillRect/>
-          </a:stretch>
-        </p:blipFill>
-        <p:spPr>
-          <a:xfrm>
-            <a:off x="8866480" y="762350"/>
-            <a:ext cx="3162741" cy="3486637"/>
-          </a:xfrm>
-          <a:prstGeom prst="rect">
-            <a:avLst/>
-          </a:prstGeom>
-        </p:spPr>
-      </p:pic>
-      <p:sp>
-        <p:nvSpPr>
-          <p:cNvPr id="22" name="TextBox 21">
-            <a:extLst>
-              <a:ext uri="{FF2B5EF4-FFF2-40B4-BE49-F238E27FC236}">
-                <a16:creationId xmlns:a16="http://schemas.microsoft.com/office/drawing/2014/main" id="{39B6A7C5-074E-6116-0E1E-52F8550D9050}"/>
-              </a:ext>
-            </a:extLst>
-          </p:cNvPr>
-          <p:cNvSpPr txBox="1"/>
-          <p:nvPr/>
-        </p:nvSpPr>
-        <p:spPr>
-          <a:xfrm>
-            <a:off x="8920209" y="2167114"/>
-            <a:ext cx="1299057" cy="338554"/>
-          </a:xfrm>
-          <a:prstGeom prst="rect">
-            <a:avLst/>
-          </a:prstGeom>
-          <a:noFill/>
-        </p:spPr>
-        <p:txBody>
-          <a:bodyPr wrap="square" rtlCol="0">
-            <a:spAutoFit/>
-          </a:bodyPr>
-          <a:lstStyle/>
-          <a:p>
-            <a:pPr algn="ctr"/>
-            <a:r>
-              <a:rPr lang="en-GB" sz="1600" dirty="0"/>
-              <a:t>Default bait</a:t>
-            </a:r>
-          </a:p>
-        </p:txBody>
-      </p:sp>
-      <p:sp>
-        <p:nvSpPr>
-          <p:cNvPr id="23" name="TextBox 22">
-            <a:extLst>
-              <a:ext uri="{FF2B5EF4-FFF2-40B4-BE49-F238E27FC236}">
-                <a16:creationId xmlns:a16="http://schemas.microsoft.com/office/drawing/2014/main" id="{42D82602-1677-9075-0404-F7ECB155D6C1}"/>
-              </a:ext>
-            </a:extLst>
-          </p:cNvPr>
-          <p:cNvSpPr txBox="1"/>
-          <p:nvPr/>
-        </p:nvSpPr>
-        <p:spPr>
-          <a:xfrm>
-            <a:off x="10647409" y="2167114"/>
-            <a:ext cx="1299057" cy="338554"/>
-          </a:xfrm>
-          <a:prstGeom prst="rect">
-            <a:avLst/>
-          </a:prstGeom>
-          <a:noFill/>
-        </p:spPr>
-        <p:txBody>
-          <a:bodyPr wrap="square" rtlCol="0">
-            <a:spAutoFit/>
-          </a:bodyPr>
-          <a:lstStyle/>
-          <a:p>
-            <a:pPr algn="ctr"/>
-            <a:r>
-              <a:rPr lang="en-GB" sz="1600" dirty="0"/>
-              <a:t>Worm</a:t>
-            </a:r>
-          </a:p>
-        </p:txBody>
-      </p:sp>
-      <p:sp>
-        <p:nvSpPr>
-          <p:cNvPr id="24" name="TextBox 23">
-            <a:extLst>
-              <a:ext uri="{FF2B5EF4-FFF2-40B4-BE49-F238E27FC236}">
-                <a16:creationId xmlns:a16="http://schemas.microsoft.com/office/drawing/2014/main" id="{C207B1EC-6810-020A-CC89-45AD39758470}"/>
-              </a:ext>
-            </a:extLst>
-          </p:cNvPr>
-          <p:cNvSpPr txBox="1"/>
-          <p:nvPr/>
-        </p:nvSpPr>
-        <p:spPr>
-          <a:xfrm>
-            <a:off x="8920208" y="3940227"/>
-            <a:ext cx="1299057" cy="261610"/>
-          </a:xfrm>
-          <a:prstGeom prst="rect">
-            <a:avLst/>
-          </a:prstGeom>
-          <a:noFill/>
-        </p:spPr>
-        <p:txBody>
-          <a:bodyPr wrap="square" rtlCol="0">
-            <a:spAutoFit/>
-          </a:bodyPr>
-          <a:lstStyle/>
-          <a:p>
-            <a:pPr algn="ctr"/>
-            <a:r>
-              <a:rPr lang="en-GB" sz="1100" dirty="0"/>
-              <a:t>Heavy ground bait</a:t>
-            </a:r>
-          </a:p>
-        </p:txBody>
-      </p:sp>
-      <p:sp>
-        <p:nvSpPr>
-          <p:cNvPr id="25" name="TextBox 24">
-            <a:extLst>
-              <a:ext uri="{FF2B5EF4-FFF2-40B4-BE49-F238E27FC236}">
-                <a16:creationId xmlns:a16="http://schemas.microsoft.com/office/drawing/2014/main" id="{48FE812A-8DF6-BA91-9302-E6ACBD61DB05}"/>
-              </a:ext>
-            </a:extLst>
-          </p:cNvPr>
-          <p:cNvSpPr txBox="1"/>
-          <p:nvPr/>
-        </p:nvSpPr>
-        <p:spPr>
-          <a:xfrm>
-            <a:off x="10647409" y="3940227"/>
-            <a:ext cx="1299057" cy="261610"/>
-          </a:xfrm>
-          <a:prstGeom prst="rect">
-            <a:avLst/>
-          </a:prstGeom>
-          <a:noFill/>
-        </p:spPr>
-        <p:txBody>
-          <a:bodyPr wrap="square" rtlCol="0">
-            <a:spAutoFit/>
-          </a:bodyPr>
-          <a:lstStyle/>
-          <a:p>
-            <a:pPr algn="ctr"/>
-            <a:r>
-              <a:rPr lang="en-GB" sz="1100" dirty="0"/>
-              <a:t>Hook bait</a:t>
+              <a:rPr lang="en-GB" sz="1200" dirty="0"/>
+              <a:t>Hook, Line and Slinger is a 2d platformer where you play as a sushi chef turned fisherman on the search for the rarest and most delicious fish in the land. Swing through the level with your trusty fishing rod and throw bait at your enemies to catch them and have them for dinner. Master your fishing technique before being tested by challenging boss enemies/delicacies.</a:t>
             </a:r>
           </a:p>
         </p:txBody>

</xml_diff>

<commit_message>
Started report and completed new poster version and improved feedback for main menu buttons.
</commit_message>
<xml_diff>
--- a/Poster.pptx
+++ b/Poster.pptx
@@ -4,17 +4,20 @@
   <p:sldMasterIdLst>
     <p:sldMasterId id="2147483751" r:id="rId1"/>
   </p:sldMasterIdLst>
+  <p:notesMasterIdLst>
+    <p:notesMasterId r:id="rId3"/>
+  </p:notesMasterIdLst>
   <p:sldIdLst>
     <p:sldId id="256" r:id="rId2"/>
   </p:sldIdLst>
-  <p:sldSz cx="12192000" cy="6858000"/>
+  <p:sldSz cx="12801600" cy="9601200" type="A3"/>
   <p:notesSz cx="6858000" cy="9144000"/>
   <p:defaultTextStyle>
     <a:defPPr>
       <a:defRPr lang="en-US"/>
     </a:defPPr>
-    <a:lvl1pPr marL="0" algn="l" defTabSz="914400" rtl="0" eaLnBrk="1" latinLnBrk="0" hangingPunct="1">
-      <a:defRPr sz="1800" kern="1200">
+    <a:lvl1pPr marL="0" algn="l" defTabSz="1075334" rtl="0" eaLnBrk="1" latinLnBrk="0" hangingPunct="1">
+      <a:defRPr sz="2117" kern="1200">
         <a:solidFill>
           <a:schemeClr val="tx1"/>
         </a:solidFill>
@@ -23,8 +26,8 @@
         <a:cs typeface="+mn-cs"/>
       </a:defRPr>
     </a:lvl1pPr>
-    <a:lvl2pPr marL="457200" algn="l" defTabSz="914400" rtl="0" eaLnBrk="1" latinLnBrk="0" hangingPunct="1">
-      <a:defRPr sz="1800" kern="1200">
+    <a:lvl2pPr marL="537667" algn="l" defTabSz="1075334" rtl="0" eaLnBrk="1" latinLnBrk="0" hangingPunct="1">
+      <a:defRPr sz="2117" kern="1200">
         <a:solidFill>
           <a:schemeClr val="tx1"/>
         </a:solidFill>
@@ -33,8 +36,8 @@
         <a:cs typeface="+mn-cs"/>
       </a:defRPr>
     </a:lvl2pPr>
-    <a:lvl3pPr marL="914400" algn="l" defTabSz="914400" rtl="0" eaLnBrk="1" latinLnBrk="0" hangingPunct="1">
-      <a:defRPr sz="1800" kern="1200">
+    <a:lvl3pPr marL="1075334" algn="l" defTabSz="1075334" rtl="0" eaLnBrk="1" latinLnBrk="0" hangingPunct="1">
+      <a:defRPr sz="2117" kern="1200">
         <a:solidFill>
           <a:schemeClr val="tx1"/>
         </a:solidFill>
@@ -43,8 +46,8 @@
         <a:cs typeface="+mn-cs"/>
       </a:defRPr>
     </a:lvl3pPr>
-    <a:lvl4pPr marL="1371600" algn="l" defTabSz="914400" rtl="0" eaLnBrk="1" latinLnBrk="0" hangingPunct="1">
-      <a:defRPr sz="1800" kern="1200">
+    <a:lvl4pPr marL="1613002" algn="l" defTabSz="1075334" rtl="0" eaLnBrk="1" latinLnBrk="0" hangingPunct="1">
+      <a:defRPr sz="2117" kern="1200">
         <a:solidFill>
           <a:schemeClr val="tx1"/>
         </a:solidFill>
@@ -53,8 +56,8 @@
         <a:cs typeface="+mn-cs"/>
       </a:defRPr>
     </a:lvl4pPr>
-    <a:lvl5pPr marL="1828800" algn="l" defTabSz="914400" rtl="0" eaLnBrk="1" latinLnBrk="0" hangingPunct="1">
-      <a:defRPr sz="1800" kern="1200">
+    <a:lvl5pPr marL="2150669" algn="l" defTabSz="1075334" rtl="0" eaLnBrk="1" latinLnBrk="0" hangingPunct="1">
+      <a:defRPr sz="2117" kern="1200">
         <a:solidFill>
           <a:schemeClr val="tx1"/>
         </a:solidFill>
@@ -63,8 +66,8 @@
         <a:cs typeface="+mn-cs"/>
       </a:defRPr>
     </a:lvl5pPr>
-    <a:lvl6pPr marL="2286000" algn="l" defTabSz="914400" rtl="0" eaLnBrk="1" latinLnBrk="0" hangingPunct="1">
-      <a:defRPr sz="1800" kern="1200">
+    <a:lvl6pPr marL="2688336" algn="l" defTabSz="1075334" rtl="0" eaLnBrk="1" latinLnBrk="0" hangingPunct="1">
+      <a:defRPr sz="2117" kern="1200">
         <a:solidFill>
           <a:schemeClr val="tx1"/>
         </a:solidFill>
@@ -73,8 +76,8 @@
         <a:cs typeface="+mn-cs"/>
       </a:defRPr>
     </a:lvl6pPr>
-    <a:lvl7pPr marL="2743200" algn="l" defTabSz="914400" rtl="0" eaLnBrk="1" latinLnBrk="0" hangingPunct="1">
-      <a:defRPr sz="1800" kern="1200">
+    <a:lvl7pPr marL="3226003" algn="l" defTabSz="1075334" rtl="0" eaLnBrk="1" latinLnBrk="0" hangingPunct="1">
+      <a:defRPr sz="2117" kern="1200">
         <a:solidFill>
           <a:schemeClr val="tx1"/>
         </a:solidFill>
@@ -83,8 +86,8 @@
         <a:cs typeface="+mn-cs"/>
       </a:defRPr>
     </a:lvl7pPr>
-    <a:lvl8pPr marL="3200400" algn="l" defTabSz="914400" rtl="0" eaLnBrk="1" latinLnBrk="0" hangingPunct="1">
-      <a:defRPr sz="1800" kern="1200">
+    <a:lvl8pPr marL="3763670" algn="l" defTabSz="1075334" rtl="0" eaLnBrk="1" latinLnBrk="0" hangingPunct="1">
+      <a:defRPr sz="2117" kern="1200">
         <a:solidFill>
           <a:schemeClr val="tx1"/>
         </a:solidFill>
@@ -93,8 +96,8 @@
         <a:cs typeface="+mn-cs"/>
       </a:defRPr>
     </a:lvl8pPr>
-    <a:lvl9pPr marL="3657600" algn="l" defTabSz="914400" rtl="0" eaLnBrk="1" latinLnBrk="0" hangingPunct="1">
-      <a:defRPr sz="1800" kern="1200">
+    <a:lvl9pPr marL="4301338" algn="l" defTabSz="1075334" rtl="0" eaLnBrk="1" latinLnBrk="0" hangingPunct="1">
+      <a:defRPr sz="2117" kern="1200">
         <a:solidFill>
           <a:schemeClr val="tx1"/>
         </a:solidFill>
@@ -110,6 +113,445 @@
     </p:ext>
   </p:extLst>
 </p:presentation>
+</file>
+
+<file path=ppt/notesMasters/notesMaster1.xml><?xml version="1.0" encoding="utf-8"?>
+<p:notesMaster xmlns:a="http://schemas.openxmlformats.org/drawingml/2006/main" xmlns:r="http://schemas.openxmlformats.org/officeDocument/2006/relationships" xmlns:p="http://schemas.openxmlformats.org/presentationml/2006/main">
+  <p:cSld>
+    <p:bg>
+      <p:bgRef idx="1001">
+        <a:schemeClr val="bg1"/>
+      </p:bgRef>
+    </p:bg>
+    <p:spTree>
+      <p:nvGrpSpPr>
+        <p:cNvPr id="1" name=""/>
+        <p:cNvGrpSpPr/>
+        <p:nvPr/>
+      </p:nvGrpSpPr>
+      <p:grpSpPr>
+        <a:xfrm>
+          <a:off x="0" y="0"/>
+          <a:ext cx="0" cy="0"/>
+          <a:chOff x="0" y="0"/>
+          <a:chExt cx="0" cy="0"/>
+        </a:xfrm>
+      </p:grpSpPr>
+      <p:sp>
+        <p:nvSpPr>
+          <p:cNvPr id="2" name="Header Placeholder 1"/>
+          <p:cNvSpPr>
+            <a:spLocks noGrp="1"/>
+          </p:cNvSpPr>
+          <p:nvPr>
+            <p:ph type="hdr" sz="quarter"/>
+          </p:nvPr>
+        </p:nvSpPr>
+        <p:spPr>
+          <a:xfrm>
+            <a:off x="0" y="0"/>
+            <a:ext cx="2971800" cy="458788"/>
+          </a:xfrm>
+          <a:prstGeom prst="rect">
+            <a:avLst/>
+          </a:prstGeom>
+        </p:spPr>
+        <p:txBody>
+          <a:bodyPr vert="horz" lIns="91440" tIns="45720" rIns="91440" bIns="45720" rtlCol="0"/>
+          <a:lstStyle>
+            <a:lvl1pPr algn="l">
+              <a:defRPr sz="1200"/>
+            </a:lvl1pPr>
+          </a:lstStyle>
+          <a:p>
+            <a:endParaRPr lang="en-GB"/>
+          </a:p>
+        </p:txBody>
+      </p:sp>
+      <p:sp>
+        <p:nvSpPr>
+          <p:cNvPr id="3" name="Date Placeholder 2"/>
+          <p:cNvSpPr>
+            <a:spLocks noGrp="1"/>
+          </p:cNvSpPr>
+          <p:nvPr>
+            <p:ph type="dt" idx="1"/>
+          </p:nvPr>
+        </p:nvSpPr>
+        <p:spPr>
+          <a:xfrm>
+            <a:off x="3884613" y="0"/>
+            <a:ext cx="2971800" cy="458788"/>
+          </a:xfrm>
+          <a:prstGeom prst="rect">
+            <a:avLst/>
+          </a:prstGeom>
+        </p:spPr>
+        <p:txBody>
+          <a:bodyPr vert="horz" lIns="91440" tIns="45720" rIns="91440" bIns="45720" rtlCol="0"/>
+          <a:lstStyle>
+            <a:lvl1pPr algn="r">
+              <a:defRPr sz="1200"/>
+            </a:lvl1pPr>
+          </a:lstStyle>
+          <a:p>
+            <a:fld id="{F4CF48D3-D0BF-45C1-ADCB-12E0ED15E779}" type="datetimeFigureOut">
+              <a:rPr lang="en-GB" smtClean="0"/>
+              <a:t>13/04/2026</a:t>
+            </a:fld>
+            <a:endParaRPr lang="en-GB"/>
+          </a:p>
+        </p:txBody>
+      </p:sp>
+      <p:sp>
+        <p:nvSpPr>
+          <p:cNvPr id="4" name="Slide Image Placeholder 3"/>
+          <p:cNvSpPr>
+            <a:spLocks noGrp="1" noRot="1" noChangeAspect="1"/>
+          </p:cNvSpPr>
+          <p:nvPr>
+            <p:ph type="sldImg" idx="2"/>
+          </p:nvPr>
+        </p:nvSpPr>
+        <p:spPr>
+          <a:xfrm>
+            <a:off x="1371600" y="1143000"/>
+            <a:ext cx="4114800" cy="3086100"/>
+          </a:xfrm>
+          <a:prstGeom prst="rect">
+            <a:avLst/>
+          </a:prstGeom>
+          <a:noFill/>
+          <a:ln w="12700">
+            <a:solidFill>
+              <a:prstClr val="black"/>
+            </a:solidFill>
+          </a:ln>
+        </p:spPr>
+        <p:txBody>
+          <a:bodyPr vert="horz" lIns="91440" tIns="45720" rIns="91440" bIns="45720" rtlCol="0" anchor="ctr"/>
+          <a:lstStyle/>
+          <a:p>
+            <a:endParaRPr lang="en-GB"/>
+          </a:p>
+        </p:txBody>
+      </p:sp>
+      <p:sp>
+        <p:nvSpPr>
+          <p:cNvPr id="5" name="Notes Placeholder 4"/>
+          <p:cNvSpPr>
+            <a:spLocks noGrp="1"/>
+          </p:cNvSpPr>
+          <p:nvPr>
+            <p:ph type="body" sz="quarter" idx="3"/>
+          </p:nvPr>
+        </p:nvSpPr>
+        <p:spPr>
+          <a:xfrm>
+            <a:off x="685800" y="4400550"/>
+            <a:ext cx="5486400" cy="3600450"/>
+          </a:xfrm>
+          <a:prstGeom prst="rect">
+            <a:avLst/>
+          </a:prstGeom>
+        </p:spPr>
+        <p:txBody>
+          <a:bodyPr vert="horz" lIns="91440" tIns="45720" rIns="91440" bIns="45720" rtlCol="0"/>
+          <a:lstStyle/>
+          <a:p>
+            <a:pPr lvl="0"/>
+            <a:r>
+              <a:rPr lang="en-US"/>
+              <a:t>Click to edit Master text styles</a:t>
+            </a:r>
+          </a:p>
+          <a:p>
+            <a:pPr lvl="1"/>
+            <a:r>
+              <a:rPr lang="en-US"/>
+              <a:t>Second level</a:t>
+            </a:r>
+          </a:p>
+          <a:p>
+            <a:pPr lvl="2"/>
+            <a:r>
+              <a:rPr lang="en-US"/>
+              <a:t>Third level</a:t>
+            </a:r>
+          </a:p>
+          <a:p>
+            <a:pPr lvl="3"/>
+            <a:r>
+              <a:rPr lang="en-US"/>
+              <a:t>Fourth level</a:t>
+            </a:r>
+          </a:p>
+          <a:p>
+            <a:pPr lvl="4"/>
+            <a:r>
+              <a:rPr lang="en-US"/>
+              <a:t>Fifth level</a:t>
+            </a:r>
+            <a:endParaRPr lang="en-GB"/>
+          </a:p>
+        </p:txBody>
+      </p:sp>
+      <p:sp>
+        <p:nvSpPr>
+          <p:cNvPr id="6" name="Footer Placeholder 5"/>
+          <p:cNvSpPr>
+            <a:spLocks noGrp="1"/>
+          </p:cNvSpPr>
+          <p:nvPr>
+            <p:ph type="ftr" sz="quarter" idx="4"/>
+          </p:nvPr>
+        </p:nvSpPr>
+        <p:spPr>
+          <a:xfrm>
+            <a:off x="0" y="8685213"/>
+            <a:ext cx="2971800" cy="458787"/>
+          </a:xfrm>
+          <a:prstGeom prst="rect">
+            <a:avLst/>
+          </a:prstGeom>
+        </p:spPr>
+        <p:txBody>
+          <a:bodyPr vert="horz" lIns="91440" tIns="45720" rIns="91440" bIns="45720" rtlCol="0" anchor="b"/>
+          <a:lstStyle>
+            <a:lvl1pPr algn="l">
+              <a:defRPr sz="1200"/>
+            </a:lvl1pPr>
+          </a:lstStyle>
+          <a:p>
+            <a:endParaRPr lang="en-GB"/>
+          </a:p>
+        </p:txBody>
+      </p:sp>
+      <p:sp>
+        <p:nvSpPr>
+          <p:cNvPr id="7" name="Slide Number Placeholder 6"/>
+          <p:cNvSpPr>
+            <a:spLocks noGrp="1"/>
+          </p:cNvSpPr>
+          <p:nvPr>
+            <p:ph type="sldNum" sz="quarter" idx="5"/>
+          </p:nvPr>
+        </p:nvSpPr>
+        <p:spPr>
+          <a:xfrm>
+            <a:off x="3884613" y="8685213"/>
+            <a:ext cx="2971800" cy="458787"/>
+          </a:xfrm>
+          <a:prstGeom prst="rect">
+            <a:avLst/>
+          </a:prstGeom>
+        </p:spPr>
+        <p:txBody>
+          <a:bodyPr vert="horz" lIns="91440" tIns="45720" rIns="91440" bIns="45720" rtlCol="0" anchor="b"/>
+          <a:lstStyle>
+            <a:lvl1pPr algn="r">
+              <a:defRPr sz="1200"/>
+            </a:lvl1pPr>
+          </a:lstStyle>
+          <a:p>
+            <a:fld id="{A9B1DD64-501C-40A6-8171-26AB7ADC5B7E}" type="slidenum">
+              <a:rPr lang="en-GB" smtClean="0"/>
+              <a:t>‹#›</a:t>
+            </a:fld>
+            <a:endParaRPr lang="en-GB"/>
+          </a:p>
+        </p:txBody>
+      </p:sp>
+    </p:spTree>
+    <p:extLst>
+      <p:ext uri="{BB962C8B-B14F-4D97-AF65-F5344CB8AC3E}">
+        <p14:creationId xmlns:p14="http://schemas.microsoft.com/office/powerpoint/2010/main" val="1057489723"/>
+      </p:ext>
+    </p:extLst>
+  </p:cSld>
+  <p:clrMap bg1="lt1" tx1="dk1" bg2="lt2" tx2="dk2" accent1="accent1" accent2="accent2" accent3="accent3" accent4="accent4" accent5="accent5" accent6="accent6" hlink="hlink" folHlink="folHlink"/>
+  <p:notesStyle>
+    <a:lvl1pPr marL="0" algn="l" defTabSz="1075334" rtl="0" eaLnBrk="1" latinLnBrk="0" hangingPunct="1">
+      <a:defRPr sz="1411" kern="1200">
+        <a:solidFill>
+          <a:schemeClr val="tx1"/>
+        </a:solidFill>
+        <a:latin typeface="+mn-lt"/>
+        <a:ea typeface="+mn-ea"/>
+        <a:cs typeface="+mn-cs"/>
+      </a:defRPr>
+    </a:lvl1pPr>
+    <a:lvl2pPr marL="537667" algn="l" defTabSz="1075334" rtl="0" eaLnBrk="1" latinLnBrk="0" hangingPunct="1">
+      <a:defRPr sz="1411" kern="1200">
+        <a:solidFill>
+          <a:schemeClr val="tx1"/>
+        </a:solidFill>
+        <a:latin typeface="+mn-lt"/>
+        <a:ea typeface="+mn-ea"/>
+        <a:cs typeface="+mn-cs"/>
+      </a:defRPr>
+    </a:lvl2pPr>
+    <a:lvl3pPr marL="1075334" algn="l" defTabSz="1075334" rtl="0" eaLnBrk="1" latinLnBrk="0" hangingPunct="1">
+      <a:defRPr sz="1411" kern="1200">
+        <a:solidFill>
+          <a:schemeClr val="tx1"/>
+        </a:solidFill>
+        <a:latin typeface="+mn-lt"/>
+        <a:ea typeface="+mn-ea"/>
+        <a:cs typeface="+mn-cs"/>
+      </a:defRPr>
+    </a:lvl3pPr>
+    <a:lvl4pPr marL="1613002" algn="l" defTabSz="1075334" rtl="0" eaLnBrk="1" latinLnBrk="0" hangingPunct="1">
+      <a:defRPr sz="1411" kern="1200">
+        <a:solidFill>
+          <a:schemeClr val="tx1"/>
+        </a:solidFill>
+        <a:latin typeface="+mn-lt"/>
+        <a:ea typeface="+mn-ea"/>
+        <a:cs typeface="+mn-cs"/>
+      </a:defRPr>
+    </a:lvl4pPr>
+    <a:lvl5pPr marL="2150669" algn="l" defTabSz="1075334" rtl="0" eaLnBrk="1" latinLnBrk="0" hangingPunct="1">
+      <a:defRPr sz="1411" kern="1200">
+        <a:solidFill>
+          <a:schemeClr val="tx1"/>
+        </a:solidFill>
+        <a:latin typeface="+mn-lt"/>
+        <a:ea typeface="+mn-ea"/>
+        <a:cs typeface="+mn-cs"/>
+      </a:defRPr>
+    </a:lvl5pPr>
+    <a:lvl6pPr marL="2688336" algn="l" defTabSz="1075334" rtl="0" eaLnBrk="1" latinLnBrk="0" hangingPunct="1">
+      <a:defRPr sz="1411" kern="1200">
+        <a:solidFill>
+          <a:schemeClr val="tx1"/>
+        </a:solidFill>
+        <a:latin typeface="+mn-lt"/>
+        <a:ea typeface="+mn-ea"/>
+        <a:cs typeface="+mn-cs"/>
+      </a:defRPr>
+    </a:lvl6pPr>
+    <a:lvl7pPr marL="3226003" algn="l" defTabSz="1075334" rtl="0" eaLnBrk="1" latinLnBrk="0" hangingPunct="1">
+      <a:defRPr sz="1411" kern="1200">
+        <a:solidFill>
+          <a:schemeClr val="tx1"/>
+        </a:solidFill>
+        <a:latin typeface="+mn-lt"/>
+        <a:ea typeface="+mn-ea"/>
+        <a:cs typeface="+mn-cs"/>
+      </a:defRPr>
+    </a:lvl7pPr>
+    <a:lvl8pPr marL="3763670" algn="l" defTabSz="1075334" rtl="0" eaLnBrk="1" latinLnBrk="0" hangingPunct="1">
+      <a:defRPr sz="1411" kern="1200">
+        <a:solidFill>
+          <a:schemeClr val="tx1"/>
+        </a:solidFill>
+        <a:latin typeface="+mn-lt"/>
+        <a:ea typeface="+mn-ea"/>
+        <a:cs typeface="+mn-cs"/>
+      </a:defRPr>
+    </a:lvl8pPr>
+    <a:lvl9pPr marL="4301338" algn="l" defTabSz="1075334" rtl="0" eaLnBrk="1" latinLnBrk="0" hangingPunct="1">
+      <a:defRPr sz="1411" kern="1200">
+        <a:solidFill>
+          <a:schemeClr val="tx1"/>
+        </a:solidFill>
+        <a:latin typeface="+mn-lt"/>
+        <a:ea typeface="+mn-ea"/>
+        <a:cs typeface="+mn-cs"/>
+      </a:defRPr>
+    </a:lvl9pPr>
+  </p:notesStyle>
+</p:notesMaster>
+</file>
+
+<file path=ppt/notesSlides/notesSlide1.xml><?xml version="1.0" encoding="utf-8"?>
+<p:notes xmlns:a="http://schemas.openxmlformats.org/drawingml/2006/main" xmlns:r="http://schemas.openxmlformats.org/officeDocument/2006/relationships" xmlns:p="http://schemas.openxmlformats.org/presentationml/2006/main">
+  <p:cSld>
+    <p:spTree>
+      <p:nvGrpSpPr>
+        <p:cNvPr id="1" name=""/>
+        <p:cNvGrpSpPr/>
+        <p:nvPr/>
+      </p:nvGrpSpPr>
+      <p:grpSpPr>
+        <a:xfrm>
+          <a:off x="0" y="0"/>
+          <a:ext cx="0" cy="0"/>
+          <a:chOff x="0" y="0"/>
+          <a:chExt cx="0" cy="0"/>
+        </a:xfrm>
+      </p:grpSpPr>
+      <p:sp>
+        <p:nvSpPr>
+          <p:cNvPr id="2" name="Slide Image Placeholder 1"/>
+          <p:cNvSpPr>
+            <a:spLocks noGrp="1" noRot="1" noChangeAspect="1"/>
+          </p:cNvSpPr>
+          <p:nvPr>
+            <p:ph type="sldImg"/>
+          </p:nvPr>
+        </p:nvSpPr>
+        <p:spPr>
+          <a:xfrm>
+            <a:off x="1371600" y="1143000"/>
+            <a:ext cx="4114800" cy="3086100"/>
+          </a:xfrm>
+        </p:spPr>
+      </p:sp>
+      <p:sp>
+        <p:nvSpPr>
+          <p:cNvPr id="3" name="Notes Placeholder 2"/>
+          <p:cNvSpPr>
+            <a:spLocks noGrp="1"/>
+          </p:cNvSpPr>
+          <p:nvPr>
+            <p:ph type="body" idx="1"/>
+          </p:nvPr>
+        </p:nvSpPr>
+        <p:spPr/>
+        <p:txBody>
+          <a:bodyPr/>
+          <a:lstStyle/>
+          <a:p>
+            <a:endParaRPr lang="en-GB" dirty="0"/>
+          </a:p>
+        </p:txBody>
+      </p:sp>
+      <p:sp>
+        <p:nvSpPr>
+          <p:cNvPr id="4" name="Slide Number Placeholder 3"/>
+          <p:cNvSpPr>
+            <a:spLocks noGrp="1"/>
+          </p:cNvSpPr>
+          <p:nvPr>
+            <p:ph type="sldNum" sz="quarter" idx="5"/>
+          </p:nvPr>
+        </p:nvSpPr>
+        <p:spPr/>
+        <p:txBody>
+          <a:bodyPr/>
+          <a:lstStyle/>
+          <a:p>
+            <a:fld id="{A9B1DD64-501C-40A6-8171-26AB7ADC5B7E}" type="slidenum">
+              <a:rPr lang="en-GB" smtClean="0"/>
+              <a:t>1</a:t>
+            </a:fld>
+            <a:endParaRPr lang="en-GB"/>
+          </a:p>
+        </p:txBody>
+      </p:sp>
+    </p:spTree>
+    <p:extLst>
+      <p:ext uri="{BB962C8B-B14F-4D97-AF65-F5344CB8AC3E}">
+        <p14:creationId xmlns:p14="http://schemas.microsoft.com/office/powerpoint/2010/main" val="3682107140"/>
+      </p:ext>
+    </p:extLst>
+  </p:cSld>
+  <p:clrMapOvr>
+    <a:masterClrMapping/>
+  </p:clrMapOvr>
+</p:notes>
 </file>
 
 <file path=ppt/slideLayouts/slideLayout1.xml><?xml version="1.0" encoding="utf-8"?>
@@ -147,8 +589,8 @@
         </p:nvSpPr>
         <p:spPr>
           <a:xfrm>
-            <a:off x="3359149" y="389840"/>
-            <a:ext cx="8281987" cy="2954655"/>
+            <a:off x="3527107" y="545777"/>
+            <a:ext cx="8696086" cy="4136517"/>
           </a:xfrm>
         </p:spPr>
         <p:txBody>
@@ -160,7 +602,7 @@
               <a:lnSpc>
                 <a:spcPct val="100000"/>
               </a:lnSpc>
-              <a:defRPr sz="6400"/>
+              <a:defRPr sz="6720"/>
             </a:lvl1pPr>
           </a:lstStyle>
           <a:p>
@@ -190,8 +632,8 @@
         </p:nvSpPr>
         <p:spPr>
           <a:xfrm>
-            <a:off x="3359149" y="3536951"/>
-            <a:ext cx="8281989" cy="2555874"/>
+            <a:off x="3527107" y="4951731"/>
+            <a:ext cx="8696088" cy="3578224"/>
           </a:xfrm>
         </p:spPr>
         <p:txBody>
@@ -204,7 +646,7 @@
                 <a:spcPct val="100000"/>
               </a:lnSpc>
               <a:buNone/>
-              <a:defRPr sz="2400">
+              <a:defRPr sz="2520">
                 <a:solidFill>
                   <a:schemeClr val="tx1">
                     <a:alpha val="80000"/>
@@ -212,37 +654,37 @@
                 </a:solidFill>
               </a:defRPr>
             </a:lvl1pPr>
-            <a:lvl2pPr marL="457200" indent="0" algn="ctr">
+            <a:lvl2pPr marL="480060" indent="0" algn="ctr">
               <a:buNone/>
-              <a:defRPr sz="2000"/>
+              <a:defRPr sz="2100"/>
             </a:lvl2pPr>
-            <a:lvl3pPr marL="914400" indent="0" algn="ctr">
+            <a:lvl3pPr marL="960120" indent="0" algn="ctr">
               <a:buNone/>
-              <a:defRPr sz="1800"/>
+              <a:defRPr sz="1890"/>
             </a:lvl3pPr>
-            <a:lvl4pPr marL="1371600" indent="0" algn="ctr">
+            <a:lvl4pPr marL="1440180" indent="0" algn="ctr">
               <a:buNone/>
-              <a:defRPr sz="1600"/>
+              <a:defRPr sz="1680"/>
             </a:lvl4pPr>
-            <a:lvl5pPr marL="1828800" indent="0" algn="ctr">
+            <a:lvl5pPr marL="1920240" indent="0" algn="ctr">
               <a:buNone/>
-              <a:defRPr sz="1600"/>
+              <a:defRPr sz="1680"/>
             </a:lvl5pPr>
-            <a:lvl6pPr marL="2286000" indent="0" algn="ctr">
+            <a:lvl6pPr marL="2400300" indent="0" algn="ctr">
               <a:buNone/>
-              <a:defRPr sz="1600"/>
+              <a:defRPr sz="1680"/>
             </a:lvl6pPr>
-            <a:lvl7pPr marL="2743200" indent="0" algn="ctr">
+            <a:lvl7pPr marL="2880360" indent="0" algn="ctr">
               <a:buNone/>
-              <a:defRPr sz="1600"/>
+              <a:defRPr sz="1680"/>
             </a:lvl7pPr>
-            <a:lvl8pPr marL="3200400" indent="0" algn="ctr">
+            <a:lvl8pPr marL="3360420" indent="0" algn="ctr">
               <a:buNone/>
-              <a:defRPr sz="1600"/>
+              <a:defRPr sz="1680"/>
             </a:lvl8pPr>
-            <a:lvl9pPr marL="3657600" indent="0" algn="ctr">
+            <a:lvl9pPr marL="3840480" indent="0" algn="ctr">
               <a:buNone/>
-              <a:defRPr sz="1600"/>
+              <a:defRPr sz="1680"/>
             </a:lvl9pPr>
           </a:lstStyle>
           <a:p>
@@ -277,7 +719,7 @@
           <a:p>
             <a:fld id="{72EA7947-E287-4738-8C82-07CE4F01EF03}" type="datetime2">
               <a:rPr lang="en-US" smtClean="0"/>
-              <a:t>Monday, March 30, 2026</a:t>
+              <a:t>Monday, April 13, 2026</a:t>
             </a:fld>
             <a:endParaRPr lang="en-US" dirty="0"/>
           </a:p>
@@ -356,8 +798,8 @@
         </p:nvSpPr>
         <p:spPr>
           <a:xfrm rot="2700000">
-            <a:off x="612445" y="481888"/>
-            <a:ext cx="1080000" cy="1262947"/>
+            <a:off x="454067" y="895660"/>
+            <a:ext cx="1512000" cy="1326094"/>
           </a:xfrm>
           <a:custGeom>
             <a:avLst/>
@@ -549,7 +991,7 @@
           </a:fontRef>
         </p:style>
         <p:txBody>
-          <a:bodyPr rot="0" spcFirstLastPara="0" vertOverflow="overflow" horzOverflow="overflow" vert="horz" wrap="square" lIns="91440" tIns="45720" rIns="91440" bIns="45720" numCol="1" spcCol="0" rtlCol="0" fromWordArt="0" anchor="ctr" anchorCtr="0" forceAA="0" compatLnSpc="1">
+          <a:bodyPr rot="0" spcFirstLastPara="0" vertOverflow="overflow" horzOverflow="overflow" vert="horz" wrap="square" lIns="96012" tIns="48006" rIns="96012" bIns="48006" numCol="1" spcCol="0" rtlCol="0" fromWordArt="0" anchor="ctr" anchorCtr="0" forceAA="0" compatLnSpc="1">
             <a:prstTxWarp prst="textNoShape">
               <a:avLst/>
             </a:prstTxWarp>
@@ -558,7 +1000,7 @@
           <a:lstStyle/>
           <a:p>
             <a:pPr algn="ctr"/>
-            <a:endParaRPr lang="en-US"/>
+            <a:endParaRPr lang="en-US" sz="2223"/>
           </a:p>
         </p:txBody>
       </p:sp>
@@ -576,8 +1018,8 @@
         </p:nvSpPr>
         <p:spPr>
           <a:xfrm rot="8100000">
-            <a:off x="626845" y="828962"/>
-            <a:ext cx="540000" cy="1080000"/>
+            <a:off x="658187" y="1160547"/>
+            <a:ext cx="567000" cy="1512000"/>
           </a:xfrm>
           <a:prstGeom prst="ellipse">
             <a:avLst/>
@@ -629,7 +1071,7 @@
           </a:fontRef>
         </p:style>
         <p:txBody>
-          <a:bodyPr rot="0" spcFirstLastPara="0" vertOverflow="overflow" horzOverflow="overflow" vert="horz" wrap="square" lIns="91440" tIns="45720" rIns="91440" bIns="45720" numCol="1" spcCol="0" rtlCol="0" fromWordArt="0" anchor="ctr" anchorCtr="0" forceAA="0" compatLnSpc="1">
+          <a:bodyPr rot="0" spcFirstLastPara="0" vertOverflow="overflow" horzOverflow="overflow" vert="horz" wrap="square" lIns="96012" tIns="48006" rIns="96012" bIns="48006" numCol="1" spcCol="0" rtlCol="0" fromWordArt="0" anchor="ctr" anchorCtr="0" forceAA="0" compatLnSpc="1">
             <a:prstTxWarp prst="textNoShape">
               <a:avLst/>
             </a:prstTxWarp>
@@ -638,7 +1080,7 @@
           <a:lstStyle/>
           <a:p>
             <a:pPr algn="ctr"/>
-            <a:endParaRPr lang="en-US"/>
+            <a:endParaRPr lang="en-US" sz="2223"/>
           </a:p>
         </p:txBody>
       </p:sp>
@@ -658,8 +1100,8 @@
         </p:nvSpPr>
         <p:spPr>
           <a:xfrm>
-            <a:off x="1800802" y="2472855"/>
-            <a:ext cx="360000" cy="360000"/>
+            <a:off x="1890842" y="3461997"/>
+            <a:ext cx="378000" cy="504000"/>
           </a:xfrm>
           <a:prstGeom prst="ellipse">
             <a:avLst/>
@@ -712,7 +1154,7 @@
           </a:fontRef>
         </p:style>
         <p:txBody>
-          <a:bodyPr rot="0" spcFirstLastPara="0" vertOverflow="overflow" horzOverflow="overflow" vert="horz" wrap="square" lIns="91440" tIns="45720" rIns="91440" bIns="45720" numCol="1" spcCol="0" rtlCol="0" fromWordArt="0" anchor="ctr" anchorCtr="0" forceAA="0" compatLnSpc="1">
+          <a:bodyPr rot="0" spcFirstLastPara="0" vertOverflow="overflow" horzOverflow="overflow" vert="horz" wrap="square" lIns="96012" tIns="48006" rIns="96012" bIns="48006" numCol="1" spcCol="0" rtlCol="0" fromWordArt="0" anchor="ctr" anchorCtr="0" forceAA="0" compatLnSpc="1">
             <a:prstTxWarp prst="textNoShape">
               <a:avLst/>
             </a:prstTxWarp>
@@ -721,7 +1163,7 @@
           <a:lstStyle/>
           <a:p>
             <a:pPr algn="ctr"/>
-            <a:endParaRPr lang="en-US"/>
+            <a:endParaRPr lang="en-US" sz="2223"/>
           </a:p>
         </p:txBody>
       </p:sp>
@@ -739,8 +1181,8 @@
         </p:nvGrpSpPr>
         <p:grpSpPr>
           <a:xfrm>
-            <a:off x="1329952" y="4524379"/>
-            <a:ext cx="1980001" cy="1363916"/>
+            <a:off x="1396450" y="6334131"/>
+            <a:ext cx="2079001" cy="1909482"/>
             <a:chOff x="4879602" y="3781429"/>
             <a:chExt cx="1980001" cy="1363916"/>
           </a:xfrm>
@@ -879,7 +1321,7 @@
             <a:lstStyle/>
             <a:p>
               <a:pPr algn="ctr"/>
-              <a:endParaRPr lang="en-US" dirty="0"/>
+              <a:endParaRPr lang="en-US" sz="2223" dirty="0"/>
             </a:p>
           </p:txBody>
         </p:sp>
@@ -1015,7 +1457,7 @@
             <a:lstStyle/>
             <a:p>
               <a:pPr algn="ctr"/>
-              <a:endParaRPr lang="en-US" dirty="0">
+              <a:endParaRPr lang="en-US" sz="2223" dirty="0">
                 <a:solidFill>
                   <a:schemeClr val="tx1"/>
                 </a:solidFill>
@@ -1088,7 +1530,7 @@
             <a:lstStyle/>
             <a:p>
               <a:pPr algn="ctr"/>
-              <a:endParaRPr lang="en-US"/>
+              <a:endParaRPr lang="en-US" sz="2223"/>
             </a:p>
           </p:txBody>
         </p:sp>
@@ -1157,7 +1599,7 @@
             <a:lstStyle/>
             <a:p>
               <a:pPr algn="ctr"/>
-              <a:endParaRPr lang="en-US"/>
+              <a:endParaRPr lang="en-US" sz="2223"/>
             </a:p>
           </p:txBody>
         </p:sp>
@@ -1210,8 +1652,8 @@
         </p:nvSpPr>
         <p:spPr>
           <a:xfrm>
-            <a:off x="550862" y="503906"/>
-            <a:ext cx="11090275" cy="1333057"/>
+            <a:off x="578406" y="705469"/>
+            <a:ext cx="11644789" cy="1866280"/>
           </a:xfrm>
         </p:spPr>
         <p:txBody>
@@ -1313,7 +1755,7 @@
           <a:p>
             <a:fld id="{EE2EBD84-71F4-4271-8C46-0D47C0A9B12E}" type="datetime2">
               <a:rPr lang="en-US" smtClean="0"/>
-              <a:t>Monday, March 30, 2026</a:t>
+              <a:t>Monday, April 13, 2026</a:t>
             </a:fld>
             <a:endParaRPr lang="en-US"/>
           </a:p>
@@ -1424,8 +1866,8 @@
         </p:nvSpPr>
         <p:spPr>
           <a:xfrm>
-            <a:off x="8724900" y="365125"/>
-            <a:ext cx="2628900" cy="5811838"/>
+            <a:off x="9161145" y="511175"/>
+            <a:ext cx="2760345" cy="8136573"/>
           </a:xfrm>
         </p:spPr>
         <p:txBody>
@@ -1457,8 +1899,8 @@
         </p:nvSpPr>
         <p:spPr>
           <a:xfrm>
-            <a:off x="838200" y="365125"/>
-            <a:ext cx="7734300" cy="5811838"/>
+            <a:off x="880110" y="511175"/>
+            <a:ext cx="8121015" cy="8136573"/>
           </a:xfrm>
         </p:spPr>
         <p:txBody>
@@ -1524,7 +1966,7 @@
           <a:p>
             <a:fld id="{ABAE0CE1-F450-4107-B2CB-17B18F8A3F4A}" type="datetime2">
               <a:rPr lang="en-US" smtClean="0"/>
-              <a:t>Monday, March 30, 2026</a:t>
+              <a:t>Monday, April 13, 2026</a:t>
             </a:fld>
             <a:endParaRPr lang="en-US"/>
           </a:p>
@@ -1631,8 +2073,8 @@
         </p:nvGrpSpPr>
         <p:grpSpPr>
           <a:xfrm>
-            <a:off x="613998" y="5334748"/>
-            <a:ext cx="678135" cy="990000"/>
+            <a:off x="644698" y="7468647"/>
+            <a:ext cx="712042" cy="1386000"/>
             <a:chOff x="10490969" y="1448827"/>
             <a:chExt cx="678135" cy="990000"/>
           </a:xfrm>
@@ -1771,7 +2213,7 @@
             <a:lstStyle/>
             <a:p>
               <a:pPr algn="ctr"/>
-              <a:endParaRPr lang="en-US" dirty="0">
+              <a:endParaRPr lang="en-US" sz="2223" dirty="0">
                 <a:solidFill>
                   <a:schemeClr val="tx1"/>
                 </a:solidFill>
@@ -1844,7 +2286,7 @@
             <a:lstStyle/>
             <a:p>
               <a:pPr algn="ctr"/>
-              <a:endParaRPr lang="en-US"/>
+              <a:endParaRPr lang="en-US" sz="2223"/>
             </a:p>
           </p:txBody>
         </p:sp>
@@ -1913,7 +2355,7 @@
             <a:lstStyle/>
             <a:p>
               <a:pPr algn="ctr"/>
-              <a:endParaRPr lang="en-US"/>
+              <a:endParaRPr lang="en-US" sz="2223"/>
             </a:p>
           </p:txBody>
         </p:sp>
@@ -2049,7 +2491,7 @@
             <a:lstStyle/>
             <a:p>
               <a:pPr algn="ctr"/>
-              <a:endParaRPr lang="en-US" dirty="0">
+              <a:endParaRPr lang="en-US" sz="2223" dirty="0">
                 <a:solidFill>
                   <a:schemeClr val="tx1"/>
                 </a:solidFill>
@@ -2076,8 +2518,8 @@
         </p:nvSpPr>
         <p:spPr>
           <a:xfrm>
-            <a:off x="550862" y="549275"/>
-            <a:ext cx="11091600" cy="1332000"/>
+            <a:off x="578405" y="768985"/>
+            <a:ext cx="11646180" cy="1864800"/>
           </a:xfrm>
         </p:spPr>
         <p:txBody>
@@ -2121,8 +2563,8 @@
         </p:nvSpPr>
         <p:spPr>
           <a:xfrm>
-            <a:off x="550863" y="2113199"/>
-            <a:ext cx="11090274" cy="3979625"/>
+            <a:off x="578406" y="2958479"/>
+            <a:ext cx="11644788" cy="5571475"/>
           </a:xfrm>
         </p:spPr>
         <p:txBody>
@@ -2189,7 +2631,7 @@
           <a:p>
             <a:fld id="{6FE8C025-CD7A-4966-867E-81CF82B15267}" type="datetime2">
               <a:rPr lang="en-US" smtClean="0"/>
-              <a:t>Monday, March 30, 2026</a:t>
+              <a:t>Monday, April 13, 2026</a:t>
             </a:fld>
             <a:endParaRPr lang="en-US"/>
           </a:p>
@@ -2296,8 +2738,8 @@
         </p:nvGrpSpPr>
         <p:grpSpPr>
           <a:xfrm>
-            <a:off x="356481" y="879007"/>
-            <a:ext cx="734257" cy="760506"/>
+            <a:off x="374306" y="1230610"/>
+            <a:ext cx="770970" cy="1064708"/>
             <a:chOff x="5243759" y="1363788"/>
             <a:chExt cx="734257" cy="760506"/>
           </a:xfrm>
@@ -2433,7 +2875,7 @@
             <a:lstStyle/>
             <a:p>
               <a:pPr algn="ctr"/>
-              <a:endParaRPr lang="en-US"/>
+              <a:endParaRPr lang="en-US" sz="2223"/>
             </a:p>
           </p:txBody>
         </p:sp>
@@ -2584,7 +3026,7 @@
             <a:lstStyle/>
             <a:p>
               <a:pPr algn="ctr"/>
-              <a:endParaRPr lang="en-US"/>
+              <a:endParaRPr lang="en-US" sz="2223"/>
             </a:p>
           </p:txBody>
         </p:sp>
@@ -2736,7 +3178,7 @@
             <a:lstStyle/>
             <a:p>
               <a:pPr algn="ctr"/>
-              <a:endParaRPr lang="en-US"/>
+              <a:endParaRPr lang="en-US" sz="2223"/>
             </a:p>
           </p:txBody>
         </p:sp>
@@ -2759,8 +3201,8 @@
         </p:nvSpPr>
         <p:spPr>
           <a:xfrm>
-            <a:off x="563563" y="474345"/>
-            <a:ext cx="11077574" cy="2954655"/>
+            <a:off x="591741" y="664084"/>
+            <a:ext cx="11631453" cy="4136517"/>
           </a:xfrm>
         </p:spPr>
         <p:txBody>
@@ -2769,7 +3211,7 @@
           </a:bodyPr>
           <a:lstStyle>
             <a:lvl1pPr>
-              <a:defRPr lang="en-US" sz="6400" dirty="0"/>
+              <a:defRPr lang="en-US" sz="6720" dirty="0"/>
             </a:lvl1pPr>
           </a:lstStyle>
           <a:p>
@@ -2809,7 +3251,7 @@
           <a:p>
             <a:fld id="{FE809929-0719-4517-94D6-FDF7F99E70F6}" type="datetime2">
               <a:rPr lang="en-US" smtClean="0"/>
-              <a:t>Monday, March 30, 2026</a:t>
+              <a:t>Monday, April 13, 2026</a:t>
             </a:fld>
             <a:endParaRPr lang="en-US"/>
           </a:p>
@@ -2890,8 +3332,8 @@
         </p:nvSpPr>
         <p:spPr>
           <a:xfrm>
-            <a:off x="566271" y="3629772"/>
-            <a:ext cx="11074866" cy="2678953"/>
+            <a:off x="594585" y="5081682"/>
+            <a:ext cx="11628609" cy="3750534"/>
           </a:xfrm>
         </p:spPr>
         <p:txBody>
@@ -2907,7 +3349,7 @@
                 <a:spcPts val="0"/>
               </a:spcBef>
               <a:buNone/>
-              <a:defRPr sz="2400">
+              <a:defRPr sz="2520">
                 <a:solidFill>
                   <a:schemeClr val="tx1">
                     <a:alpha val="80000"/>
@@ -2915,9 +3357,9 @@
                 </a:solidFill>
               </a:defRPr>
             </a:lvl1pPr>
-            <a:lvl2pPr marL="457200" indent="0">
+            <a:lvl2pPr marL="480060" indent="0">
               <a:buNone/>
-              <a:defRPr sz="2000">
+              <a:defRPr sz="2100">
                 <a:solidFill>
                   <a:schemeClr val="tx1">
                     <a:tint val="75000"/>
@@ -2925,9 +3367,9 @@
                 </a:solidFill>
               </a:defRPr>
             </a:lvl2pPr>
-            <a:lvl3pPr marL="914400" indent="0">
+            <a:lvl3pPr marL="960120" indent="0">
               <a:buNone/>
-              <a:defRPr sz="1800">
+              <a:defRPr sz="1890">
                 <a:solidFill>
                   <a:schemeClr val="tx1">
                     <a:tint val="75000"/>
@@ -2935,9 +3377,9 @@
                 </a:solidFill>
               </a:defRPr>
             </a:lvl3pPr>
-            <a:lvl4pPr marL="1371600" indent="0">
+            <a:lvl4pPr marL="1440180" indent="0">
               <a:buNone/>
-              <a:defRPr sz="1600">
+              <a:defRPr sz="1680">
                 <a:solidFill>
                   <a:schemeClr val="tx1">
                     <a:tint val="75000"/>
@@ -2945,9 +3387,9 @@
                 </a:solidFill>
               </a:defRPr>
             </a:lvl4pPr>
-            <a:lvl5pPr marL="1828800" indent="0">
+            <a:lvl5pPr marL="1920240" indent="0">
               <a:buNone/>
-              <a:defRPr sz="1600">
+              <a:defRPr sz="1680">
                 <a:solidFill>
                   <a:schemeClr val="tx1">
                     <a:tint val="75000"/>
@@ -2955,9 +3397,9 @@
                 </a:solidFill>
               </a:defRPr>
             </a:lvl5pPr>
-            <a:lvl6pPr marL="2286000" indent="0">
+            <a:lvl6pPr marL="2400300" indent="0">
               <a:buNone/>
-              <a:defRPr sz="1600">
+              <a:defRPr sz="1680">
                 <a:solidFill>
                   <a:schemeClr val="tx1">
                     <a:tint val="75000"/>
@@ -2965,9 +3407,9 @@
                 </a:solidFill>
               </a:defRPr>
             </a:lvl6pPr>
-            <a:lvl7pPr marL="2743200" indent="0">
+            <a:lvl7pPr marL="2880360" indent="0">
               <a:buNone/>
-              <a:defRPr sz="1600">
+              <a:defRPr sz="1680">
                 <a:solidFill>
                   <a:schemeClr val="tx1">
                     <a:tint val="75000"/>
@@ -2975,9 +3417,9 @@
                 </a:solidFill>
               </a:defRPr>
             </a:lvl7pPr>
-            <a:lvl8pPr marL="3200400" indent="0">
+            <a:lvl8pPr marL="3360420" indent="0">
               <a:buNone/>
-              <a:defRPr sz="1600">
+              <a:defRPr sz="1680">
                 <a:solidFill>
                   <a:schemeClr val="tx1">
                     <a:tint val="75000"/>
@@ -2985,9 +3427,9 @@
                 </a:solidFill>
               </a:defRPr>
             </a:lvl8pPr>
-            <a:lvl9pPr marL="3657600" indent="0">
+            <a:lvl9pPr marL="3840480" indent="0">
               <a:buNone/>
-              <a:defRPr sz="1600">
+              <a:defRPr sz="1680">
                 <a:solidFill>
                   <a:schemeClr val="tx1">
                     <a:tint val="75000"/>
@@ -3021,8 +3463,8 @@
         </p:nvSpPr>
         <p:spPr>
           <a:xfrm rot="18900000">
-            <a:off x="11209132" y="4448189"/>
-            <a:ext cx="999200" cy="1262947"/>
+            <a:off x="11769589" y="6227465"/>
+            <a:ext cx="1049160" cy="1768126"/>
           </a:xfrm>
           <a:custGeom>
             <a:avLst/>
@@ -3154,7 +3596,7 @@
           </a:fontRef>
         </p:style>
         <p:txBody>
-          <a:bodyPr rot="0" spcFirstLastPara="0" vertOverflow="overflow" horzOverflow="overflow" vert="horz" wrap="square" lIns="91440" tIns="45720" rIns="91440" bIns="45720" numCol="1" spcCol="0" rtlCol="0" fromWordArt="0" anchor="ctr" anchorCtr="0" forceAA="0" compatLnSpc="1">
+          <a:bodyPr rot="0" spcFirstLastPara="0" vertOverflow="overflow" horzOverflow="overflow" vert="horz" wrap="square" lIns="96012" tIns="48006" rIns="96012" bIns="48006" numCol="1" spcCol="0" rtlCol="0" fromWordArt="0" anchor="ctr" anchorCtr="0" forceAA="0" compatLnSpc="1">
             <a:prstTxWarp prst="textNoShape">
               <a:avLst/>
             </a:prstTxWarp>
@@ -3163,7 +3605,7 @@
           <a:lstStyle/>
           <a:p>
             <a:pPr algn="ctr"/>
-            <a:endParaRPr lang="en-US"/>
+            <a:endParaRPr lang="en-US" sz="2223"/>
           </a:p>
         </p:txBody>
       </p:sp>
@@ -3181,8 +3623,8 @@
         </p:nvSpPr>
         <p:spPr>
           <a:xfrm rot="2700000">
-            <a:off x="11686937" y="4853516"/>
-            <a:ext cx="540000" cy="978284"/>
+            <a:off x="12176784" y="6966122"/>
+            <a:ext cx="756000" cy="1027198"/>
           </a:xfrm>
           <a:custGeom>
             <a:avLst/>
@@ -3288,7 +3730,7 @@
           </a:fontRef>
         </p:style>
         <p:txBody>
-          <a:bodyPr rot="0" spcFirstLastPara="0" vertOverflow="overflow" horzOverflow="overflow" vert="horz" wrap="square" lIns="91440" tIns="45720" rIns="91440" bIns="45720" numCol="1" spcCol="0" rtlCol="0" fromWordArt="0" anchor="ctr" anchorCtr="0" forceAA="0" compatLnSpc="1">
+          <a:bodyPr rot="0" spcFirstLastPara="0" vertOverflow="overflow" horzOverflow="overflow" vert="horz" wrap="square" lIns="96012" tIns="48006" rIns="96012" bIns="48006" numCol="1" spcCol="0" rtlCol="0" fromWordArt="0" anchor="ctr" anchorCtr="0" forceAA="0" compatLnSpc="1">
             <a:prstTxWarp prst="textNoShape">
               <a:avLst/>
             </a:prstTxWarp>
@@ -3297,7 +3739,7 @@
           <a:lstStyle/>
           <a:p>
             <a:pPr algn="ctr"/>
-            <a:endParaRPr lang="en-US"/>
+            <a:endParaRPr lang="en-US" sz="2223"/>
           </a:p>
         </p:txBody>
       </p:sp>
@@ -3347,8 +3789,8 @@
         </p:nvSpPr>
         <p:spPr>
           <a:xfrm>
-            <a:off x="11069864" y="333375"/>
-            <a:ext cx="360000" cy="360000"/>
+            <a:off x="11623357" y="466725"/>
+            <a:ext cx="378000" cy="504000"/>
           </a:xfrm>
           <a:prstGeom prst="ellipse">
             <a:avLst/>
@@ -3401,7 +3843,7 @@
           </a:fontRef>
         </p:style>
         <p:txBody>
-          <a:bodyPr rot="0" spcFirstLastPara="0" vertOverflow="overflow" horzOverflow="overflow" vert="horz" wrap="square" lIns="91440" tIns="45720" rIns="91440" bIns="45720" numCol="1" spcCol="0" rtlCol="0" fromWordArt="0" anchor="ctr" anchorCtr="0" forceAA="0" compatLnSpc="1">
+          <a:bodyPr rot="0" spcFirstLastPara="0" vertOverflow="overflow" horzOverflow="overflow" vert="horz" wrap="square" lIns="96012" tIns="48006" rIns="96012" bIns="48006" numCol="1" spcCol="0" rtlCol="0" fromWordArt="0" anchor="ctr" anchorCtr="0" forceAA="0" compatLnSpc="1">
             <a:prstTxWarp prst="textNoShape">
               <a:avLst/>
             </a:prstTxWarp>
@@ -3410,7 +3852,7 @@
           <a:lstStyle/>
           <a:p>
             <a:pPr algn="ctr"/>
-            <a:endParaRPr lang="en-US"/>
+            <a:endParaRPr lang="en-US" sz="2223"/>
           </a:p>
         </p:txBody>
       </p:sp>
@@ -3428,8 +3870,8 @@
         </p:nvGrpSpPr>
         <p:grpSpPr>
           <a:xfrm>
-            <a:off x="331786" y="5528198"/>
-            <a:ext cx="631474" cy="667800"/>
+            <a:off x="348375" y="7739477"/>
+            <a:ext cx="663048" cy="934920"/>
             <a:chOff x="2994153" y="1378666"/>
             <a:chExt cx="631474" cy="667800"/>
           </a:xfrm>
@@ -3652,7 +4094,7 @@
             <a:lstStyle/>
             <a:p>
               <a:pPr algn="ctr"/>
-              <a:endParaRPr lang="en-US"/>
+              <a:endParaRPr lang="en-US" sz="2223"/>
             </a:p>
           </p:txBody>
         </p:sp>
@@ -3732,7 +4174,7 @@
             <a:lstStyle/>
             <a:p>
               <a:pPr algn="ctr"/>
-              <a:endParaRPr lang="en-US"/>
+              <a:endParaRPr lang="en-US" sz="2223"/>
             </a:p>
           </p:txBody>
         </p:sp>
@@ -3755,8 +4197,8 @@
         </p:nvSpPr>
         <p:spPr>
           <a:xfrm>
-            <a:off x="550863" y="549275"/>
-            <a:ext cx="11090274" cy="1332000"/>
+            <a:off x="578406" y="768985"/>
+            <a:ext cx="11644788" cy="1864800"/>
           </a:xfrm>
         </p:spPr>
         <p:txBody>
@@ -3796,8 +4238,8 @@
         </p:nvSpPr>
         <p:spPr>
           <a:xfrm>
-            <a:off x="550862" y="2097175"/>
-            <a:ext cx="5435600" cy="3995650"/>
+            <a:off x="578405" y="2936045"/>
+            <a:ext cx="5707380" cy="5593910"/>
           </a:xfrm>
         </p:spPr>
         <p:txBody>
@@ -3859,8 +4301,8 @@
         </p:nvSpPr>
         <p:spPr>
           <a:xfrm>
-            <a:off x="6205538" y="2097175"/>
-            <a:ext cx="5435600" cy="3995650"/>
+            <a:off x="6515815" y="2936045"/>
+            <a:ext cx="5707380" cy="5593910"/>
           </a:xfrm>
         </p:spPr>
         <p:txBody>
@@ -3927,7 +4369,7 @@
           <a:p>
             <a:fld id="{20E95673-5512-4AAA-9AEB-E00C61EC65D5}" type="datetime2">
               <a:rPr lang="en-US" smtClean="0"/>
-              <a:t>Monday, March 30, 2026</a:t>
+              <a:t>Monday, April 13, 2026</a:t>
             </a:fld>
             <a:endParaRPr lang="en-US"/>
           </a:p>
@@ -4036,8 +4478,8 @@
         </p:nvSpPr>
         <p:spPr>
           <a:xfrm>
-            <a:off x="11091612" y="5893466"/>
-            <a:ext cx="360000" cy="360000"/>
+            <a:off x="11646193" y="8250852"/>
+            <a:ext cx="378000" cy="504000"/>
           </a:xfrm>
           <a:prstGeom prst="ellipse">
             <a:avLst/>
@@ -4090,7 +4532,7 @@
           </a:fontRef>
         </p:style>
         <p:txBody>
-          <a:bodyPr rot="0" spcFirstLastPara="0" vertOverflow="overflow" horzOverflow="overflow" vert="horz" wrap="square" lIns="91440" tIns="45720" rIns="91440" bIns="45720" numCol="1" spcCol="0" rtlCol="0" fromWordArt="0" anchor="ctr" anchorCtr="0" forceAA="0" compatLnSpc="1">
+          <a:bodyPr rot="0" spcFirstLastPara="0" vertOverflow="overflow" horzOverflow="overflow" vert="horz" wrap="square" lIns="96012" tIns="48006" rIns="96012" bIns="48006" numCol="1" spcCol="0" rtlCol="0" fromWordArt="0" anchor="ctr" anchorCtr="0" forceAA="0" compatLnSpc="1">
             <a:prstTxWarp prst="textNoShape">
               <a:avLst/>
             </a:prstTxWarp>
@@ -4099,7 +4541,7 @@
           <a:lstStyle/>
           <a:p>
             <a:pPr algn="ctr"/>
-            <a:endParaRPr lang="en-US"/>
+            <a:endParaRPr lang="en-US" sz="2223"/>
           </a:p>
         </p:txBody>
       </p:sp>
@@ -4117,8 +4559,8 @@
         </p:nvSpPr>
         <p:spPr>
           <a:xfrm>
-            <a:off x="11451612" y="5827878"/>
-            <a:ext cx="379049" cy="360000"/>
+            <a:off x="12024193" y="8159029"/>
+            <a:ext cx="398001" cy="504000"/>
           </a:xfrm>
           <a:prstGeom prst="rect">
             <a:avLst/>
@@ -4153,7 +4595,7 @@
           <a:lstStyle/>
           <a:p>
             <a:pPr algn="ctr"/>
-            <a:endParaRPr lang="en-US"/>
+            <a:endParaRPr lang="en-US" sz="2223"/>
           </a:p>
         </p:txBody>
       </p:sp>
@@ -4175,8 +4617,8 @@
         </p:nvSpPr>
         <p:spPr>
           <a:xfrm>
-            <a:off x="550862" y="549275"/>
-            <a:ext cx="11097551" cy="1332000"/>
+            <a:off x="578405" y="768985"/>
+            <a:ext cx="11652429" cy="1864800"/>
           </a:xfrm>
         </p:spPr>
         <p:txBody>
@@ -4185,7 +4627,7 @@
           </a:bodyPr>
           <a:lstStyle>
             <a:lvl1pPr>
-              <a:defRPr lang="en-US" sz="3200" dirty="0"/>
+              <a:defRPr lang="en-US" sz="3360" dirty="0"/>
             </a:lvl1pPr>
           </a:lstStyle>
           <a:p>
@@ -4220,8 +4662,8 @@
         </p:nvSpPr>
         <p:spPr>
           <a:xfrm>
-            <a:off x="550864" y="1881275"/>
-            <a:ext cx="5437186" cy="535354"/>
+            <a:off x="578407" y="2633785"/>
+            <a:ext cx="5709045" cy="749496"/>
           </a:xfrm>
         </p:spPr>
         <p:txBody>
@@ -4231,44 +4673,44 @@
           <a:lstStyle>
             <a:lvl1pPr marL="0" indent="0">
               <a:buNone/>
-              <a:defRPr sz="1400" b="0" cap="all" spc="200" baseline="0">
+              <a:defRPr sz="1470" b="0" cap="all" spc="210" baseline="0">
                 <a:solidFill>
                   <a:schemeClr val="tx1"/>
                 </a:solidFill>
                 <a:latin typeface="+mn-lt"/>
               </a:defRPr>
             </a:lvl1pPr>
-            <a:lvl2pPr marL="457200" indent="0">
+            <a:lvl2pPr marL="480060" indent="0">
               <a:buNone/>
-              <a:defRPr sz="2000" b="1"/>
+              <a:defRPr sz="2100" b="1"/>
             </a:lvl2pPr>
-            <a:lvl3pPr marL="914400" indent="0">
+            <a:lvl3pPr marL="960120" indent="0">
               <a:buNone/>
-              <a:defRPr sz="1800" b="1"/>
+              <a:defRPr sz="1890" b="1"/>
             </a:lvl3pPr>
-            <a:lvl4pPr marL="1371600" indent="0">
+            <a:lvl4pPr marL="1440180" indent="0">
               <a:buNone/>
-              <a:defRPr sz="1600" b="1"/>
+              <a:defRPr sz="1680" b="1"/>
             </a:lvl4pPr>
-            <a:lvl5pPr marL="1828800" indent="0">
+            <a:lvl5pPr marL="1920240" indent="0">
               <a:buNone/>
-              <a:defRPr sz="1600" b="1"/>
+              <a:defRPr sz="1680" b="1"/>
             </a:lvl5pPr>
-            <a:lvl6pPr marL="2286000" indent="0">
+            <a:lvl6pPr marL="2400300" indent="0">
               <a:buNone/>
-              <a:defRPr sz="1600" b="1"/>
+              <a:defRPr sz="1680" b="1"/>
             </a:lvl6pPr>
-            <a:lvl7pPr marL="2743200" indent="0">
+            <a:lvl7pPr marL="2880360" indent="0">
               <a:buNone/>
-              <a:defRPr sz="1600" b="1"/>
+              <a:defRPr sz="1680" b="1"/>
             </a:lvl7pPr>
-            <a:lvl8pPr marL="3200400" indent="0">
+            <a:lvl8pPr marL="3360420" indent="0">
               <a:buNone/>
-              <a:defRPr sz="1600" b="1"/>
+              <a:defRPr sz="1680" b="1"/>
             </a:lvl8pPr>
-            <a:lvl9pPr marL="3657600" indent="0">
+            <a:lvl9pPr marL="3840480" indent="0">
               <a:buNone/>
-              <a:defRPr sz="1600" b="1"/>
+              <a:defRPr sz="1680" b="1"/>
             </a:lvl9pPr>
           </a:lstStyle>
           <a:p>
@@ -4298,8 +4740,8 @@
         </p:nvSpPr>
         <p:spPr>
           <a:xfrm>
-            <a:off x="550863" y="2577270"/>
-            <a:ext cx="5429114" cy="3515555"/>
+            <a:off x="578406" y="3608179"/>
+            <a:ext cx="5700570" cy="4921777"/>
           </a:xfrm>
         </p:spPr>
         <p:txBody>
@@ -4361,8 +4803,8 @@
         </p:nvSpPr>
         <p:spPr>
           <a:xfrm>
-            <a:off x="6212024" y="1881275"/>
-            <a:ext cx="5436392" cy="535354"/>
+            <a:off x="6522625" y="2633785"/>
+            <a:ext cx="5708212" cy="749496"/>
           </a:xfrm>
         </p:spPr>
         <p:txBody>
@@ -4371,7 +4813,7 @@
           </a:bodyPr>
           <a:lstStyle>
             <a:lvl1pPr>
-              <a:defRPr lang="en-US" sz="1400" b="0" cap="all" spc="200" baseline="0" dirty="0">
+              <a:defRPr lang="en-US" sz="1470" b="0" cap="all" spc="210" baseline="0" dirty="0">
                 <a:solidFill>
                   <a:schemeClr val="tx1"/>
                 </a:solidFill>
@@ -4407,8 +4849,8 @@
         </p:nvSpPr>
         <p:spPr>
           <a:xfrm>
-            <a:off x="6212023" y="2577270"/>
-            <a:ext cx="5436391" cy="3515555"/>
+            <a:off x="6522624" y="3608179"/>
+            <a:ext cx="5708211" cy="4921777"/>
           </a:xfrm>
         </p:spPr>
         <p:txBody>
@@ -4474,7 +4916,7 @@
           <a:p>
             <a:fld id="{C13138FA-2E87-4873-8BBA-13E447C9A99A}" type="datetime2">
               <a:rPr lang="en-US" smtClean="0"/>
-              <a:t>Monday, March 30, 2026</a:t>
+              <a:t>Monday, April 13, 2026</a:t>
             </a:fld>
             <a:endParaRPr lang="en-US"/>
           </a:p>
@@ -4585,8 +5027,8 @@
         </p:nvSpPr>
         <p:spPr>
           <a:xfrm>
-            <a:off x="3359149" y="550799"/>
-            <a:ext cx="8283313" cy="5542025"/>
+            <a:off x="3527107" y="771119"/>
+            <a:ext cx="8697479" cy="7758835"/>
           </a:xfrm>
         </p:spPr>
         <p:txBody>
@@ -4635,7 +5077,7 @@
           <a:p>
             <a:fld id="{D75BB40A-97BD-4BFB-B639-0BFF95FDE8B7}" type="datetime2">
               <a:rPr lang="en-US" smtClean="0"/>
-              <a:t>Monday, March 30, 2026</a:t>
+              <a:t>Monday, April 13, 2026</a:t>
             </a:fld>
             <a:endParaRPr lang="en-US"/>
           </a:p>
@@ -4714,8 +5156,8 @@
         </p:nvSpPr>
         <p:spPr>
           <a:xfrm rot="18900000" flipV="1">
-            <a:off x="-410727" y="3958416"/>
-            <a:ext cx="3536330" cy="1853969"/>
+            <a:off x="-431264" y="5541783"/>
+            <a:ext cx="3713147" cy="2595557"/>
           </a:xfrm>
           <a:custGeom>
             <a:avLst/>
@@ -4854,7 +5296,7 @@
           <a:lstStyle/>
           <a:p>
             <a:pPr algn="ctr"/>
-            <a:endParaRPr lang="en-US" dirty="0"/>
+            <a:endParaRPr lang="en-US" sz="2223" dirty="0"/>
           </a:p>
         </p:txBody>
       </p:sp>
@@ -4874,8 +5316,8 @@
         </p:nvSpPr>
         <p:spPr>
           <a:xfrm rot="18900000" flipV="1">
-            <a:off x="-481151" y="3649708"/>
-            <a:ext cx="3478701" cy="2164843"/>
+            <a:off x="-505208" y="5109592"/>
+            <a:ext cx="3652636" cy="3030780"/>
           </a:xfrm>
           <a:custGeom>
             <a:avLst/>
@@ -5000,7 +5442,7 @@
           <a:lstStyle/>
           <a:p>
             <a:pPr algn="ctr"/>
-            <a:endParaRPr lang="en-US" dirty="0"/>
+            <a:endParaRPr lang="en-US" sz="2223" dirty="0"/>
           </a:p>
         </p:txBody>
       </p:sp>
@@ -5018,8 +5460,8 @@
         </p:nvSpPr>
         <p:spPr>
           <a:xfrm rot="13500000" flipV="1">
-            <a:off x="1512277" y="2840042"/>
-            <a:ext cx="214196" cy="933178"/>
+            <a:off x="1550407" y="4139365"/>
+            <a:ext cx="299874" cy="979837"/>
           </a:xfrm>
           <a:prstGeom prst="ellipse">
             <a:avLst/>
@@ -5060,7 +5502,7 @@
           </a:fontRef>
         </p:style>
         <p:txBody>
-          <a:bodyPr rot="0" spcFirstLastPara="0" vertOverflow="overflow" horzOverflow="overflow" vert="horz" wrap="square" lIns="91440" tIns="45720" rIns="91440" bIns="45720" numCol="1" spcCol="0" rtlCol="0" fromWordArt="0" anchor="ctr" anchorCtr="0" forceAA="0" compatLnSpc="1">
+          <a:bodyPr rot="0" spcFirstLastPara="0" vertOverflow="overflow" horzOverflow="overflow" vert="horz" wrap="square" lIns="96012" tIns="48006" rIns="96012" bIns="48006" numCol="1" spcCol="0" rtlCol="0" fromWordArt="0" anchor="ctr" anchorCtr="0" forceAA="0" compatLnSpc="1">
             <a:prstTxWarp prst="textNoShape">
               <a:avLst/>
             </a:prstTxWarp>
@@ -5069,7 +5511,7 @@
           <a:lstStyle/>
           <a:p>
             <a:pPr algn="ctr"/>
-            <a:endParaRPr lang="en-US"/>
+            <a:endParaRPr lang="en-US" sz="2223"/>
           </a:p>
         </p:txBody>
       </p:sp>
@@ -5089,8 +5531,8 @@
         </p:nvSpPr>
         <p:spPr>
           <a:xfrm>
-            <a:off x="1780661" y="385236"/>
-            <a:ext cx="1080000" cy="1080000"/>
+            <a:off x="1869694" y="539330"/>
+            <a:ext cx="1134000" cy="1512000"/>
           </a:xfrm>
           <a:prstGeom prst="ellipse">
             <a:avLst/>
@@ -5145,7 +5587,7 @@
           </a:fontRef>
         </p:style>
         <p:txBody>
-          <a:bodyPr rot="0" spcFirstLastPara="0" vertOverflow="overflow" horzOverflow="overflow" vert="horz" wrap="square" lIns="91440" tIns="45720" rIns="91440" bIns="45720" numCol="1" spcCol="0" rtlCol="0" fromWordArt="0" anchor="ctr" anchorCtr="0" forceAA="0" compatLnSpc="1">
+          <a:bodyPr rot="0" spcFirstLastPara="0" vertOverflow="overflow" horzOverflow="overflow" vert="horz" wrap="square" lIns="96012" tIns="48006" rIns="96012" bIns="48006" numCol="1" spcCol="0" rtlCol="0" fromWordArt="0" anchor="ctr" anchorCtr="0" forceAA="0" compatLnSpc="1">
             <a:prstTxWarp prst="textNoShape">
               <a:avLst/>
             </a:prstTxWarp>
@@ -5154,7 +5596,7 @@
           <a:lstStyle/>
           <a:p>
             <a:pPr algn="ctr"/>
-            <a:endParaRPr lang="en-US"/>
+            <a:endParaRPr lang="en-US" sz="2223"/>
           </a:p>
         </p:txBody>
       </p:sp>
@@ -5172,8 +5614,8 @@
         </p:nvGrpSpPr>
         <p:grpSpPr>
           <a:xfrm>
-            <a:off x="623181" y="1514007"/>
-            <a:ext cx="734257" cy="760506"/>
+            <a:off x="654341" y="2119610"/>
+            <a:ext cx="770970" cy="1064708"/>
             <a:chOff x="5243759" y="1363788"/>
             <a:chExt cx="734257" cy="760506"/>
           </a:xfrm>
@@ -5309,7 +5751,7 @@
             <a:lstStyle/>
             <a:p>
               <a:pPr algn="ctr"/>
-              <a:endParaRPr lang="en-US"/>
+              <a:endParaRPr lang="en-US" sz="2223"/>
             </a:p>
           </p:txBody>
         </p:sp>
@@ -5460,7 +5902,7 @@
             <a:lstStyle/>
             <a:p>
               <a:pPr algn="ctr"/>
-              <a:endParaRPr lang="en-US"/>
+              <a:endParaRPr lang="en-US" sz="2223"/>
             </a:p>
           </p:txBody>
         </p:sp>
@@ -5612,7 +6054,7 @@
             <a:lstStyle/>
             <a:p>
               <a:pPr algn="ctr"/>
-              <a:endParaRPr lang="en-US"/>
+              <a:endParaRPr lang="en-US" sz="2223"/>
             </a:p>
           </p:txBody>
         </p:sp>
@@ -5670,7 +6112,7 @@
           <a:p>
             <a:fld id="{9EE9E0E3-ECF6-4CFE-8698-AEFEBCECC3C0}" type="datetime2">
               <a:rPr lang="en-US" smtClean="0"/>
-              <a:t>Monday, March 30, 2026</a:t>
+              <a:t>Monday, April 13, 2026</a:t>
             </a:fld>
             <a:endParaRPr lang="en-US"/>
           </a:p>
@@ -5777,8 +6219,8 @@
         </p:nvGrpSpPr>
         <p:grpSpPr>
           <a:xfrm>
-            <a:off x="4949631" y="5111861"/>
-            <a:ext cx="1262947" cy="1335600"/>
+            <a:off x="5197113" y="7156605"/>
+            <a:ext cx="1326094" cy="1869840"/>
             <a:chOff x="2678417" y="2427951"/>
             <a:chExt cx="1262947" cy="1335600"/>
           </a:xfrm>
@@ -6001,7 +6443,7 @@
             <a:lstStyle/>
             <a:p>
               <a:pPr algn="ctr"/>
-              <a:endParaRPr lang="en-US"/>
+              <a:endParaRPr lang="en-US" sz="2223"/>
             </a:p>
           </p:txBody>
         </p:sp>
@@ -6081,7 +6523,7 @@
             <a:lstStyle/>
             <a:p>
               <a:pPr algn="ctr"/>
-              <a:endParaRPr lang="en-US"/>
+              <a:endParaRPr lang="en-US" sz="2223"/>
             </a:p>
           </p:txBody>
         </p:sp>
@@ -6104,8 +6546,8 @@
         </p:nvSpPr>
         <p:spPr>
           <a:xfrm>
-            <a:off x="550863" y="549275"/>
-            <a:ext cx="11090275" cy="984885"/>
+            <a:off x="578407" y="768986"/>
+            <a:ext cx="11644789" cy="1378839"/>
           </a:xfrm>
         </p:spPr>
         <p:txBody>
@@ -6117,7 +6559,7 @@
               <a:lnSpc>
                 <a:spcPct val="100000"/>
               </a:lnSpc>
-              <a:defRPr sz="3200"/>
+              <a:defRPr sz="3360"/>
             </a:lvl1pPr>
           </a:lstStyle>
           <a:p>
@@ -6147,8 +6589,8 @@
         </p:nvSpPr>
         <p:spPr>
           <a:xfrm>
-            <a:off x="4295775" y="1750060"/>
-            <a:ext cx="7345362" cy="4342765"/>
+            <a:off x="4510564" y="2450085"/>
+            <a:ext cx="7712630" cy="6079871"/>
           </a:xfrm>
         </p:spPr>
         <p:txBody>
@@ -6157,31 +6599,31 @@
           </a:bodyPr>
           <a:lstStyle>
             <a:lvl1pPr>
-              <a:defRPr sz="1600"/>
+              <a:defRPr sz="1680"/>
             </a:lvl1pPr>
             <a:lvl2pPr>
-              <a:defRPr sz="1600"/>
+              <a:defRPr sz="1680"/>
             </a:lvl2pPr>
             <a:lvl3pPr>
-              <a:defRPr sz="1600"/>
+              <a:defRPr sz="1680"/>
             </a:lvl3pPr>
             <a:lvl4pPr>
-              <a:defRPr sz="1600"/>
+              <a:defRPr sz="1680"/>
             </a:lvl4pPr>
             <a:lvl5pPr>
-              <a:defRPr sz="1600"/>
+              <a:defRPr sz="1680"/>
             </a:lvl5pPr>
             <a:lvl6pPr>
-              <a:defRPr sz="2000"/>
+              <a:defRPr sz="2100"/>
             </a:lvl6pPr>
             <a:lvl7pPr>
-              <a:defRPr sz="2000"/>
+              <a:defRPr sz="2100"/>
             </a:lvl7pPr>
             <a:lvl8pPr>
-              <a:defRPr sz="2000"/>
+              <a:defRPr sz="2100"/>
             </a:lvl8pPr>
             <a:lvl9pPr>
-              <a:defRPr sz="2000"/>
+              <a:defRPr sz="2100"/>
             </a:lvl9pPr>
           </a:lstStyle>
           <a:p>
@@ -6240,8 +6682,8 @@
         </p:nvSpPr>
         <p:spPr>
           <a:xfrm>
-            <a:off x="550863" y="1750060"/>
-            <a:ext cx="3565525" cy="4342765"/>
+            <a:off x="578407" y="2450085"/>
+            <a:ext cx="3743801" cy="6079871"/>
           </a:xfrm>
         </p:spPr>
         <p:txBody>
@@ -6249,39 +6691,39 @@
           <a:lstStyle>
             <a:lvl1pPr marL="0" indent="0">
               <a:buNone/>
-              <a:defRPr sz="1600"/>
+              <a:defRPr sz="1680"/>
             </a:lvl1pPr>
-            <a:lvl2pPr marL="457200" indent="0">
+            <a:lvl2pPr marL="480060" indent="0">
               <a:buNone/>
-              <a:defRPr sz="1400"/>
+              <a:defRPr sz="1470"/>
             </a:lvl2pPr>
-            <a:lvl3pPr marL="914400" indent="0">
+            <a:lvl3pPr marL="960120" indent="0">
               <a:buNone/>
-              <a:defRPr sz="1200"/>
+              <a:defRPr sz="1260"/>
             </a:lvl3pPr>
-            <a:lvl4pPr marL="1371600" indent="0">
+            <a:lvl4pPr marL="1440180" indent="0">
               <a:buNone/>
-              <a:defRPr sz="1000"/>
+              <a:defRPr sz="1050"/>
             </a:lvl4pPr>
-            <a:lvl5pPr marL="1828800" indent="0">
+            <a:lvl5pPr marL="1920240" indent="0">
               <a:buNone/>
-              <a:defRPr sz="1000"/>
+              <a:defRPr sz="1050"/>
             </a:lvl5pPr>
-            <a:lvl6pPr marL="2286000" indent="0">
+            <a:lvl6pPr marL="2400300" indent="0">
               <a:buNone/>
-              <a:defRPr sz="1000"/>
+              <a:defRPr sz="1050"/>
             </a:lvl6pPr>
-            <a:lvl7pPr marL="2743200" indent="0">
+            <a:lvl7pPr marL="2880360" indent="0">
               <a:buNone/>
-              <a:defRPr sz="1000"/>
+              <a:defRPr sz="1050"/>
             </a:lvl7pPr>
-            <a:lvl8pPr marL="3200400" indent="0">
+            <a:lvl8pPr marL="3360420" indent="0">
               <a:buNone/>
-              <a:defRPr sz="1000"/>
+              <a:defRPr sz="1050"/>
             </a:lvl8pPr>
-            <a:lvl9pPr marL="3657600" indent="0">
+            <a:lvl9pPr marL="3840480" indent="0">
               <a:buNone/>
-              <a:defRPr sz="1000"/>
+              <a:defRPr sz="1050"/>
             </a:lvl9pPr>
           </a:lstStyle>
           <a:p>
@@ -6316,7 +6758,7 @@
           <a:p>
             <a:fld id="{251462FC-960E-4740-921F-B36862979F21}" type="datetime2">
               <a:rPr lang="en-US" smtClean="0"/>
-              <a:t>Monday, March 30, 2026</a:t>
+              <a:t>Monday, April 13, 2026</a:t>
             </a:fld>
             <a:endParaRPr lang="en-US"/>
           </a:p>
@@ -6423,8 +6865,8 @@
         </p:nvGrpSpPr>
         <p:grpSpPr>
           <a:xfrm>
-            <a:off x="334964" y="5115518"/>
-            <a:ext cx="734257" cy="760506"/>
+            <a:off x="351713" y="7161725"/>
+            <a:ext cx="770970" cy="1064708"/>
             <a:chOff x="5243759" y="1363788"/>
             <a:chExt cx="734257" cy="760506"/>
           </a:xfrm>
@@ -6560,7 +7002,7 @@
             <a:lstStyle/>
             <a:p>
               <a:pPr algn="ctr"/>
-              <a:endParaRPr lang="en-US"/>
+              <a:endParaRPr lang="en-US" sz="2223"/>
             </a:p>
           </p:txBody>
         </p:sp>
@@ -6711,7 +7153,7 @@
             <a:lstStyle/>
             <a:p>
               <a:pPr algn="ctr"/>
-              <a:endParaRPr lang="en-US"/>
+              <a:endParaRPr lang="en-US" sz="2223"/>
             </a:p>
           </p:txBody>
         </p:sp>
@@ -6863,7 +7305,7 @@
             <a:lstStyle/>
             <a:p>
               <a:pPr algn="ctr"/>
-              <a:endParaRPr lang="en-US"/>
+              <a:endParaRPr lang="en-US" sz="2223"/>
             </a:p>
           </p:txBody>
         </p:sp>
@@ -6886,8 +7328,8 @@
         </p:nvSpPr>
         <p:spPr>
           <a:xfrm>
-            <a:off x="550863" y="575409"/>
-            <a:ext cx="4500562" cy="984885"/>
+            <a:off x="578406" y="805573"/>
+            <a:ext cx="4725590" cy="1378839"/>
           </a:xfrm>
         </p:spPr>
         <p:txBody>
@@ -6896,7 +7338,7 @@
           </a:bodyPr>
           <a:lstStyle>
             <a:lvl1pPr>
-              <a:defRPr lang="en-US" sz="3200" dirty="0"/>
+              <a:defRPr lang="en-US" sz="3360" dirty="0"/>
             </a:lvl1pPr>
           </a:lstStyle>
           <a:p>
@@ -6931,8 +7373,8 @@
         </p:nvSpPr>
         <p:spPr>
           <a:xfrm>
-            <a:off x="5267324" y="575409"/>
-            <a:ext cx="6373813" cy="5733316"/>
+            <a:off x="5530691" y="805573"/>
+            <a:ext cx="6692504" cy="8026642"/>
           </a:xfrm>
         </p:spPr>
         <p:txBody>
@@ -6942,39 +7384,39 @@
           <a:lstStyle>
             <a:lvl1pPr marL="0" indent="0">
               <a:buNone/>
-              <a:defRPr sz="1600"/>
+              <a:defRPr sz="1680"/>
             </a:lvl1pPr>
-            <a:lvl2pPr marL="457200" indent="0">
+            <a:lvl2pPr marL="480060" indent="0">
               <a:buNone/>
-              <a:defRPr sz="2800"/>
+              <a:defRPr sz="2940"/>
             </a:lvl2pPr>
-            <a:lvl3pPr marL="914400" indent="0">
+            <a:lvl3pPr marL="960120" indent="0">
               <a:buNone/>
-              <a:defRPr sz="2400"/>
+              <a:defRPr sz="2520"/>
             </a:lvl3pPr>
-            <a:lvl4pPr marL="1371600" indent="0">
+            <a:lvl4pPr marL="1440180" indent="0">
               <a:buNone/>
-              <a:defRPr sz="2000"/>
+              <a:defRPr sz="2100"/>
             </a:lvl4pPr>
-            <a:lvl5pPr marL="1828800" indent="0">
+            <a:lvl5pPr marL="1920240" indent="0">
               <a:buNone/>
-              <a:defRPr sz="2000"/>
+              <a:defRPr sz="2100"/>
             </a:lvl5pPr>
-            <a:lvl6pPr marL="2286000" indent="0">
+            <a:lvl6pPr marL="2400300" indent="0">
               <a:buNone/>
-              <a:defRPr sz="2000"/>
+              <a:defRPr sz="2100"/>
             </a:lvl6pPr>
-            <a:lvl7pPr marL="2743200" indent="0">
+            <a:lvl7pPr marL="2880360" indent="0">
               <a:buNone/>
-              <a:defRPr sz="2000"/>
+              <a:defRPr sz="2100"/>
             </a:lvl7pPr>
-            <a:lvl8pPr marL="3200400" indent="0">
+            <a:lvl8pPr marL="3360420" indent="0">
               <a:buNone/>
-              <a:defRPr sz="2000"/>
+              <a:defRPr sz="2100"/>
             </a:lvl8pPr>
-            <a:lvl9pPr marL="3657600" indent="0">
+            <a:lvl9pPr marL="3840480" indent="0">
               <a:buNone/>
-              <a:defRPr sz="2000"/>
+              <a:defRPr sz="2100"/>
             </a:lvl9pPr>
           </a:lstStyle>
           <a:p>
@@ -7004,8 +7446,8 @@
         </p:nvSpPr>
         <p:spPr>
           <a:xfrm>
-            <a:off x="550863" y="1776195"/>
-            <a:ext cx="4500562" cy="4532530"/>
+            <a:off x="578406" y="2486673"/>
+            <a:ext cx="4725590" cy="6345542"/>
           </a:xfrm>
         </p:spPr>
         <p:txBody>
@@ -7013,39 +7455,39 @@
           <a:lstStyle>
             <a:lvl1pPr marL="0" indent="0">
               <a:buNone/>
-              <a:defRPr sz="1600"/>
+              <a:defRPr sz="1680"/>
             </a:lvl1pPr>
-            <a:lvl2pPr marL="457200" indent="0">
+            <a:lvl2pPr marL="480060" indent="0">
               <a:buNone/>
-              <a:defRPr sz="1400"/>
+              <a:defRPr sz="1470"/>
             </a:lvl2pPr>
-            <a:lvl3pPr marL="914400" indent="0">
+            <a:lvl3pPr marL="960120" indent="0">
               <a:buNone/>
-              <a:defRPr sz="1200"/>
+              <a:defRPr sz="1260"/>
             </a:lvl3pPr>
-            <a:lvl4pPr marL="1371600" indent="0">
+            <a:lvl4pPr marL="1440180" indent="0">
               <a:buNone/>
-              <a:defRPr sz="1000"/>
+              <a:defRPr sz="1050"/>
             </a:lvl4pPr>
-            <a:lvl5pPr marL="1828800" indent="0">
+            <a:lvl5pPr marL="1920240" indent="0">
               <a:buNone/>
-              <a:defRPr sz="1000"/>
+              <a:defRPr sz="1050"/>
             </a:lvl5pPr>
-            <a:lvl6pPr marL="2286000" indent="0">
+            <a:lvl6pPr marL="2400300" indent="0">
               <a:buNone/>
-              <a:defRPr sz="1000"/>
+              <a:defRPr sz="1050"/>
             </a:lvl6pPr>
-            <a:lvl7pPr marL="2743200" indent="0">
+            <a:lvl7pPr marL="2880360" indent="0">
               <a:buNone/>
-              <a:defRPr sz="1000"/>
+              <a:defRPr sz="1050"/>
             </a:lvl7pPr>
-            <a:lvl8pPr marL="3200400" indent="0">
+            <a:lvl8pPr marL="3360420" indent="0">
               <a:buNone/>
-              <a:defRPr sz="1000"/>
+              <a:defRPr sz="1050"/>
             </a:lvl8pPr>
-            <a:lvl9pPr marL="3657600" indent="0">
+            <a:lvl9pPr marL="3840480" indent="0">
               <a:buNone/>
-              <a:defRPr sz="1000"/>
+              <a:defRPr sz="1050"/>
             </a:lvl9pPr>
           </a:lstStyle>
           <a:p>
@@ -7080,7 +7522,7 @@
           <a:p>
             <a:fld id="{E50BC9E2-CB44-4C05-9BB5-496C18A241E0}" type="datetime2">
               <a:rPr lang="en-US" smtClean="0"/>
-              <a:t>Monday, March 30, 2026</a:t>
+              <a:t>Monday, April 13, 2026</a:t>
             </a:fld>
             <a:endParaRPr lang="en-US"/>
           </a:p>
@@ -7196,8 +7638,8 @@
         </p:nvSpPr>
         <p:spPr>
           <a:xfrm>
-            <a:off x="550863" y="550800"/>
-            <a:ext cx="11090275" cy="1333057"/>
+            <a:off x="578407" y="771121"/>
+            <a:ext cx="11644789" cy="1866280"/>
           </a:xfrm>
           <a:prstGeom prst="rect">
             <a:avLst/>
@@ -7240,8 +7682,8 @@
         </p:nvSpPr>
         <p:spPr>
           <a:xfrm>
-            <a:off x="550863" y="2113862"/>
-            <a:ext cx="11091600" cy="3978963"/>
+            <a:off x="578406" y="2959408"/>
+            <a:ext cx="11646180" cy="5570548"/>
           </a:xfrm>
           <a:prstGeom prst="rect">
             <a:avLst/>
@@ -7308,8 +7750,8 @@
         </p:nvSpPr>
         <p:spPr>
           <a:xfrm>
-            <a:off x="550863" y="6507212"/>
-            <a:ext cx="2628900" cy="153888"/>
+            <a:off x="578406" y="9145106"/>
+            <a:ext cx="2760345" cy="145424"/>
           </a:xfrm>
           <a:prstGeom prst="rect">
             <a:avLst/>
@@ -7321,7 +7763,7 @@
           </a:bodyPr>
           <a:lstStyle>
             <a:lvl1pPr algn="l">
-              <a:defRPr sz="900">
+              <a:defRPr sz="945">
                 <a:solidFill>
                   <a:schemeClr val="tx1">
                     <a:alpha val="80000"/>
@@ -7333,7 +7775,7 @@
           <a:p>
             <a:fld id="{246CB39B-5F4C-4A7E-9BE3-AAFD45576D16}" type="datetime2">
               <a:rPr lang="en-US" smtClean="0"/>
-              <a:t>Monday, March 30, 2026</a:t>
+              <a:t>Monday, April 13, 2026</a:t>
             </a:fld>
             <a:endParaRPr lang="en-US" dirty="0"/>
           </a:p>
@@ -7357,8 +7799,8 @@
         </p:nvSpPr>
         <p:spPr>
           <a:xfrm>
-            <a:off x="3359150" y="6507212"/>
-            <a:ext cx="6379210" cy="153888"/>
+            <a:off x="3527107" y="9145106"/>
+            <a:ext cx="6698171" cy="145424"/>
           </a:xfrm>
           <a:prstGeom prst="rect">
             <a:avLst/>
@@ -7370,7 +7812,7 @@
           </a:bodyPr>
           <a:lstStyle>
             <a:lvl1pPr algn="l">
-              <a:defRPr sz="900">
+              <a:defRPr sz="945">
                 <a:solidFill>
                   <a:schemeClr val="tx1">
                     <a:alpha val="80000"/>
@@ -7406,8 +7848,8 @@
         </p:nvSpPr>
         <p:spPr>
           <a:xfrm>
-            <a:off x="9948863" y="6507212"/>
-            <a:ext cx="1692274" cy="153888"/>
+            <a:off x="10446306" y="9145106"/>
+            <a:ext cx="1776888" cy="145424"/>
           </a:xfrm>
           <a:prstGeom prst="rect">
             <a:avLst/>
@@ -7419,7 +7861,7 @@
           </a:bodyPr>
           <a:lstStyle>
             <a:lvl1pPr algn="r">
-              <a:defRPr sz="900">
+              <a:defRPr sz="945">
                 <a:solidFill>
                   <a:schemeClr val="tx1">
                     <a:alpha val="80000"/>
@@ -7462,7 +7904,7 @@
   <p:hf sldNum="0" hdr="0" ftr="0" dt="0"/>
   <p:txStyles>
     <p:titleStyle>
-      <a:lvl1pPr algn="l" defTabSz="914400" rtl="0" eaLnBrk="1" latinLnBrk="0" hangingPunct="1">
+      <a:lvl1pPr algn="l" defTabSz="960120" rtl="0" eaLnBrk="1" latinLnBrk="0" hangingPunct="1">
         <a:lnSpc>
           <a:spcPct val="100000"/>
         </a:lnSpc>
@@ -7470,7 +7912,7 @@
           <a:spcPct val="0"/>
         </a:spcBef>
         <a:buNone/>
-        <a:defRPr lang="en-US" sz="4800" kern="1200" dirty="0">
+        <a:defRPr lang="en-US" sz="5040" kern="1200" dirty="0">
           <a:solidFill>
             <a:schemeClr val="tx1"/>
           </a:solidFill>
@@ -7481,19 +7923,19 @@
       </a:lvl1pPr>
     </p:titleStyle>
     <p:bodyStyle>
-      <a:lvl1pPr marL="228600" indent="-228600" algn="l" defTabSz="914400" rtl="0" eaLnBrk="1" latinLnBrk="0" hangingPunct="1">
+      <a:lvl1pPr marL="240030" indent="-240030" algn="l" defTabSz="960120" rtl="0" eaLnBrk="1" latinLnBrk="0" hangingPunct="1">
         <a:lnSpc>
           <a:spcPct val="110000"/>
         </a:lnSpc>
         <a:spcBef>
-          <a:spcPts val="1000"/>
+          <a:spcPts val="1050"/>
         </a:spcBef>
         <a:spcAft>
-          <a:spcPts val="800"/>
+          <a:spcPts val="840"/>
         </a:spcAft>
         <a:buFont typeface="Arial" panose="020B0604020202020204" pitchFamily="34" charset="0"/>
         <a:buChar char="•"/>
-        <a:defRPr sz="2000" kern="1200">
+        <a:defRPr sz="2100" kern="1200">
           <a:solidFill>
             <a:schemeClr val="tx1">
               <a:alpha val="60000"/>
@@ -7504,19 +7946,19 @@
           <a:cs typeface="+mn-cs"/>
         </a:defRPr>
       </a:lvl1pPr>
-      <a:lvl2pPr marL="685800" indent="-228600" algn="l" defTabSz="914400" rtl="0" eaLnBrk="1" latinLnBrk="0" hangingPunct="1">
+      <a:lvl2pPr marL="720090" indent="-240030" algn="l" defTabSz="960120" rtl="0" eaLnBrk="1" latinLnBrk="0" hangingPunct="1">
         <a:lnSpc>
           <a:spcPct val="110000"/>
         </a:lnSpc>
         <a:spcBef>
-          <a:spcPts val="500"/>
+          <a:spcPts val="525"/>
         </a:spcBef>
         <a:spcAft>
-          <a:spcPts val="800"/>
+          <a:spcPts val="840"/>
         </a:spcAft>
         <a:buFont typeface="Arial" panose="020B0604020202020204" pitchFamily="34" charset="0"/>
         <a:buChar char="•"/>
-        <a:defRPr sz="1400" kern="1200">
+        <a:defRPr sz="1470" kern="1200">
           <a:solidFill>
             <a:schemeClr val="tx1">
               <a:alpha val="60000"/>
@@ -7527,19 +7969,19 @@
           <a:cs typeface="+mn-cs"/>
         </a:defRPr>
       </a:lvl2pPr>
-      <a:lvl3pPr marL="1143000" indent="-228600" algn="l" defTabSz="914400" rtl="0" eaLnBrk="1" latinLnBrk="0" hangingPunct="1">
+      <a:lvl3pPr marL="1200150" indent="-240030" algn="l" defTabSz="960120" rtl="0" eaLnBrk="1" latinLnBrk="0" hangingPunct="1">
         <a:lnSpc>
           <a:spcPct val="110000"/>
         </a:lnSpc>
         <a:spcBef>
-          <a:spcPts val="500"/>
+          <a:spcPts val="525"/>
         </a:spcBef>
         <a:spcAft>
-          <a:spcPts val="800"/>
+          <a:spcPts val="840"/>
         </a:spcAft>
         <a:buFont typeface="Arial" panose="020B0604020202020204" pitchFamily="34" charset="0"/>
         <a:buChar char="•"/>
-        <a:defRPr sz="1400" kern="1200">
+        <a:defRPr sz="1470" kern="1200">
           <a:solidFill>
             <a:schemeClr val="tx1">
               <a:alpha val="60000"/>
@@ -7550,19 +7992,19 @@
           <a:cs typeface="+mn-cs"/>
         </a:defRPr>
       </a:lvl3pPr>
-      <a:lvl4pPr marL="1600200" indent="-228600" algn="l" defTabSz="914400" rtl="0" eaLnBrk="1" latinLnBrk="0" hangingPunct="1">
+      <a:lvl4pPr marL="1680210" indent="-240030" algn="l" defTabSz="960120" rtl="0" eaLnBrk="1" latinLnBrk="0" hangingPunct="1">
         <a:lnSpc>
           <a:spcPct val="110000"/>
         </a:lnSpc>
         <a:spcBef>
-          <a:spcPts val="500"/>
+          <a:spcPts val="525"/>
         </a:spcBef>
         <a:spcAft>
-          <a:spcPts val="800"/>
+          <a:spcPts val="840"/>
         </a:spcAft>
         <a:buFont typeface="Arial" panose="020B0604020202020204" pitchFamily="34" charset="0"/>
         <a:buChar char="•"/>
-        <a:defRPr sz="1400" kern="1200">
+        <a:defRPr sz="1470" kern="1200">
           <a:solidFill>
             <a:schemeClr val="tx1">
               <a:alpha val="60000"/>
@@ -7573,19 +8015,19 @@
           <a:cs typeface="+mn-cs"/>
         </a:defRPr>
       </a:lvl4pPr>
-      <a:lvl5pPr marL="2057400" indent="-228600" algn="l" defTabSz="914400" rtl="0" eaLnBrk="1" latinLnBrk="0" hangingPunct="1">
+      <a:lvl5pPr marL="2160270" indent="-240030" algn="l" defTabSz="960120" rtl="0" eaLnBrk="1" latinLnBrk="0" hangingPunct="1">
         <a:lnSpc>
           <a:spcPct val="110000"/>
         </a:lnSpc>
         <a:spcBef>
-          <a:spcPts val="500"/>
+          <a:spcPts val="525"/>
         </a:spcBef>
         <a:spcAft>
-          <a:spcPts val="800"/>
+          <a:spcPts val="840"/>
         </a:spcAft>
         <a:buFont typeface="Arial" panose="020B0604020202020204" pitchFamily="34" charset="0"/>
         <a:buChar char="•"/>
-        <a:defRPr sz="1400" kern="1200">
+        <a:defRPr sz="1470" kern="1200">
           <a:solidFill>
             <a:schemeClr val="tx1">
               <a:alpha val="60000"/>
@@ -7596,16 +8038,16 @@
           <a:cs typeface="+mn-cs"/>
         </a:defRPr>
       </a:lvl5pPr>
-      <a:lvl6pPr marL="2514600" indent="-228600" algn="l" defTabSz="914400" rtl="0" eaLnBrk="1" latinLnBrk="0" hangingPunct="1">
+      <a:lvl6pPr marL="2640330" indent="-240030" algn="l" defTabSz="960120" rtl="0" eaLnBrk="1" latinLnBrk="0" hangingPunct="1">
         <a:lnSpc>
           <a:spcPct val="90000"/>
         </a:lnSpc>
         <a:spcBef>
-          <a:spcPts val="500"/>
+          <a:spcPts val="525"/>
         </a:spcBef>
         <a:buFont typeface="Arial" panose="020B0604020202020204" pitchFamily="34" charset="0"/>
         <a:buChar char="•"/>
-        <a:defRPr sz="1800" kern="1200">
+        <a:defRPr sz="1890" kern="1200">
           <a:solidFill>
             <a:schemeClr val="tx1"/>
           </a:solidFill>
@@ -7614,16 +8056,16 @@
           <a:cs typeface="+mn-cs"/>
         </a:defRPr>
       </a:lvl6pPr>
-      <a:lvl7pPr marL="2971800" indent="-228600" algn="l" defTabSz="914400" rtl="0" eaLnBrk="1" latinLnBrk="0" hangingPunct="1">
+      <a:lvl7pPr marL="3120390" indent="-240030" algn="l" defTabSz="960120" rtl="0" eaLnBrk="1" latinLnBrk="0" hangingPunct="1">
         <a:lnSpc>
           <a:spcPct val="90000"/>
         </a:lnSpc>
         <a:spcBef>
-          <a:spcPts val="500"/>
+          <a:spcPts val="525"/>
         </a:spcBef>
         <a:buFont typeface="Arial" panose="020B0604020202020204" pitchFamily="34" charset="0"/>
         <a:buChar char="•"/>
-        <a:defRPr sz="1800" kern="1200">
+        <a:defRPr sz="1890" kern="1200">
           <a:solidFill>
             <a:schemeClr val="tx1"/>
           </a:solidFill>
@@ -7632,16 +8074,16 @@
           <a:cs typeface="+mn-cs"/>
         </a:defRPr>
       </a:lvl7pPr>
-      <a:lvl8pPr marL="3429000" indent="-228600" algn="l" defTabSz="914400" rtl="0" eaLnBrk="1" latinLnBrk="0" hangingPunct="1">
+      <a:lvl8pPr marL="3600450" indent="-240030" algn="l" defTabSz="960120" rtl="0" eaLnBrk="1" latinLnBrk="0" hangingPunct="1">
         <a:lnSpc>
           <a:spcPct val="90000"/>
         </a:lnSpc>
         <a:spcBef>
-          <a:spcPts val="500"/>
+          <a:spcPts val="525"/>
         </a:spcBef>
         <a:buFont typeface="Arial" panose="020B0604020202020204" pitchFamily="34" charset="0"/>
         <a:buChar char="•"/>
-        <a:defRPr sz="1800" kern="1200">
+        <a:defRPr sz="1890" kern="1200">
           <a:solidFill>
             <a:schemeClr val="tx1"/>
           </a:solidFill>
@@ -7650,16 +8092,16 @@
           <a:cs typeface="+mn-cs"/>
         </a:defRPr>
       </a:lvl8pPr>
-      <a:lvl9pPr marL="3886200" indent="-228600" algn="l" defTabSz="914400" rtl="0" eaLnBrk="1" latinLnBrk="0" hangingPunct="1">
+      <a:lvl9pPr marL="4080510" indent="-240030" algn="l" defTabSz="960120" rtl="0" eaLnBrk="1" latinLnBrk="0" hangingPunct="1">
         <a:lnSpc>
           <a:spcPct val="90000"/>
         </a:lnSpc>
         <a:spcBef>
-          <a:spcPts val="500"/>
+          <a:spcPts val="525"/>
         </a:spcBef>
         <a:buFont typeface="Arial" panose="020B0604020202020204" pitchFamily="34" charset="0"/>
         <a:buChar char="•"/>
-        <a:defRPr sz="1800" kern="1200">
+        <a:defRPr sz="1890" kern="1200">
           <a:solidFill>
             <a:schemeClr val="tx1"/>
           </a:solidFill>
@@ -7673,8 +8115,8 @@
       <a:defPPr>
         <a:defRPr lang="en-US"/>
       </a:defPPr>
-      <a:lvl1pPr marL="0" algn="l" defTabSz="914400" rtl="0" eaLnBrk="1" latinLnBrk="0" hangingPunct="1">
-        <a:defRPr sz="1800" kern="1200">
+      <a:lvl1pPr marL="0" algn="l" defTabSz="960120" rtl="0" eaLnBrk="1" latinLnBrk="0" hangingPunct="1">
+        <a:defRPr sz="1890" kern="1200">
           <a:solidFill>
             <a:schemeClr val="tx1"/>
           </a:solidFill>
@@ -7683,8 +8125,8 @@
           <a:cs typeface="+mn-cs"/>
         </a:defRPr>
       </a:lvl1pPr>
-      <a:lvl2pPr marL="457200" algn="l" defTabSz="914400" rtl="0" eaLnBrk="1" latinLnBrk="0" hangingPunct="1">
-        <a:defRPr sz="1800" kern="1200">
+      <a:lvl2pPr marL="480060" algn="l" defTabSz="960120" rtl="0" eaLnBrk="1" latinLnBrk="0" hangingPunct="1">
+        <a:defRPr sz="1890" kern="1200">
           <a:solidFill>
             <a:schemeClr val="tx1"/>
           </a:solidFill>
@@ -7693,8 +8135,8 @@
           <a:cs typeface="+mn-cs"/>
         </a:defRPr>
       </a:lvl2pPr>
-      <a:lvl3pPr marL="914400" algn="l" defTabSz="914400" rtl="0" eaLnBrk="1" latinLnBrk="0" hangingPunct="1">
-        <a:defRPr sz="1800" kern="1200">
+      <a:lvl3pPr marL="960120" algn="l" defTabSz="960120" rtl="0" eaLnBrk="1" latinLnBrk="0" hangingPunct="1">
+        <a:defRPr sz="1890" kern="1200">
           <a:solidFill>
             <a:schemeClr val="tx1"/>
           </a:solidFill>
@@ -7703,8 +8145,8 @@
           <a:cs typeface="+mn-cs"/>
         </a:defRPr>
       </a:lvl3pPr>
-      <a:lvl4pPr marL="1371600" algn="l" defTabSz="914400" rtl="0" eaLnBrk="1" latinLnBrk="0" hangingPunct="1">
-        <a:defRPr sz="1800" kern="1200">
+      <a:lvl4pPr marL="1440180" algn="l" defTabSz="960120" rtl="0" eaLnBrk="1" latinLnBrk="0" hangingPunct="1">
+        <a:defRPr sz="1890" kern="1200">
           <a:solidFill>
             <a:schemeClr val="tx1"/>
           </a:solidFill>
@@ -7713,8 +8155,8 @@
           <a:cs typeface="+mn-cs"/>
         </a:defRPr>
       </a:lvl4pPr>
-      <a:lvl5pPr marL="1828800" algn="l" defTabSz="914400" rtl="0" eaLnBrk="1" latinLnBrk="0" hangingPunct="1">
-        <a:defRPr sz="1800" kern="1200">
+      <a:lvl5pPr marL="1920240" algn="l" defTabSz="960120" rtl="0" eaLnBrk="1" latinLnBrk="0" hangingPunct="1">
+        <a:defRPr sz="1890" kern="1200">
           <a:solidFill>
             <a:schemeClr val="tx1"/>
           </a:solidFill>
@@ -7723,8 +8165,8 @@
           <a:cs typeface="+mn-cs"/>
         </a:defRPr>
       </a:lvl5pPr>
-      <a:lvl6pPr marL="2286000" algn="l" defTabSz="914400" rtl="0" eaLnBrk="1" latinLnBrk="0" hangingPunct="1">
-        <a:defRPr sz="1800" kern="1200">
+      <a:lvl6pPr marL="2400300" algn="l" defTabSz="960120" rtl="0" eaLnBrk="1" latinLnBrk="0" hangingPunct="1">
+        <a:defRPr sz="1890" kern="1200">
           <a:solidFill>
             <a:schemeClr val="tx1"/>
           </a:solidFill>
@@ -7733,8 +8175,8 @@
           <a:cs typeface="+mn-cs"/>
         </a:defRPr>
       </a:lvl6pPr>
-      <a:lvl7pPr marL="2743200" algn="l" defTabSz="914400" rtl="0" eaLnBrk="1" latinLnBrk="0" hangingPunct="1">
-        <a:defRPr sz="1800" kern="1200">
+      <a:lvl7pPr marL="2880360" algn="l" defTabSz="960120" rtl="0" eaLnBrk="1" latinLnBrk="0" hangingPunct="1">
+        <a:defRPr sz="1890" kern="1200">
           <a:solidFill>
             <a:schemeClr val="tx1"/>
           </a:solidFill>
@@ -7743,8 +8185,8 @@
           <a:cs typeface="+mn-cs"/>
         </a:defRPr>
       </a:lvl7pPr>
-      <a:lvl8pPr marL="3200400" algn="l" defTabSz="914400" rtl="0" eaLnBrk="1" latinLnBrk="0" hangingPunct="1">
-        <a:defRPr sz="1800" kern="1200">
+      <a:lvl8pPr marL="3360420" algn="l" defTabSz="960120" rtl="0" eaLnBrk="1" latinLnBrk="0" hangingPunct="1">
+        <a:defRPr sz="1890" kern="1200">
           <a:solidFill>
             <a:schemeClr val="tx1"/>
           </a:solidFill>
@@ -7753,8 +8195,8 @@
           <a:cs typeface="+mn-cs"/>
         </a:defRPr>
       </a:lvl8pPr>
-      <a:lvl9pPr marL="3657600" algn="l" defTabSz="914400" rtl="0" eaLnBrk="1" latinLnBrk="0" hangingPunct="1">
-        <a:defRPr sz="1800" kern="1200">
+      <a:lvl9pPr marL="3840480" algn="l" defTabSz="960120" rtl="0" eaLnBrk="1" latinLnBrk="0" hangingPunct="1">
+        <a:defRPr sz="1890" kern="1200">
           <a:solidFill>
             <a:schemeClr val="tx1"/>
           </a:solidFill>
@@ -7818,8 +8260,8 @@
         </p:nvSpPr>
         <p:spPr>
           <a:xfrm>
-            <a:off x="0" y="0"/>
-            <a:ext cx="12192000" cy="6858000"/>
+            <a:off x="0" y="1200150"/>
+            <a:ext cx="12801600" cy="7200900"/>
           </a:xfrm>
           <a:prstGeom prst="rect">
             <a:avLst/>
@@ -7865,10 +8307,40 @@
           <a:lstStyle/>
           <a:p>
             <a:pPr algn="ctr"/>
-            <a:endParaRPr lang="en-US"/>
-          </a:p>
-        </p:txBody>
-      </p:sp>
+            <a:endParaRPr lang="en-US" sz="2223"/>
+          </a:p>
+        </p:txBody>
+      </p:sp>
+      <p:pic>
+        <p:nvPicPr>
+          <p:cNvPr id="4" name="Picture 3">
+            <a:extLst>
+              <a:ext uri="{FF2B5EF4-FFF2-40B4-BE49-F238E27FC236}">
+                <a16:creationId xmlns:a16="http://schemas.microsoft.com/office/drawing/2014/main" id="{9F26224E-E75A-4171-C2B5-EA577C479A24}"/>
+              </a:ext>
+            </a:extLst>
+          </p:cNvPr>
+          <p:cNvPicPr>
+            <a:picLocks noChangeAspect="1"/>
+          </p:cNvPicPr>
+          <p:nvPr/>
+        </p:nvPicPr>
+        <p:blipFill>
+          <a:blip r:embed="rId3"/>
+          <a:stretch>
+            <a:fillRect/>
+          </a:stretch>
+        </p:blipFill>
+        <p:spPr>
+          <a:xfrm>
+            <a:off x="-4446" y="0"/>
+            <a:ext cx="12801600" cy="8687651"/>
+          </a:xfrm>
+          <a:prstGeom prst="rect">
+            <a:avLst/>
+          </a:prstGeom>
+        </p:spPr>
+      </p:pic>
       <p:sp>
         <p:nvSpPr>
           <p:cNvPr id="2" name="Title 1">
@@ -7887,8 +8359,8 @@
         </p:nvSpPr>
         <p:spPr>
           <a:xfrm>
-            <a:off x="2728955" y="5990793"/>
-            <a:ext cx="6573520" cy="867207"/>
+            <a:off x="2859907" y="8687652"/>
+            <a:ext cx="6902196" cy="910567"/>
           </a:xfrm>
         </p:spPr>
         <p:txBody>
@@ -7903,23 +8375,23 @@
               </a:lnSpc>
             </a:pPr>
             <a:r>
-              <a:rPr lang="en-GB" sz="1800" dirty="0"/>
+              <a:rPr lang="en-GB" sz="1890" dirty="0"/>
               <a:t>Michael Hooper</a:t>
             </a:r>
             <a:br>
-              <a:rPr lang="en-GB" sz="1800" dirty="0"/>
+              <a:rPr lang="en-GB" sz="1890" dirty="0"/>
             </a:br>
             <a:r>
-              <a:rPr lang="en-GB" sz="1800" dirty="0">
-                <a:hlinkClick r:id="rId2"/>
+              <a:rPr lang="en-GB" sz="1890" dirty="0">
+                <a:hlinkClick r:id="rId4"/>
               </a:rPr>
-              <a:t>michael.hooper@students.Plymouth.ac.uk</a:t>
+              <a:t>michael.hooper@students.plymouth.ac.uk</a:t>
             </a:r>
             <a:br>
-              <a:rPr lang="en-GB" sz="1800" dirty="0"/>
+              <a:rPr lang="en-GB" sz="1890" dirty="0"/>
             </a:br>
             <a:r>
-              <a:rPr lang="en-GB" sz="1800" dirty="0"/>
+              <a:rPr lang="en-GB" sz="1890" dirty="0"/>
               <a:t>BSc (Hons) Computer Science (Games Development)</a:t>
             </a:r>
           </a:p>
@@ -7950,8 +8422,8 @@
         </p:nvSpPr>
         <p:spPr>
           <a:xfrm>
-            <a:off x="0" y="5773729"/>
-            <a:ext cx="12192000" cy="1084271"/>
+            <a:off x="0" y="7262566"/>
+            <a:ext cx="12801600" cy="1138485"/>
           </a:xfrm>
           <a:prstGeom prst="rect">
             <a:avLst/>
@@ -7997,7 +8469,7 @@
           <a:lstStyle/>
           <a:p>
             <a:pPr algn="ctr"/>
-            <a:endParaRPr lang="en-US"/>
+            <a:endParaRPr lang="en-US" sz="2223"/>
           </a:p>
         </p:txBody>
       </p:sp>
@@ -8007,66 +8479,6 @@
             <a:extLst>
               <a:ext uri="{FF2B5EF4-FFF2-40B4-BE49-F238E27FC236}">
                 <a16:creationId xmlns:a16="http://schemas.microsoft.com/office/drawing/2014/main" id="{F4FFF2E3-AB4B-AFD4-0596-7A766066BD52}"/>
-              </a:ext>
-            </a:extLst>
-          </p:cNvPr>
-          <p:cNvPicPr>
-            <a:picLocks noChangeAspect="1"/>
-          </p:cNvPicPr>
-          <p:nvPr/>
-        </p:nvPicPr>
-        <p:blipFill>
-          <a:blip r:embed="rId3"/>
-          <a:stretch>
-            <a:fillRect/>
-          </a:stretch>
-        </p:blipFill>
-        <p:spPr>
-          <a:xfrm>
-            <a:off x="10532529" y="5990792"/>
-            <a:ext cx="1659472" cy="867208"/>
-          </a:xfrm>
-          <a:prstGeom prst="rect">
-            <a:avLst/>
-          </a:prstGeom>
-        </p:spPr>
-      </p:pic>
-      <p:pic>
-        <p:nvPicPr>
-          <p:cNvPr id="7" name="Picture 6">
-            <a:extLst>
-              <a:ext uri="{FF2B5EF4-FFF2-40B4-BE49-F238E27FC236}">
-                <a16:creationId xmlns:a16="http://schemas.microsoft.com/office/drawing/2014/main" id="{9BE86DEA-2F0A-1EF0-0B84-0240C8A1A3C7}"/>
-              </a:ext>
-            </a:extLst>
-          </p:cNvPr>
-          <p:cNvPicPr>
-            <a:picLocks noChangeAspect="1"/>
-          </p:cNvPicPr>
-          <p:nvPr/>
-        </p:nvPicPr>
-        <p:blipFill>
-          <a:blip r:embed="rId4"/>
-          <a:stretch>
-            <a:fillRect/>
-          </a:stretch>
-        </p:blipFill>
-        <p:spPr>
-          <a:xfrm>
-            <a:off x="9622675" y="5882260"/>
-            <a:ext cx="1084271" cy="1084271"/>
-          </a:xfrm>
-          <a:prstGeom prst="rect">
-            <a:avLst/>
-          </a:prstGeom>
-        </p:spPr>
-      </p:pic>
-      <p:pic>
-        <p:nvPicPr>
-          <p:cNvPr id="9" name="Picture 8">
-            <a:extLst>
-              <a:ext uri="{FF2B5EF4-FFF2-40B4-BE49-F238E27FC236}">
-                <a16:creationId xmlns:a16="http://schemas.microsoft.com/office/drawing/2014/main" id="{0CC5208E-FE56-C9A6-3684-094CEAB498DD}"/>
               </a:ext>
             </a:extLst>
           </p:cNvPr>
@@ -8083,8 +8495,8 @@
         </p:blipFill>
         <p:spPr>
           <a:xfrm>
-            <a:off x="61794" y="6064132"/>
-            <a:ext cx="2346961" cy="720528"/>
+            <a:off x="11054708" y="8687651"/>
+            <a:ext cx="1742446" cy="910568"/>
           </a:xfrm>
           <a:prstGeom prst="rect">
             <a:avLst/>
@@ -8093,10 +8505,10 @@
       </p:pic>
       <p:pic>
         <p:nvPicPr>
-          <p:cNvPr id="12" name="Picture 11">
-            <a:extLst>
-              <a:ext uri="{FF2B5EF4-FFF2-40B4-BE49-F238E27FC236}">
-                <a16:creationId xmlns:a16="http://schemas.microsoft.com/office/drawing/2014/main" id="{5790FD15-1416-D5DD-7D31-5ED12D97098E}"/>
+          <p:cNvPr id="7" name="Picture 6">
+            <a:extLst>
+              <a:ext uri="{FF2B5EF4-FFF2-40B4-BE49-F238E27FC236}">
+                <a16:creationId xmlns:a16="http://schemas.microsoft.com/office/drawing/2014/main" id="{9BE86DEA-2F0A-1EF0-0B84-0240C8A1A3C7}"/>
               </a:ext>
             </a:extLst>
           </p:cNvPr>
@@ -8107,15 +8519,14 @@
         </p:nvPicPr>
         <p:blipFill>
           <a:blip r:embed="rId6"/>
-          <a:srcRect t="12296"/>
           <a:stretch>
             <a:fillRect/>
           </a:stretch>
         </p:blipFill>
         <p:spPr>
           <a:xfrm>
-            <a:off x="0" y="0"/>
-            <a:ext cx="12192000" cy="5990792"/>
+            <a:off x="10001249" y="8573692"/>
+            <a:ext cx="1138485" cy="1138485"/>
           </a:xfrm>
           <a:prstGeom prst="rect">
             <a:avLst/>
@@ -8124,10 +8535,10 @@
       </p:pic>
       <p:pic>
         <p:nvPicPr>
-          <p:cNvPr id="16" name="Picture 15">
-            <a:extLst>
-              <a:ext uri="{FF2B5EF4-FFF2-40B4-BE49-F238E27FC236}">
-                <a16:creationId xmlns:a16="http://schemas.microsoft.com/office/drawing/2014/main" id="{23FE44DE-BC03-61CC-5886-3CA9273730E3}"/>
+          <p:cNvPr id="9" name="Picture 8">
+            <a:extLst>
+              <a:ext uri="{FF2B5EF4-FFF2-40B4-BE49-F238E27FC236}">
+                <a16:creationId xmlns:a16="http://schemas.microsoft.com/office/drawing/2014/main" id="{0CC5208E-FE56-C9A6-3684-094CEAB498DD}"/>
               </a:ext>
             </a:extLst>
           </p:cNvPr>
@@ -8144,8 +8555,8 @@
         </p:blipFill>
         <p:spPr>
           <a:xfrm>
-            <a:off x="-1" y="0"/>
-            <a:ext cx="818969" cy="1400173"/>
+            <a:off x="182115" y="8764658"/>
+            <a:ext cx="2464309" cy="756554"/>
           </a:xfrm>
           <a:prstGeom prst="rect">
             <a:avLst/>
@@ -8154,10 +8565,10 @@
       </p:pic>
       <p:pic>
         <p:nvPicPr>
-          <p:cNvPr id="20" name="Picture 19">
-            <a:extLst>
-              <a:ext uri="{FF2B5EF4-FFF2-40B4-BE49-F238E27FC236}">
-                <a16:creationId xmlns:a16="http://schemas.microsoft.com/office/drawing/2014/main" id="{F73AA51E-4923-CDD1-4133-F1184B21179B}"/>
+          <p:cNvPr id="16" name="Picture 15">
+            <a:extLst>
+              <a:ext uri="{FF2B5EF4-FFF2-40B4-BE49-F238E27FC236}">
+                <a16:creationId xmlns:a16="http://schemas.microsoft.com/office/drawing/2014/main" id="{23FE44DE-BC03-61CC-5886-3CA9273730E3}"/>
               </a:ext>
             </a:extLst>
           </p:cNvPr>
@@ -8174,97 +8585,37 @@
         </p:blipFill>
         <p:spPr>
           <a:xfrm>
-            <a:off x="0" y="1398369"/>
-            <a:ext cx="818968" cy="1414237"/>
+            <a:off x="-3" y="3886763"/>
+            <a:ext cx="1417320" cy="2417685"/>
           </a:xfrm>
           <a:prstGeom prst="rect">
             <a:avLst/>
           </a:prstGeom>
         </p:spPr>
       </p:pic>
-      <p:pic>
-        <p:nvPicPr>
-          <p:cNvPr id="27" name="Picture 26">
-            <a:extLst>
-              <a:ext uri="{FF2B5EF4-FFF2-40B4-BE49-F238E27FC236}">
-                <a16:creationId xmlns:a16="http://schemas.microsoft.com/office/drawing/2014/main" id="{1205FD5D-DED8-455E-54BB-2BC28036D3CF}"/>
-              </a:ext>
-            </a:extLst>
-          </p:cNvPr>
-          <p:cNvPicPr>
-            <a:picLocks noChangeAspect="1"/>
-          </p:cNvPicPr>
+      <p:sp>
+        <p:nvSpPr>
+          <p:cNvPr id="30" name="Rectangle 29">
+            <a:extLst>
+              <a:ext uri="{FF2B5EF4-FFF2-40B4-BE49-F238E27FC236}">
+                <a16:creationId xmlns:a16="http://schemas.microsoft.com/office/drawing/2014/main" id="{8382977B-C19A-52B0-757B-D1D7D14217C6}"/>
+              </a:ext>
+            </a:extLst>
+          </p:cNvPr>
+          <p:cNvSpPr/>
           <p:nvPr/>
-        </p:nvPicPr>
-        <p:blipFill>
-          <a:blip r:embed="rId9"/>
-          <a:stretch>
-            <a:fillRect/>
-          </a:stretch>
-        </p:blipFill>
+        </p:nvSpPr>
         <p:spPr>
           <a:xfrm>
-            <a:off x="0" y="2812606"/>
-            <a:ext cx="818968" cy="1400171"/>
-          </a:xfrm>
-          <a:prstGeom prst="rect">
-            <a:avLst/>
-          </a:prstGeom>
-        </p:spPr>
-      </p:pic>
-      <p:pic>
-        <p:nvPicPr>
-          <p:cNvPr id="29" name="Picture 28">
-            <a:extLst>
-              <a:ext uri="{FF2B5EF4-FFF2-40B4-BE49-F238E27FC236}">
-                <a16:creationId xmlns:a16="http://schemas.microsoft.com/office/drawing/2014/main" id="{660CCF62-1E69-B08F-9E7C-D8E4C6662605}"/>
-              </a:ext>
-            </a:extLst>
-          </p:cNvPr>
-          <p:cNvPicPr>
-            <a:picLocks noChangeAspect="1"/>
-          </p:cNvPicPr>
-          <p:nvPr/>
-        </p:nvPicPr>
-        <p:blipFill>
-          <a:blip r:embed="rId10"/>
-          <a:stretch>
-            <a:fillRect/>
-          </a:stretch>
-        </p:blipFill>
-        <p:spPr>
-          <a:xfrm>
-            <a:off x="1" y="4210975"/>
-            <a:ext cx="820530" cy="1400171"/>
-          </a:xfrm>
-          <a:prstGeom prst="rect">
-            <a:avLst/>
-          </a:prstGeom>
-        </p:spPr>
-      </p:pic>
-      <p:sp>
-        <p:nvSpPr>
-          <p:cNvPr id="30" name="Rectangle 29">
-            <a:extLst>
-              <a:ext uri="{FF2B5EF4-FFF2-40B4-BE49-F238E27FC236}">
-                <a16:creationId xmlns:a16="http://schemas.microsoft.com/office/drawing/2014/main" id="{8382977B-C19A-52B0-757B-D1D7D14217C6}"/>
-              </a:ext>
-            </a:extLst>
-          </p:cNvPr>
-          <p:cNvSpPr/>
-          <p:nvPr/>
-        </p:nvSpPr>
-        <p:spPr>
-          <a:xfrm>
-            <a:off x="2659380" y="1217394"/>
-            <a:ext cx="6865620" cy="1161739"/>
+            <a:off x="2790123" y="964839"/>
+            <a:ext cx="7208901" cy="1254481"/>
           </a:xfrm>
           <a:prstGeom prst="rect">
             <a:avLst/>
           </a:prstGeom>
           <a:solidFill>
             <a:srgbClr val="000000">
-              <a:alpha val="50196"/>
+              <a:alpha val="74902"/>
             </a:srgbClr>
           </a:solidFill>
           <a:ln>
@@ -8296,7 +8647,7 @@
           <a:lstStyle/>
           <a:p>
             <a:pPr algn="ctr"/>
-            <a:endParaRPr lang="en-GB"/>
+            <a:endParaRPr lang="en-GB" sz="2223"/>
           </a:p>
         </p:txBody>
       </p:sp>
@@ -8314,8 +8665,8 @@
         </p:nvSpPr>
         <p:spPr>
           <a:xfrm>
-            <a:off x="2659378" y="1210733"/>
-            <a:ext cx="6865621" cy="1107996"/>
+            <a:off x="2781226" y="957436"/>
+            <a:ext cx="7217798" cy="1261884"/>
           </a:xfrm>
           <a:prstGeom prst="rect">
             <a:avLst/>
@@ -8330,15 +8681,1042 @@
           <a:p>
             <a:pPr algn="ctr"/>
             <a:r>
-              <a:rPr lang="en-GB" u="sng" dirty="0"/>
+              <a:rPr lang="en-GB" sz="2800" u="sng" dirty="0"/>
               <a:t>Summary</a:t>
             </a:r>
           </a:p>
           <a:p>
+            <a:pPr marL="180023" indent="-180023" algn="ctr">
+              <a:buFont typeface="Arial" panose="020B0604020202020204" pitchFamily="34" charset="0"/>
+              <a:buChar char="•"/>
+            </a:pPr>
+            <a:r>
+              <a:rPr lang="en-GB" sz="1600" dirty="0"/>
+              <a:t>Play as a fisherman on the search for the most delicious fish in the land.</a:t>
+            </a:r>
+          </a:p>
+          <a:p>
+            <a:pPr marL="180023" indent="-180023" algn="ctr">
+              <a:buFont typeface="Arial" panose="020B0604020202020204" pitchFamily="34" charset="0"/>
+              <a:buChar char="•"/>
+            </a:pPr>
+            <a:r>
+              <a:rPr lang="en-GB" sz="1600" dirty="0"/>
+              <a:t>Swing around with your trusty fishing rod and throw bait to catch fish.</a:t>
+            </a:r>
+          </a:p>
+          <a:p>
+            <a:pPr marL="180023" indent="-180023" algn="ctr">
+              <a:buFont typeface="Arial" panose="020B0604020202020204" pitchFamily="34" charset="0"/>
+              <a:buChar char="•"/>
+            </a:pPr>
+            <a:r>
+              <a:rPr lang="en-GB" sz="1600" dirty="0"/>
+              <a:t>Master your fishing technique before being tested by challenging bosses.</a:t>
+            </a:r>
+          </a:p>
+        </p:txBody>
+      </p:sp>
+      <p:sp>
+        <p:nvSpPr>
+          <p:cNvPr id="15" name="Rectangle 14">
+            <a:extLst>
+              <a:ext uri="{FF2B5EF4-FFF2-40B4-BE49-F238E27FC236}">
+                <a16:creationId xmlns:a16="http://schemas.microsoft.com/office/drawing/2014/main" id="{C8AAA8A3-093D-F80C-B193-AA48BA551F09}"/>
+              </a:ext>
+            </a:extLst>
+          </p:cNvPr>
+          <p:cNvSpPr/>
+          <p:nvPr/>
+        </p:nvSpPr>
+        <p:spPr>
+          <a:xfrm>
+            <a:off x="-1557" y="2606532"/>
+            <a:ext cx="2809245" cy="1276176"/>
+          </a:xfrm>
+          <a:prstGeom prst="rect">
+            <a:avLst/>
+          </a:prstGeom>
+          <a:solidFill>
+            <a:srgbClr val="000000">
+              <a:alpha val="50196"/>
+            </a:srgbClr>
+          </a:solidFill>
+        </p:spPr>
+        <p:style>
+          <a:lnRef idx="2">
+            <a:schemeClr val="dk1">
+              <a:shade val="15000"/>
+            </a:schemeClr>
+          </a:lnRef>
+          <a:fillRef idx="1">
+            <a:schemeClr val="dk1"/>
+          </a:fillRef>
+          <a:effectRef idx="0">
+            <a:schemeClr val="dk1"/>
+          </a:effectRef>
+          <a:fontRef idx="minor">
+            <a:schemeClr val="lt1"/>
+          </a:fontRef>
+        </p:style>
+        <p:txBody>
+          <a:bodyPr rtlCol="0" anchor="ctr"/>
+          <a:lstStyle/>
+          <a:p>
+            <a:pPr algn="ctr"/>
+            <a:endParaRPr lang="en-GB" sz="2223" dirty="0"/>
+          </a:p>
+        </p:txBody>
+      </p:sp>
+      <p:sp>
+        <p:nvSpPr>
+          <p:cNvPr id="18" name="TextBox 17">
+            <a:extLst>
+              <a:ext uri="{FF2B5EF4-FFF2-40B4-BE49-F238E27FC236}">
+                <a16:creationId xmlns:a16="http://schemas.microsoft.com/office/drawing/2014/main" id="{ED5E1366-ECAF-B043-E534-F9BBB70A2302}"/>
+              </a:ext>
+            </a:extLst>
+          </p:cNvPr>
+          <p:cNvSpPr txBox="1"/>
+          <p:nvPr/>
+        </p:nvSpPr>
+        <p:spPr>
+          <a:xfrm>
+            <a:off x="-13343" y="2623303"/>
+            <a:ext cx="2794569" cy="1261884"/>
+          </a:xfrm>
+          <a:prstGeom prst="rect">
+            <a:avLst/>
+          </a:prstGeom>
+          <a:noFill/>
+        </p:spPr>
+        <p:txBody>
+          <a:bodyPr wrap="square" rtlCol="0">
+            <a:spAutoFit/>
+          </a:bodyPr>
+          <a:lstStyle/>
+          <a:p>
             <a:pPr algn="ctr"/>
             <a:r>
-              <a:rPr lang="en-GB" sz="1200" dirty="0"/>
-              <a:t>Hook, Line and Slinger is a 2d platformer where you play as a sushi chef turned fisherman on the search for the rarest and most delicious fish in the land. Swing through the level with your trusty fishing rod and throw bait at your enemies to catch them and have them for dinner. Master your fishing technique before being tested by challenging boss enemies/delicacies.</a:t>
+              <a:rPr lang="en-GB" sz="2000" u="sng" dirty="0"/>
+              <a:t>Bait</a:t>
+            </a:r>
+          </a:p>
+          <a:p>
+            <a:pPr algn="ctr"/>
+            <a:r>
+              <a:rPr lang="en-GB" sz="1400" dirty="0"/>
+              <a:t>Throughout the game, there are various types of bait that the player can obtain that provide different play patterns.</a:t>
+            </a:r>
+          </a:p>
+        </p:txBody>
+      </p:sp>
+      <p:pic>
+        <p:nvPicPr>
+          <p:cNvPr id="20" name="Picture 19">
+            <a:extLst>
+              <a:ext uri="{FF2B5EF4-FFF2-40B4-BE49-F238E27FC236}">
+                <a16:creationId xmlns:a16="http://schemas.microsoft.com/office/drawing/2014/main" id="{F73AA51E-4923-CDD1-4133-F1184B21179B}"/>
+              </a:ext>
+            </a:extLst>
+          </p:cNvPr>
+          <p:cNvPicPr>
+            <a:picLocks noChangeAspect="1"/>
+          </p:cNvPicPr>
+          <p:nvPr/>
+        </p:nvPicPr>
+        <p:blipFill>
+          <a:blip r:embed="rId9"/>
+          <a:stretch>
+            <a:fillRect/>
+          </a:stretch>
+        </p:blipFill>
+        <p:spPr>
+          <a:xfrm>
+            <a:off x="1409983" y="3886763"/>
+            <a:ext cx="1397705" cy="2413630"/>
+          </a:xfrm>
+          <a:prstGeom prst="rect">
+            <a:avLst/>
+          </a:prstGeom>
+        </p:spPr>
+      </p:pic>
+      <p:pic>
+        <p:nvPicPr>
+          <p:cNvPr id="27" name="Picture 26">
+            <a:extLst>
+              <a:ext uri="{FF2B5EF4-FFF2-40B4-BE49-F238E27FC236}">
+                <a16:creationId xmlns:a16="http://schemas.microsoft.com/office/drawing/2014/main" id="{1205FD5D-DED8-455E-54BB-2BC28036D3CF}"/>
+              </a:ext>
+            </a:extLst>
+          </p:cNvPr>
+          <p:cNvPicPr>
+            <a:picLocks noChangeAspect="1"/>
+          </p:cNvPicPr>
+          <p:nvPr/>
+        </p:nvPicPr>
+        <p:blipFill>
+          <a:blip r:embed="rId10"/>
+          <a:stretch>
+            <a:fillRect/>
+          </a:stretch>
+        </p:blipFill>
+        <p:spPr>
+          <a:xfrm>
+            <a:off x="-1" y="6305351"/>
+            <a:ext cx="1412873" cy="2378341"/>
+          </a:xfrm>
+          <a:prstGeom prst="rect">
+            <a:avLst/>
+          </a:prstGeom>
+        </p:spPr>
+      </p:pic>
+      <p:pic>
+        <p:nvPicPr>
+          <p:cNvPr id="29" name="Picture 28">
+            <a:extLst>
+              <a:ext uri="{FF2B5EF4-FFF2-40B4-BE49-F238E27FC236}">
+                <a16:creationId xmlns:a16="http://schemas.microsoft.com/office/drawing/2014/main" id="{660CCF62-1E69-B08F-9E7C-D8E4C6662605}"/>
+              </a:ext>
+            </a:extLst>
+          </p:cNvPr>
+          <p:cNvPicPr>
+            <a:picLocks noChangeAspect="1"/>
+          </p:cNvPicPr>
+          <p:nvPr/>
+        </p:nvPicPr>
+        <p:blipFill>
+          <a:blip r:embed="rId11"/>
+          <a:stretch>
+            <a:fillRect/>
+          </a:stretch>
+        </p:blipFill>
+        <p:spPr>
+          <a:xfrm>
+            <a:off x="1412872" y="6303546"/>
+            <a:ext cx="1394816" cy="2380146"/>
+          </a:xfrm>
+          <a:prstGeom prst="rect">
+            <a:avLst/>
+          </a:prstGeom>
+        </p:spPr>
+      </p:pic>
+      <p:sp>
+        <p:nvSpPr>
+          <p:cNvPr id="26" name="Rectangle 25">
+            <a:extLst>
+              <a:ext uri="{FF2B5EF4-FFF2-40B4-BE49-F238E27FC236}">
+                <a16:creationId xmlns:a16="http://schemas.microsoft.com/office/drawing/2014/main" id="{E65147BC-9F9D-53BB-6C7E-24E5AD84E084}"/>
+              </a:ext>
+            </a:extLst>
+          </p:cNvPr>
+          <p:cNvSpPr/>
+          <p:nvPr/>
+        </p:nvSpPr>
+        <p:spPr>
+          <a:xfrm>
+            <a:off x="5961301" y="5440069"/>
+            <a:ext cx="3732510" cy="2657496"/>
+          </a:xfrm>
+          <a:prstGeom prst="rect">
+            <a:avLst/>
+          </a:prstGeom>
+          <a:solidFill>
+            <a:srgbClr val="000000">
+              <a:alpha val="74902"/>
+            </a:srgbClr>
+          </a:solidFill>
+        </p:spPr>
+        <p:style>
+          <a:lnRef idx="2">
+            <a:schemeClr val="dk1">
+              <a:shade val="15000"/>
+            </a:schemeClr>
+          </a:lnRef>
+          <a:fillRef idx="1">
+            <a:schemeClr val="dk1"/>
+          </a:fillRef>
+          <a:effectRef idx="0">
+            <a:schemeClr val="dk1"/>
+          </a:effectRef>
+          <a:fontRef idx="minor">
+            <a:schemeClr val="lt1"/>
+          </a:fontRef>
+        </p:style>
+        <p:txBody>
+          <a:bodyPr rtlCol="0" anchor="ctr"/>
+          <a:lstStyle/>
+          <a:p>
+            <a:pPr algn="ctr"/>
+            <a:endParaRPr lang="en-GB" sz="2223" dirty="0"/>
+          </a:p>
+        </p:txBody>
+      </p:sp>
+      <p:sp>
+        <p:nvSpPr>
+          <p:cNvPr id="5" name="Rectangle 4">
+            <a:extLst>
+              <a:ext uri="{FF2B5EF4-FFF2-40B4-BE49-F238E27FC236}">
+                <a16:creationId xmlns:a16="http://schemas.microsoft.com/office/drawing/2014/main" id="{0FB456EB-F03E-8A49-38AF-7CBFBF7742BB}"/>
+              </a:ext>
+            </a:extLst>
+          </p:cNvPr>
+          <p:cNvSpPr/>
+          <p:nvPr/>
+        </p:nvSpPr>
+        <p:spPr>
+          <a:xfrm>
+            <a:off x="2787900" y="95291"/>
+            <a:ext cx="7213349" cy="769329"/>
+          </a:xfrm>
+          <a:prstGeom prst="rect">
+            <a:avLst/>
+          </a:prstGeom>
+          <a:solidFill>
+            <a:srgbClr val="000000">
+              <a:alpha val="74902"/>
+            </a:srgbClr>
+          </a:solidFill>
+        </p:spPr>
+        <p:style>
+          <a:lnRef idx="2">
+            <a:schemeClr val="dk1">
+              <a:shade val="15000"/>
+            </a:schemeClr>
+          </a:lnRef>
+          <a:fillRef idx="1">
+            <a:schemeClr val="dk1"/>
+          </a:fillRef>
+          <a:effectRef idx="0">
+            <a:schemeClr val="dk1"/>
+          </a:effectRef>
+          <a:fontRef idx="minor">
+            <a:schemeClr val="lt1"/>
+          </a:fontRef>
+        </p:style>
+        <p:txBody>
+          <a:bodyPr rtlCol="0" anchor="ctr"/>
+          <a:lstStyle/>
+          <a:p>
+            <a:pPr algn="ctr"/>
+            <a:endParaRPr lang="en-GB"/>
+          </a:p>
+        </p:txBody>
+      </p:sp>
+      <p:sp>
+        <p:nvSpPr>
+          <p:cNvPr id="8" name="TextBox 7">
+            <a:extLst>
+              <a:ext uri="{FF2B5EF4-FFF2-40B4-BE49-F238E27FC236}">
+                <a16:creationId xmlns:a16="http://schemas.microsoft.com/office/drawing/2014/main" id="{68789AA8-6854-86EE-0627-2E8609BBD182}"/>
+              </a:ext>
+            </a:extLst>
+          </p:cNvPr>
+          <p:cNvSpPr txBox="1"/>
+          <p:nvPr/>
+        </p:nvSpPr>
+        <p:spPr>
+          <a:xfrm>
+            <a:off x="2804799" y="15354"/>
+            <a:ext cx="7208901" cy="769441"/>
+          </a:xfrm>
+          <a:prstGeom prst="rect">
+            <a:avLst/>
+          </a:prstGeom>
+          <a:noFill/>
+        </p:spPr>
+        <p:txBody>
+          <a:bodyPr wrap="square" rtlCol="0">
+            <a:spAutoFit/>
+          </a:bodyPr>
+          <a:lstStyle/>
+          <a:p>
+            <a:pPr algn="ctr"/>
+            <a:r>
+              <a:rPr lang="en-GB" sz="4400" dirty="0">
+                <a:latin typeface="Zain Fishing Hooks" panose="02000503000000000000" pitchFamily="2" charset="0"/>
+              </a:rPr>
+              <a:t>Hook line and slinger</a:t>
+            </a:r>
+          </a:p>
+        </p:txBody>
+      </p:sp>
+      <p:sp>
+        <p:nvSpPr>
+          <p:cNvPr id="24" name="Rectangle 23">
+            <a:extLst>
+              <a:ext uri="{FF2B5EF4-FFF2-40B4-BE49-F238E27FC236}">
+                <a16:creationId xmlns:a16="http://schemas.microsoft.com/office/drawing/2014/main" id="{870B11C9-D814-92BC-71D2-515402425ABF}"/>
+              </a:ext>
+            </a:extLst>
+          </p:cNvPr>
+          <p:cNvSpPr/>
+          <p:nvPr/>
+        </p:nvSpPr>
+        <p:spPr>
+          <a:xfrm>
+            <a:off x="2867278" y="2730795"/>
+            <a:ext cx="2461845" cy="2647359"/>
+          </a:xfrm>
+          <a:prstGeom prst="rect">
+            <a:avLst/>
+          </a:prstGeom>
+          <a:solidFill>
+            <a:srgbClr val="000000">
+              <a:alpha val="74902"/>
+            </a:srgbClr>
+          </a:solidFill>
+        </p:spPr>
+        <p:style>
+          <a:lnRef idx="2">
+            <a:schemeClr val="dk1">
+              <a:shade val="15000"/>
+            </a:schemeClr>
+          </a:lnRef>
+          <a:fillRef idx="1">
+            <a:schemeClr val="dk1"/>
+          </a:fillRef>
+          <a:effectRef idx="0">
+            <a:schemeClr val="dk1"/>
+          </a:effectRef>
+          <a:fontRef idx="minor">
+            <a:schemeClr val="lt1"/>
+          </a:fontRef>
+        </p:style>
+        <p:txBody>
+          <a:bodyPr rtlCol="0" anchor="ctr"/>
+          <a:lstStyle/>
+          <a:p>
+            <a:pPr algn="ctr"/>
+            <a:endParaRPr lang="en-GB"/>
+          </a:p>
+        </p:txBody>
+      </p:sp>
+      <p:pic>
+        <p:nvPicPr>
+          <p:cNvPr id="23" name="Picture 22">
+            <a:extLst>
+              <a:ext uri="{FF2B5EF4-FFF2-40B4-BE49-F238E27FC236}">
+                <a16:creationId xmlns:a16="http://schemas.microsoft.com/office/drawing/2014/main" id="{13C9D004-D490-C68A-1BA6-76449FA1ED19}"/>
+              </a:ext>
+            </a:extLst>
+          </p:cNvPr>
+          <p:cNvPicPr>
+            <a:picLocks noChangeAspect="1"/>
+          </p:cNvPicPr>
+          <p:nvPr/>
+        </p:nvPicPr>
+        <p:blipFill>
+          <a:blip r:embed="rId12"/>
+          <a:stretch>
+            <a:fillRect/>
+          </a:stretch>
+        </p:blipFill>
+        <p:spPr>
+          <a:xfrm>
+            <a:off x="2932529" y="2797884"/>
+            <a:ext cx="2331341" cy="1717293"/>
+          </a:xfrm>
+          <a:prstGeom prst="rect">
+            <a:avLst/>
+          </a:prstGeom>
+        </p:spPr>
+      </p:pic>
+      <p:sp>
+        <p:nvSpPr>
+          <p:cNvPr id="28" name="TextBox 27">
+            <a:extLst>
+              <a:ext uri="{FF2B5EF4-FFF2-40B4-BE49-F238E27FC236}">
+                <a16:creationId xmlns:a16="http://schemas.microsoft.com/office/drawing/2014/main" id="{D808267A-0CFE-312B-6B6F-F706C2730176}"/>
+              </a:ext>
+            </a:extLst>
+          </p:cNvPr>
+          <p:cNvSpPr txBox="1"/>
+          <p:nvPr/>
+        </p:nvSpPr>
+        <p:spPr>
+          <a:xfrm>
+            <a:off x="2859907" y="4547157"/>
+            <a:ext cx="2469215" cy="830997"/>
+          </a:xfrm>
+          <a:prstGeom prst="rect">
+            <a:avLst/>
+          </a:prstGeom>
+          <a:noFill/>
+        </p:spPr>
+        <p:txBody>
+          <a:bodyPr wrap="square" rtlCol="0">
+            <a:spAutoFit/>
+          </a:bodyPr>
+          <a:lstStyle/>
+          <a:p>
+            <a:pPr algn="ctr"/>
+            <a:r>
+              <a:rPr lang="en-GB" sz="1600" dirty="0"/>
+              <a:t>Move from one area to the next to encounter diverse enemies and challenges.</a:t>
+            </a:r>
+          </a:p>
+        </p:txBody>
+      </p:sp>
+      <p:sp>
+        <p:nvSpPr>
+          <p:cNvPr id="38" name="Rectangle 37">
+            <a:extLst>
+              <a:ext uri="{FF2B5EF4-FFF2-40B4-BE49-F238E27FC236}">
+                <a16:creationId xmlns:a16="http://schemas.microsoft.com/office/drawing/2014/main" id="{A9F7AE95-0423-3232-EBB2-7086B0AA2618}"/>
+              </a:ext>
+            </a:extLst>
+          </p:cNvPr>
+          <p:cNvSpPr/>
+          <p:nvPr/>
+        </p:nvSpPr>
+        <p:spPr>
+          <a:xfrm>
+            <a:off x="5415175" y="2730795"/>
+            <a:ext cx="1968197" cy="2647359"/>
+          </a:xfrm>
+          <a:prstGeom prst="rect">
+            <a:avLst/>
+          </a:prstGeom>
+          <a:solidFill>
+            <a:srgbClr val="000000">
+              <a:alpha val="74902"/>
+            </a:srgbClr>
+          </a:solidFill>
+        </p:spPr>
+        <p:style>
+          <a:lnRef idx="2">
+            <a:schemeClr val="dk1">
+              <a:shade val="15000"/>
+            </a:schemeClr>
+          </a:lnRef>
+          <a:fillRef idx="1">
+            <a:schemeClr val="dk1"/>
+          </a:fillRef>
+          <a:effectRef idx="0">
+            <a:schemeClr val="dk1"/>
+          </a:effectRef>
+          <a:fontRef idx="minor">
+            <a:schemeClr val="lt1"/>
+          </a:fontRef>
+        </p:style>
+        <p:txBody>
+          <a:bodyPr rtlCol="0" anchor="ctr"/>
+          <a:lstStyle/>
+          <a:p>
+            <a:pPr algn="ctr"/>
+            <a:endParaRPr lang="en-GB"/>
+          </a:p>
+        </p:txBody>
+      </p:sp>
+      <p:pic>
+        <p:nvPicPr>
+          <p:cNvPr id="35" name="Picture 34">
+            <a:extLst>
+              <a:ext uri="{FF2B5EF4-FFF2-40B4-BE49-F238E27FC236}">
+                <a16:creationId xmlns:a16="http://schemas.microsoft.com/office/drawing/2014/main" id="{EA132EEC-F09A-94F2-A3FC-435152CAFA8D}"/>
+              </a:ext>
+            </a:extLst>
+          </p:cNvPr>
+          <p:cNvPicPr>
+            <a:picLocks noChangeAspect="1"/>
+          </p:cNvPicPr>
+          <p:nvPr/>
+        </p:nvPicPr>
+        <p:blipFill>
+          <a:blip r:embed="rId13"/>
+          <a:stretch>
+            <a:fillRect/>
+          </a:stretch>
+        </p:blipFill>
+        <p:spPr>
+          <a:xfrm>
+            <a:off x="5486953" y="2808648"/>
+            <a:ext cx="1844249" cy="1695763"/>
+          </a:xfrm>
+          <a:prstGeom prst="rect">
+            <a:avLst/>
+          </a:prstGeom>
+        </p:spPr>
+      </p:pic>
+      <p:sp>
+        <p:nvSpPr>
+          <p:cNvPr id="37" name="TextBox 36">
+            <a:extLst>
+              <a:ext uri="{FF2B5EF4-FFF2-40B4-BE49-F238E27FC236}">
+                <a16:creationId xmlns:a16="http://schemas.microsoft.com/office/drawing/2014/main" id="{10CADF2A-81D9-9E0F-3D8F-2A359C85A0E2}"/>
+              </a:ext>
+            </a:extLst>
+          </p:cNvPr>
+          <p:cNvSpPr txBox="1"/>
+          <p:nvPr/>
+        </p:nvSpPr>
+        <p:spPr>
+          <a:xfrm>
+            <a:off x="5415174" y="4537701"/>
+            <a:ext cx="1968196" cy="830997"/>
+          </a:xfrm>
+          <a:prstGeom prst="rect">
+            <a:avLst/>
+          </a:prstGeom>
+          <a:noFill/>
+        </p:spPr>
+        <p:txBody>
+          <a:bodyPr wrap="square" rtlCol="0">
+            <a:spAutoFit/>
+          </a:bodyPr>
+          <a:lstStyle/>
+          <a:p>
+            <a:pPr algn="ctr"/>
+            <a:r>
+              <a:rPr lang="en-GB" sz="1600" dirty="0"/>
+              <a:t>Use your fishing rod to grapple to rings around each level.</a:t>
+            </a:r>
+          </a:p>
+        </p:txBody>
+      </p:sp>
+      <p:sp>
+        <p:nvSpPr>
+          <p:cNvPr id="39" name="Rectangle 38">
+            <a:extLst>
+              <a:ext uri="{FF2B5EF4-FFF2-40B4-BE49-F238E27FC236}">
+                <a16:creationId xmlns:a16="http://schemas.microsoft.com/office/drawing/2014/main" id="{297AFF86-F149-0F13-11BF-0D6BEDEE2D5B}"/>
+              </a:ext>
+            </a:extLst>
+          </p:cNvPr>
+          <p:cNvSpPr/>
+          <p:nvPr/>
+        </p:nvSpPr>
+        <p:spPr>
+          <a:xfrm>
+            <a:off x="7469422" y="2736761"/>
+            <a:ext cx="2578135" cy="2630190"/>
+          </a:xfrm>
+          <a:prstGeom prst="rect">
+            <a:avLst/>
+          </a:prstGeom>
+          <a:solidFill>
+            <a:srgbClr val="000000">
+              <a:alpha val="74902"/>
+            </a:srgbClr>
+          </a:solidFill>
+        </p:spPr>
+        <p:style>
+          <a:lnRef idx="2">
+            <a:schemeClr val="dk1">
+              <a:shade val="15000"/>
+            </a:schemeClr>
+          </a:lnRef>
+          <a:fillRef idx="1">
+            <a:schemeClr val="dk1"/>
+          </a:fillRef>
+          <a:effectRef idx="0">
+            <a:schemeClr val="dk1"/>
+          </a:effectRef>
+          <a:fontRef idx="minor">
+            <a:schemeClr val="lt1"/>
+          </a:fontRef>
+        </p:style>
+        <p:txBody>
+          <a:bodyPr rtlCol="0" anchor="ctr"/>
+          <a:lstStyle/>
+          <a:p>
+            <a:pPr algn="ctr"/>
+            <a:endParaRPr lang="en-GB"/>
+          </a:p>
+        </p:txBody>
+      </p:sp>
+      <p:pic>
+        <p:nvPicPr>
+          <p:cNvPr id="41" name="Picture 40">
+            <a:extLst>
+              <a:ext uri="{FF2B5EF4-FFF2-40B4-BE49-F238E27FC236}">
+                <a16:creationId xmlns:a16="http://schemas.microsoft.com/office/drawing/2014/main" id="{5BF6EE4A-ED63-2098-9C11-B480794330C4}"/>
+              </a:ext>
+            </a:extLst>
+          </p:cNvPr>
+          <p:cNvPicPr>
+            <a:picLocks noChangeAspect="1"/>
+          </p:cNvPicPr>
+          <p:nvPr/>
+        </p:nvPicPr>
+        <p:blipFill>
+          <a:blip r:embed="rId14"/>
+          <a:stretch>
+            <a:fillRect/>
+          </a:stretch>
+        </p:blipFill>
+        <p:spPr>
+          <a:xfrm>
+            <a:off x="7532442" y="2817829"/>
+            <a:ext cx="2452094" cy="1719872"/>
+          </a:xfrm>
+          <a:prstGeom prst="rect">
+            <a:avLst/>
+          </a:prstGeom>
+        </p:spPr>
+      </p:pic>
+      <p:sp>
+        <p:nvSpPr>
+          <p:cNvPr id="42" name="TextBox 41">
+            <a:extLst>
+              <a:ext uri="{FF2B5EF4-FFF2-40B4-BE49-F238E27FC236}">
+                <a16:creationId xmlns:a16="http://schemas.microsoft.com/office/drawing/2014/main" id="{8F30C585-FCFC-007B-73E9-64FB4B9222AB}"/>
+              </a:ext>
+            </a:extLst>
+          </p:cNvPr>
+          <p:cNvSpPr txBox="1"/>
+          <p:nvPr/>
+        </p:nvSpPr>
+        <p:spPr>
+          <a:xfrm>
+            <a:off x="7472756" y="4554611"/>
+            <a:ext cx="2571465" cy="830997"/>
+          </a:xfrm>
+          <a:prstGeom prst="rect">
+            <a:avLst/>
+          </a:prstGeom>
+          <a:noFill/>
+        </p:spPr>
+        <p:txBody>
+          <a:bodyPr wrap="square" rtlCol="0">
+            <a:spAutoFit/>
+          </a:bodyPr>
+          <a:lstStyle/>
+          <a:p>
+            <a:pPr algn="ctr"/>
+            <a:r>
+              <a:rPr lang="en-GB" sz="1600" dirty="0"/>
+              <a:t>Use grapple points to fly through the world or to reveal hidden paths.</a:t>
+            </a:r>
+          </a:p>
+        </p:txBody>
+      </p:sp>
+      <p:sp>
+        <p:nvSpPr>
+          <p:cNvPr id="43" name="Rectangle 42">
+            <a:extLst>
+              <a:ext uri="{FF2B5EF4-FFF2-40B4-BE49-F238E27FC236}">
+                <a16:creationId xmlns:a16="http://schemas.microsoft.com/office/drawing/2014/main" id="{28180014-961A-3C40-4EF5-B48B34745C55}"/>
+              </a:ext>
+            </a:extLst>
+          </p:cNvPr>
+          <p:cNvSpPr/>
+          <p:nvPr/>
+        </p:nvSpPr>
+        <p:spPr>
+          <a:xfrm>
+            <a:off x="2869882" y="5440068"/>
+            <a:ext cx="3042943" cy="2657496"/>
+          </a:xfrm>
+          <a:prstGeom prst="rect">
+            <a:avLst/>
+          </a:prstGeom>
+          <a:solidFill>
+            <a:srgbClr val="000000">
+              <a:alpha val="74902"/>
+            </a:srgbClr>
+          </a:solidFill>
+        </p:spPr>
+        <p:style>
+          <a:lnRef idx="2">
+            <a:schemeClr val="dk1">
+              <a:shade val="15000"/>
+            </a:schemeClr>
+          </a:lnRef>
+          <a:fillRef idx="1">
+            <a:schemeClr val="dk1"/>
+          </a:fillRef>
+          <a:effectRef idx="0">
+            <a:schemeClr val="dk1"/>
+          </a:effectRef>
+          <a:fontRef idx="minor">
+            <a:schemeClr val="lt1"/>
+          </a:fontRef>
+        </p:style>
+        <p:txBody>
+          <a:bodyPr rtlCol="0" anchor="ctr"/>
+          <a:lstStyle/>
+          <a:p>
+            <a:pPr algn="ctr"/>
+            <a:endParaRPr lang="en-GB"/>
+          </a:p>
+        </p:txBody>
+      </p:sp>
+      <p:pic>
+        <p:nvPicPr>
+          <p:cNvPr id="45" name="Picture 44">
+            <a:extLst>
+              <a:ext uri="{FF2B5EF4-FFF2-40B4-BE49-F238E27FC236}">
+                <a16:creationId xmlns:a16="http://schemas.microsoft.com/office/drawing/2014/main" id="{405CE23C-93BC-3392-064E-484AD2EC9126}"/>
+              </a:ext>
+            </a:extLst>
+          </p:cNvPr>
+          <p:cNvPicPr>
+            <a:picLocks noChangeAspect="1"/>
+          </p:cNvPicPr>
+          <p:nvPr/>
+        </p:nvPicPr>
+        <p:blipFill>
+          <a:blip r:embed="rId15"/>
+          <a:stretch>
+            <a:fillRect/>
+          </a:stretch>
+        </p:blipFill>
+        <p:spPr>
+          <a:xfrm>
+            <a:off x="2931192" y="5513865"/>
+            <a:ext cx="2920321" cy="1986203"/>
+          </a:xfrm>
+          <a:prstGeom prst="rect">
+            <a:avLst/>
+          </a:prstGeom>
+        </p:spPr>
+      </p:pic>
+      <p:sp>
+        <p:nvSpPr>
+          <p:cNvPr id="46" name="TextBox 45">
+            <a:extLst>
+              <a:ext uri="{FF2B5EF4-FFF2-40B4-BE49-F238E27FC236}">
+                <a16:creationId xmlns:a16="http://schemas.microsoft.com/office/drawing/2014/main" id="{8B3A62AD-1D77-C173-1A02-240B2747EFB4}"/>
+              </a:ext>
+            </a:extLst>
+          </p:cNvPr>
+          <p:cNvSpPr txBox="1"/>
+          <p:nvPr/>
+        </p:nvSpPr>
+        <p:spPr>
+          <a:xfrm>
+            <a:off x="2869882" y="7502411"/>
+            <a:ext cx="3010878" cy="584775"/>
+          </a:xfrm>
+          <a:prstGeom prst="rect">
+            <a:avLst/>
+          </a:prstGeom>
+          <a:noFill/>
+        </p:spPr>
+        <p:txBody>
+          <a:bodyPr wrap="square" rtlCol="0">
+            <a:spAutoFit/>
+          </a:bodyPr>
+          <a:lstStyle/>
+          <a:p>
+            <a:pPr algn="ctr"/>
+            <a:r>
+              <a:rPr lang="en-GB" sz="1600" dirty="0"/>
+              <a:t>Sit at benches to rest and switch up your loadout.</a:t>
+            </a:r>
+          </a:p>
+        </p:txBody>
+      </p:sp>
+      <p:pic>
+        <p:nvPicPr>
+          <p:cNvPr id="48" name="Picture 47">
+            <a:extLst>
+              <a:ext uri="{FF2B5EF4-FFF2-40B4-BE49-F238E27FC236}">
+                <a16:creationId xmlns:a16="http://schemas.microsoft.com/office/drawing/2014/main" id="{C6C7742F-31C6-54C0-A181-08BA00962261}"/>
+              </a:ext>
+            </a:extLst>
+          </p:cNvPr>
+          <p:cNvPicPr>
+            <a:picLocks noChangeAspect="1"/>
+          </p:cNvPicPr>
+          <p:nvPr/>
+        </p:nvPicPr>
+        <p:blipFill>
+          <a:blip r:embed="rId16"/>
+          <a:stretch>
+            <a:fillRect/>
+          </a:stretch>
+        </p:blipFill>
+        <p:spPr>
+          <a:xfrm>
+            <a:off x="6043558" y="5516013"/>
+            <a:ext cx="3587813" cy="1981906"/>
+          </a:xfrm>
+          <a:prstGeom prst="rect">
+            <a:avLst/>
+          </a:prstGeom>
+        </p:spPr>
+      </p:pic>
+      <p:sp>
+        <p:nvSpPr>
+          <p:cNvPr id="49" name="TextBox 48">
+            <a:extLst>
+              <a:ext uri="{FF2B5EF4-FFF2-40B4-BE49-F238E27FC236}">
+                <a16:creationId xmlns:a16="http://schemas.microsoft.com/office/drawing/2014/main" id="{0469F113-1F62-FEB7-5285-2A1441E397DD}"/>
+              </a:ext>
+            </a:extLst>
+          </p:cNvPr>
+          <p:cNvSpPr txBox="1"/>
+          <p:nvPr/>
+        </p:nvSpPr>
+        <p:spPr>
+          <a:xfrm>
+            <a:off x="5974649" y="7484621"/>
+            <a:ext cx="3719162" cy="584775"/>
+          </a:xfrm>
+          <a:prstGeom prst="rect">
+            <a:avLst/>
+          </a:prstGeom>
+          <a:noFill/>
+        </p:spPr>
+        <p:txBody>
+          <a:bodyPr wrap="square" rtlCol="0">
+            <a:spAutoFit/>
+          </a:bodyPr>
+          <a:lstStyle/>
+          <a:p>
+            <a:pPr algn="ctr"/>
+            <a:r>
+              <a:rPr lang="en-GB" sz="1600" dirty="0"/>
+              <a:t>Fight various bosses that test different mechanics</a:t>
+            </a:r>
+          </a:p>
+        </p:txBody>
+      </p:sp>
+      <p:sp>
+        <p:nvSpPr>
+          <p:cNvPr id="50" name="Rectangle 49">
+            <a:extLst>
+              <a:ext uri="{FF2B5EF4-FFF2-40B4-BE49-F238E27FC236}">
+                <a16:creationId xmlns:a16="http://schemas.microsoft.com/office/drawing/2014/main" id="{902C15CA-61BF-EE18-9872-B6427FEEB07D}"/>
+              </a:ext>
+            </a:extLst>
+          </p:cNvPr>
+          <p:cNvSpPr/>
+          <p:nvPr/>
+        </p:nvSpPr>
+        <p:spPr>
+          <a:xfrm>
+            <a:off x="9755634" y="6258655"/>
+            <a:ext cx="2578135" cy="1826810"/>
+          </a:xfrm>
+          <a:prstGeom prst="rect">
+            <a:avLst/>
+          </a:prstGeom>
+          <a:solidFill>
+            <a:srgbClr val="000000">
+              <a:alpha val="74902"/>
+            </a:srgbClr>
+          </a:solidFill>
+        </p:spPr>
+        <p:style>
+          <a:lnRef idx="2">
+            <a:schemeClr val="dk1">
+              <a:shade val="15000"/>
+            </a:schemeClr>
+          </a:lnRef>
+          <a:fillRef idx="1">
+            <a:schemeClr val="dk1"/>
+          </a:fillRef>
+          <a:effectRef idx="0">
+            <a:schemeClr val="dk1"/>
+          </a:effectRef>
+          <a:fontRef idx="minor">
+            <a:schemeClr val="lt1"/>
+          </a:fontRef>
+        </p:style>
+        <p:txBody>
+          <a:bodyPr rtlCol="0" anchor="ctr"/>
+          <a:lstStyle/>
+          <a:p>
+            <a:pPr algn="ctr"/>
+            <a:endParaRPr lang="en-GB"/>
+          </a:p>
+        </p:txBody>
+      </p:sp>
+      <p:sp>
+        <p:nvSpPr>
+          <p:cNvPr id="51" name="TextBox 50">
+            <a:extLst>
+              <a:ext uri="{FF2B5EF4-FFF2-40B4-BE49-F238E27FC236}">
+                <a16:creationId xmlns:a16="http://schemas.microsoft.com/office/drawing/2014/main" id="{8BF25F8C-5B32-64CD-CF8E-CD1D8AF815E6}"/>
+              </a:ext>
+            </a:extLst>
+          </p:cNvPr>
+          <p:cNvSpPr txBox="1"/>
+          <p:nvPr/>
+        </p:nvSpPr>
+        <p:spPr>
+          <a:xfrm>
+            <a:off x="9762103" y="6253514"/>
+            <a:ext cx="2571666" cy="1815882"/>
+          </a:xfrm>
+          <a:prstGeom prst="rect">
+            <a:avLst/>
+          </a:prstGeom>
+          <a:noFill/>
+        </p:spPr>
+        <p:txBody>
+          <a:bodyPr wrap="square" rtlCol="0">
+            <a:spAutoFit/>
+          </a:bodyPr>
+          <a:lstStyle/>
+          <a:p>
+            <a:r>
+              <a:rPr lang="en-GB" sz="1600" dirty="0"/>
+              <a:t>Additional features include:</a:t>
+            </a:r>
+          </a:p>
+          <a:p>
+            <a:pPr marL="285750" indent="-285750">
+              <a:buFont typeface="Arial" panose="020B0604020202020204" pitchFamily="34" charset="0"/>
+              <a:buChar char="•"/>
+            </a:pPr>
+            <a:r>
+              <a:rPr lang="en-GB" sz="1600" dirty="0"/>
+              <a:t>Pause “menu”.</a:t>
+            </a:r>
+          </a:p>
+          <a:p>
+            <a:pPr marL="285750" indent="-285750">
+              <a:buFont typeface="Arial" panose="020B0604020202020204" pitchFamily="34" charset="0"/>
+              <a:buChar char="•"/>
+            </a:pPr>
+            <a:r>
+              <a:rPr lang="en-GB" sz="1600" dirty="0"/>
+              <a:t>Play on pc or controller!</a:t>
+            </a:r>
+          </a:p>
+          <a:p>
+            <a:pPr marL="285750" indent="-285750">
+              <a:buFont typeface="Arial" panose="020B0604020202020204" pitchFamily="34" charset="0"/>
+              <a:buChar char="•"/>
+            </a:pPr>
+            <a:r>
+              <a:rPr lang="en-GB" sz="1600" dirty="0"/>
+              <a:t>Speedrun timer.</a:t>
+            </a:r>
+          </a:p>
+          <a:p>
+            <a:pPr marL="285750" indent="-285750">
+              <a:buFont typeface="Arial" panose="020B0604020202020204" pitchFamily="34" charset="0"/>
+              <a:buChar char="•"/>
+            </a:pPr>
+            <a:r>
+              <a:rPr lang="en-GB" sz="1600" dirty="0"/>
+              <a:t>Data stored locally.</a:t>
+            </a:r>
+          </a:p>
+          <a:p>
+            <a:pPr marL="285750" indent="-285750">
+              <a:buFont typeface="Arial" panose="020B0604020202020204" pitchFamily="34" charset="0"/>
+              <a:buChar char="•"/>
+            </a:pPr>
+            <a:r>
+              <a:rPr lang="en-GB" sz="1600" dirty="0"/>
+              <a:t>More levels in the future.</a:t>
+            </a:r>
+          </a:p>
+          <a:p>
+            <a:pPr marL="285750" indent="-285750">
+              <a:buFont typeface="Arial" panose="020B0604020202020204" pitchFamily="34" charset="0"/>
+              <a:buChar char="•"/>
+            </a:pPr>
+            <a:r>
+              <a:rPr lang="en-GB" sz="1600" dirty="0"/>
+              <a:t>And so much more!</a:t>
             </a:r>
           </a:p>
         </p:txBody>
@@ -8555,4 +9933,319 @@
     </a:ext>
   </a:extLst>
 </a:theme>
+</file>
+
+<file path=ppt/theme/theme2.xml><?xml version="1.0" encoding="utf-8"?>
+<a:theme xmlns:a="http://schemas.openxmlformats.org/drawingml/2006/main" name="Office Theme">
+  <a:themeElements>
+    <a:clrScheme name="Office">
+      <a:dk1>
+        <a:sysClr val="windowText" lastClr="000000"/>
+      </a:dk1>
+      <a:lt1>
+        <a:sysClr val="window" lastClr="FFFFFF"/>
+      </a:lt1>
+      <a:dk2>
+        <a:srgbClr val="0E2841"/>
+      </a:dk2>
+      <a:lt2>
+        <a:srgbClr val="E8E8E8"/>
+      </a:lt2>
+      <a:accent1>
+        <a:srgbClr val="156082"/>
+      </a:accent1>
+      <a:accent2>
+        <a:srgbClr val="E97132"/>
+      </a:accent2>
+      <a:accent3>
+        <a:srgbClr val="196B24"/>
+      </a:accent3>
+      <a:accent4>
+        <a:srgbClr val="0F9ED5"/>
+      </a:accent4>
+      <a:accent5>
+        <a:srgbClr val="A02B93"/>
+      </a:accent5>
+      <a:accent6>
+        <a:srgbClr val="4EA72E"/>
+      </a:accent6>
+      <a:hlink>
+        <a:srgbClr val="467886"/>
+      </a:hlink>
+      <a:folHlink>
+        <a:srgbClr val="96607D"/>
+      </a:folHlink>
+    </a:clrScheme>
+    <a:fontScheme name="Office">
+      <a:majorFont>
+        <a:latin typeface="Aptos Display" panose="02110004020202020204"/>
+        <a:ea typeface=""/>
+        <a:cs typeface=""/>
+        <a:font script="Jpan" typeface="游ゴシック Light"/>
+        <a:font script="Hang" typeface="맑은 고딕"/>
+        <a:font script="Hans" typeface="等线 Light"/>
+        <a:font script="Hant" typeface="新細明體"/>
+        <a:font script="Arab" typeface="Times New Roman"/>
+        <a:font script="Hebr" typeface="Times New Roman"/>
+        <a:font script="Thai" typeface="Angsana New"/>
+        <a:font script="Ethi" typeface="Nyala"/>
+        <a:font script="Beng" typeface="Vrinda"/>
+        <a:font script="Gujr" typeface="Shruti"/>
+        <a:font script="Khmr" typeface="MoolBoran"/>
+        <a:font script="Knda" typeface="Tunga"/>
+        <a:font script="Guru" typeface="Raavi"/>
+        <a:font script="Cans" typeface="Euphemia"/>
+        <a:font script="Cher" typeface="Plantagenet Cherokee"/>
+        <a:font script="Yiii" typeface="Microsoft Yi Baiti"/>
+        <a:font script="Tibt" typeface="Microsoft Himalaya"/>
+        <a:font script="Thaa" typeface="MV Boli"/>
+        <a:font script="Deva" typeface="Mangal"/>
+        <a:font script="Telu" typeface="Gautami"/>
+        <a:font script="Taml" typeface="Latha"/>
+        <a:font script="Syrc" typeface="Estrangelo Edessa"/>
+        <a:font script="Orya" typeface="Kalinga"/>
+        <a:font script="Mlym" typeface="Kartika"/>
+        <a:font script="Laoo" typeface="DokChampa"/>
+        <a:font script="Sinh" typeface="Iskoola Pota"/>
+        <a:font script="Mong" typeface="Mongolian Baiti"/>
+        <a:font script="Viet" typeface="Times New Roman"/>
+        <a:font script="Uigh" typeface="Microsoft Uighur"/>
+        <a:font script="Geor" typeface="Sylfaen"/>
+        <a:font script="Armn" typeface="Arial"/>
+        <a:font script="Bugi" typeface="Leelawadee UI"/>
+        <a:font script="Bopo" typeface="Microsoft JhengHei"/>
+        <a:font script="Java" typeface="Javanese Text"/>
+        <a:font script="Lisu" typeface="Segoe UI"/>
+        <a:font script="Mymr" typeface="Myanmar Text"/>
+        <a:font script="Nkoo" typeface="Ebrima"/>
+        <a:font script="Olck" typeface="Nirmala UI"/>
+        <a:font script="Osma" typeface="Ebrima"/>
+        <a:font script="Phag" typeface="Phagspa"/>
+        <a:font script="Syrn" typeface="Estrangelo Edessa"/>
+        <a:font script="Syrj" typeface="Estrangelo Edessa"/>
+        <a:font script="Syre" typeface="Estrangelo Edessa"/>
+        <a:font script="Sora" typeface="Nirmala UI"/>
+        <a:font script="Tale" typeface="Microsoft Tai Le"/>
+        <a:font script="Talu" typeface="Microsoft New Tai Lue"/>
+        <a:font script="Tfng" typeface="Ebrima"/>
+      </a:majorFont>
+      <a:minorFont>
+        <a:latin typeface="Aptos" panose="02110004020202020204"/>
+        <a:ea typeface=""/>
+        <a:cs typeface=""/>
+        <a:font script="Jpan" typeface="游ゴシック"/>
+        <a:font script="Hang" typeface="맑은 고딕"/>
+        <a:font script="Hans" typeface="等线"/>
+        <a:font script="Hant" typeface="新細明體"/>
+        <a:font script="Arab" typeface="Arial"/>
+        <a:font script="Hebr" typeface="Arial"/>
+        <a:font script="Thai" typeface="Cordia New"/>
+        <a:font script="Ethi" typeface="Nyala"/>
+        <a:font script="Beng" typeface="Vrinda"/>
+        <a:font script="Gujr" typeface="Shruti"/>
+        <a:font script="Khmr" typeface="DaunPenh"/>
+        <a:font script="Knda" typeface="Tunga"/>
+        <a:font script="Guru" typeface="Raavi"/>
+        <a:font script="Cans" typeface="Euphemia"/>
+        <a:font script="Cher" typeface="Plantagenet Cherokee"/>
+        <a:font script="Yiii" typeface="Microsoft Yi Baiti"/>
+        <a:font script="Tibt" typeface="Microsoft Himalaya"/>
+        <a:font script="Thaa" typeface="MV Boli"/>
+        <a:font script="Deva" typeface="Mangal"/>
+        <a:font script="Telu" typeface="Gautami"/>
+        <a:font script="Taml" typeface="Latha"/>
+        <a:font script="Syrc" typeface="Estrangelo Edessa"/>
+        <a:font script="Orya" typeface="Kalinga"/>
+        <a:font script="Mlym" typeface="Kartika"/>
+        <a:font script="Laoo" typeface="DokChampa"/>
+        <a:font script="Sinh" typeface="Iskoola Pota"/>
+        <a:font script="Mong" typeface="Mongolian Baiti"/>
+        <a:font script="Viet" typeface="Arial"/>
+        <a:font script="Uigh" typeface="Microsoft Uighur"/>
+        <a:font script="Geor" typeface="Sylfaen"/>
+        <a:font script="Armn" typeface="Arial"/>
+        <a:font script="Bugi" typeface="Leelawadee UI"/>
+        <a:font script="Bopo" typeface="Microsoft JhengHei"/>
+        <a:font script="Java" typeface="Javanese Text"/>
+        <a:font script="Lisu" typeface="Segoe UI"/>
+        <a:font script="Mymr" typeface="Myanmar Text"/>
+        <a:font script="Nkoo" typeface="Ebrima"/>
+        <a:font script="Olck" typeface="Nirmala UI"/>
+        <a:font script="Osma" typeface="Ebrima"/>
+        <a:font script="Phag" typeface="Phagspa"/>
+        <a:font script="Syrn" typeface="Estrangelo Edessa"/>
+        <a:font script="Syrj" typeface="Estrangelo Edessa"/>
+        <a:font script="Syre" typeface="Estrangelo Edessa"/>
+        <a:font script="Sora" typeface="Nirmala UI"/>
+        <a:font script="Tale" typeface="Microsoft Tai Le"/>
+        <a:font script="Talu" typeface="Microsoft New Tai Lue"/>
+        <a:font script="Tfng" typeface="Ebrima"/>
+      </a:minorFont>
+    </a:fontScheme>
+    <a:fmtScheme name="Office">
+      <a:fillStyleLst>
+        <a:solidFill>
+          <a:schemeClr val="phClr"/>
+        </a:solidFill>
+        <a:gradFill rotWithShape="1">
+          <a:gsLst>
+            <a:gs pos="0">
+              <a:schemeClr val="phClr">
+                <a:lumMod val="110000"/>
+                <a:satMod val="105000"/>
+                <a:tint val="67000"/>
+              </a:schemeClr>
+            </a:gs>
+            <a:gs pos="50000">
+              <a:schemeClr val="phClr">
+                <a:lumMod val="105000"/>
+                <a:satMod val="103000"/>
+                <a:tint val="73000"/>
+              </a:schemeClr>
+            </a:gs>
+            <a:gs pos="100000">
+              <a:schemeClr val="phClr">
+                <a:lumMod val="105000"/>
+                <a:satMod val="109000"/>
+                <a:tint val="81000"/>
+              </a:schemeClr>
+            </a:gs>
+          </a:gsLst>
+          <a:lin ang="5400000" scaled="0"/>
+        </a:gradFill>
+        <a:gradFill rotWithShape="1">
+          <a:gsLst>
+            <a:gs pos="0">
+              <a:schemeClr val="phClr">
+                <a:satMod val="103000"/>
+                <a:lumMod val="102000"/>
+                <a:tint val="94000"/>
+              </a:schemeClr>
+            </a:gs>
+            <a:gs pos="50000">
+              <a:schemeClr val="phClr">
+                <a:satMod val="110000"/>
+                <a:lumMod val="100000"/>
+                <a:shade val="100000"/>
+              </a:schemeClr>
+            </a:gs>
+            <a:gs pos="100000">
+              <a:schemeClr val="phClr">
+                <a:lumMod val="99000"/>
+                <a:satMod val="120000"/>
+                <a:shade val="78000"/>
+              </a:schemeClr>
+            </a:gs>
+          </a:gsLst>
+          <a:lin ang="5400000" scaled="0"/>
+        </a:gradFill>
+      </a:fillStyleLst>
+      <a:lnStyleLst>
+        <a:ln w="12700" cap="flat" cmpd="sng" algn="ctr">
+          <a:solidFill>
+            <a:schemeClr val="phClr"/>
+          </a:solidFill>
+          <a:prstDash val="solid"/>
+          <a:miter lim="800000"/>
+        </a:ln>
+        <a:ln w="19050" cap="flat" cmpd="sng" algn="ctr">
+          <a:solidFill>
+            <a:schemeClr val="phClr"/>
+          </a:solidFill>
+          <a:prstDash val="solid"/>
+          <a:miter lim="800000"/>
+        </a:ln>
+        <a:ln w="25400" cap="flat" cmpd="sng" algn="ctr">
+          <a:solidFill>
+            <a:schemeClr val="phClr"/>
+          </a:solidFill>
+          <a:prstDash val="solid"/>
+          <a:miter lim="800000"/>
+        </a:ln>
+      </a:lnStyleLst>
+      <a:effectStyleLst>
+        <a:effectStyle>
+          <a:effectLst/>
+        </a:effectStyle>
+        <a:effectStyle>
+          <a:effectLst/>
+        </a:effectStyle>
+        <a:effectStyle>
+          <a:effectLst>
+            <a:outerShdw blurRad="57150" dist="19050" dir="5400000" algn="ctr" rotWithShape="0">
+              <a:srgbClr val="000000">
+                <a:alpha val="63000"/>
+              </a:srgbClr>
+            </a:outerShdw>
+          </a:effectLst>
+        </a:effectStyle>
+      </a:effectStyleLst>
+      <a:bgFillStyleLst>
+        <a:solidFill>
+          <a:schemeClr val="phClr"/>
+        </a:solidFill>
+        <a:solidFill>
+          <a:schemeClr val="phClr">
+            <a:tint val="95000"/>
+            <a:satMod val="170000"/>
+          </a:schemeClr>
+        </a:solidFill>
+        <a:gradFill rotWithShape="1">
+          <a:gsLst>
+            <a:gs pos="0">
+              <a:schemeClr val="phClr">
+                <a:tint val="93000"/>
+                <a:satMod val="150000"/>
+                <a:shade val="98000"/>
+                <a:lumMod val="102000"/>
+              </a:schemeClr>
+            </a:gs>
+            <a:gs pos="50000">
+              <a:schemeClr val="phClr">
+                <a:tint val="98000"/>
+                <a:satMod val="130000"/>
+                <a:shade val="90000"/>
+                <a:lumMod val="103000"/>
+              </a:schemeClr>
+            </a:gs>
+            <a:gs pos="100000">
+              <a:schemeClr val="phClr">
+                <a:shade val="63000"/>
+                <a:satMod val="120000"/>
+              </a:schemeClr>
+            </a:gs>
+          </a:gsLst>
+          <a:lin ang="5400000" scaled="0"/>
+        </a:gradFill>
+      </a:bgFillStyleLst>
+    </a:fmtScheme>
+  </a:themeElements>
+  <a:objectDefaults>
+    <a:lnDef>
+      <a:spPr/>
+      <a:bodyPr/>
+      <a:lstStyle/>
+      <a:style>
+        <a:lnRef idx="2">
+          <a:schemeClr val="accent1"/>
+        </a:lnRef>
+        <a:fillRef idx="0">
+          <a:schemeClr val="accent1"/>
+        </a:fillRef>
+        <a:effectRef idx="1">
+          <a:schemeClr val="accent1"/>
+        </a:effectRef>
+        <a:fontRef idx="minor">
+          <a:schemeClr val="tx1"/>
+        </a:fontRef>
+      </a:style>
+    </a:lnDef>
+  </a:objectDefaults>
+  <a:extraClrSchemeLst/>
+  <a:extLst>
+    <a:ext uri="{05A4C25C-085E-4340-85A3-A5531E510DB2}">
+      <thm15:themeFamily xmlns:thm15="http://schemas.microsoft.com/office/thememl/2012/main" name="Office Theme" id="{2E142A2C-CD16-42D6-873A-C26D2A0506FA}" vid="{1BDDFF52-6CD6-40A5-AB3C-68EB2F1E4D0A}"/>
+    </a:ext>
+  </a:extLst>
+</a:theme>
 </file>
</xml_diff>

<commit_message>
final poster changes (hopefully)
</commit_message>
<xml_diff>
--- a/Poster.pptx
+++ b/Poster.pptx
@@ -8915,7 +8915,7 @@
         </p:nvSpPr>
         <p:spPr>
           <a:xfrm>
-            <a:off x="5961301" y="5440069"/>
+            <a:off x="6166884" y="5449632"/>
             <a:ext cx="3732510" cy="2657496"/>
           </a:xfrm>
           <a:prstGeom prst="rect">
@@ -9055,7 +9055,7 @@
         </p:nvSpPr>
         <p:spPr>
           <a:xfrm>
-            <a:off x="2867278" y="2730795"/>
+            <a:off x="3072861" y="2740358"/>
             <a:ext cx="2461845" cy="2647359"/>
           </a:xfrm>
           <a:prstGeom prst="rect">
@@ -9114,7 +9114,7 @@
         </p:blipFill>
         <p:spPr>
           <a:xfrm>
-            <a:off x="2932529" y="2797884"/>
+            <a:off x="3138112" y="2807447"/>
             <a:ext cx="2331341" cy="1717293"/>
           </a:xfrm>
           <a:prstGeom prst="rect">
@@ -9136,7 +9136,7 @@
         </p:nvSpPr>
         <p:spPr>
           <a:xfrm>
-            <a:off x="2859907" y="4547157"/>
+            <a:off x="3065490" y="4556720"/>
             <a:ext cx="2469215" cy="830997"/>
           </a:xfrm>
           <a:prstGeom prst="rect">
@@ -9172,7 +9172,7 @@
         </p:nvSpPr>
         <p:spPr>
           <a:xfrm>
-            <a:off x="5415175" y="2730795"/>
+            <a:off x="5620758" y="2740358"/>
             <a:ext cx="1968197" cy="2647359"/>
           </a:xfrm>
           <a:prstGeom prst="rect">
@@ -9231,7 +9231,7 @@
         </p:blipFill>
         <p:spPr>
           <a:xfrm>
-            <a:off x="5486953" y="2808648"/>
+            <a:off x="5692536" y="2818211"/>
             <a:ext cx="1844249" cy="1695763"/>
           </a:xfrm>
           <a:prstGeom prst="rect">
@@ -9253,7 +9253,7 @@
         </p:nvSpPr>
         <p:spPr>
           <a:xfrm>
-            <a:off x="5415174" y="4537701"/>
+            <a:off x="5620757" y="4547264"/>
             <a:ext cx="1968196" cy="830997"/>
           </a:xfrm>
           <a:prstGeom prst="rect">
@@ -9289,7 +9289,7 @@
         </p:nvSpPr>
         <p:spPr>
           <a:xfrm>
-            <a:off x="7469422" y="2736761"/>
+            <a:off x="7675005" y="2746324"/>
             <a:ext cx="2578135" cy="2630190"/>
           </a:xfrm>
           <a:prstGeom prst="rect">
@@ -9348,7 +9348,7 @@
         </p:blipFill>
         <p:spPr>
           <a:xfrm>
-            <a:off x="7532442" y="2817829"/>
+            <a:off x="7738025" y="2827392"/>
             <a:ext cx="2452094" cy="1719872"/>
           </a:xfrm>
           <a:prstGeom prst="rect">
@@ -9370,7 +9370,7 @@
         </p:nvSpPr>
         <p:spPr>
           <a:xfrm>
-            <a:off x="7472756" y="4554611"/>
+            <a:off x="7678339" y="4564174"/>
             <a:ext cx="2571465" cy="830997"/>
           </a:xfrm>
           <a:prstGeom prst="rect">
@@ -9406,7 +9406,7 @@
         </p:nvSpPr>
         <p:spPr>
           <a:xfrm>
-            <a:off x="2869882" y="5440068"/>
+            <a:off x="3075465" y="5449631"/>
             <a:ext cx="3042943" cy="2657496"/>
           </a:xfrm>
           <a:prstGeom prst="rect">
@@ -9465,7 +9465,7 @@
         </p:blipFill>
         <p:spPr>
           <a:xfrm>
-            <a:off x="2931192" y="5513865"/>
+            <a:off x="3136775" y="5523428"/>
             <a:ext cx="2920321" cy="1986203"/>
           </a:xfrm>
           <a:prstGeom prst="rect">
@@ -9487,7 +9487,7 @@
         </p:nvSpPr>
         <p:spPr>
           <a:xfrm>
-            <a:off x="2869882" y="7502411"/>
+            <a:off x="3075465" y="7511974"/>
             <a:ext cx="3010878" cy="584775"/>
           </a:xfrm>
           <a:prstGeom prst="rect">
@@ -9531,7 +9531,7 @@
         </p:blipFill>
         <p:spPr>
           <a:xfrm>
-            <a:off x="6043558" y="5516013"/>
+            <a:off x="6249141" y="5525576"/>
             <a:ext cx="3587813" cy="1981906"/>
           </a:xfrm>
           <a:prstGeom prst="rect">
@@ -9553,7 +9553,7 @@
         </p:nvSpPr>
         <p:spPr>
           <a:xfrm>
-            <a:off x="5974649" y="7484621"/>
+            <a:off x="6180232" y="7494184"/>
             <a:ext cx="3719162" cy="584775"/>
           </a:xfrm>
           <a:prstGeom prst="rect">
@@ -9589,7 +9589,7 @@
         </p:nvSpPr>
         <p:spPr>
           <a:xfrm>
-            <a:off x="9755634" y="6258655"/>
+            <a:off x="9961217" y="6268218"/>
             <a:ext cx="2578135" cy="1826810"/>
           </a:xfrm>
           <a:prstGeom prst="rect">
@@ -9640,7 +9640,7 @@
         </p:nvSpPr>
         <p:spPr>
           <a:xfrm>
-            <a:off x="9762103" y="6253514"/>
+            <a:off x="9967686" y="6263077"/>
             <a:ext cx="2571666" cy="1815882"/>
           </a:xfrm>
           <a:prstGeom prst="rect">

</xml_diff>

<commit_message>
small balancing changes and more report writing
</commit_message>
<xml_diff>
--- a/Poster.pptx
+++ b/Poster.pptx
@@ -197,7 +197,7 @@
           <a:p>
             <a:fld id="{F4CF48D3-D0BF-45C1-ADCB-12E0ED15E779}" type="datetimeFigureOut">
               <a:rPr lang="en-GB" smtClean="0"/>
-              <a:t>13/04/2026</a:t>
+              <a:t>15/04/2026</a:t>
             </a:fld>
             <a:endParaRPr lang="en-GB"/>
           </a:p>
@@ -719,7 +719,7 @@
           <a:p>
             <a:fld id="{72EA7947-E287-4738-8C82-07CE4F01EF03}" type="datetime2">
               <a:rPr lang="en-US" smtClean="0"/>
-              <a:t>Monday, April 13, 2026</a:t>
+              <a:t>Wednesday, April 15, 2026</a:t>
             </a:fld>
             <a:endParaRPr lang="en-US" dirty="0"/>
           </a:p>
@@ -1755,7 +1755,7 @@
           <a:p>
             <a:fld id="{EE2EBD84-71F4-4271-8C46-0D47C0A9B12E}" type="datetime2">
               <a:rPr lang="en-US" smtClean="0"/>
-              <a:t>Monday, April 13, 2026</a:t>
+              <a:t>Wednesday, April 15, 2026</a:t>
             </a:fld>
             <a:endParaRPr lang="en-US"/>
           </a:p>
@@ -1966,7 +1966,7 @@
           <a:p>
             <a:fld id="{ABAE0CE1-F450-4107-B2CB-17B18F8A3F4A}" type="datetime2">
               <a:rPr lang="en-US" smtClean="0"/>
-              <a:t>Monday, April 13, 2026</a:t>
+              <a:t>Wednesday, April 15, 2026</a:t>
             </a:fld>
             <a:endParaRPr lang="en-US"/>
           </a:p>
@@ -2631,7 +2631,7 @@
           <a:p>
             <a:fld id="{6FE8C025-CD7A-4966-867E-81CF82B15267}" type="datetime2">
               <a:rPr lang="en-US" smtClean="0"/>
-              <a:t>Monday, April 13, 2026</a:t>
+              <a:t>Wednesday, April 15, 2026</a:t>
             </a:fld>
             <a:endParaRPr lang="en-US"/>
           </a:p>
@@ -3251,7 +3251,7 @@
           <a:p>
             <a:fld id="{FE809929-0719-4517-94D6-FDF7F99E70F6}" type="datetime2">
               <a:rPr lang="en-US" smtClean="0"/>
-              <a:t>Monday, April 13, 2026</a:t>
+              <a:t>Wednesday, April 15, 2026</a:t>
             </a:fld>
             <a:endParaRPr lang="en-US"/>
           </a:p>
@@ -4369,7 +4369,7 @@
           <a:p>
             <a:fld id="{20E95673-5512-4AAA-9AEB-E00C61EC65D5}" type="datetime2">
               <a:rPr lang="en-US" smtClean="0"/>
-              <a:t>Monday, April 13, 2026</a:t>
+              <a:t>Wednesday, April 15, 2026</a:t>
             </a:fld>
             <a:endParaRPr lang="en-US"/>
           </a:p>
@@ -4916,7 +4916,7 @@
           <a:p>
             <a:fld id="{C13138FA-2E87-4873-8BBA-13E447C9A99A}" type="datetime2">
               <a:rPr lang="en-US" smtClean="0"/>
-              <a:t>Monday, April 13, 2026</a:t>
+              <a:t>Wednesday, April 15, 2026</a:t>
             </a:fld>
             <a:endParaRPr lang="en-US"/>
           </a:p>
@@ -5077,7 +5077,7 @@
           <a:p>
             <a:fld id="{D75BB40A-97BD-4BFB-B639-0BFF95FDE8B7}" type="datetime2">
               <a:rPr lang="en-US" smtClean="0"/>
-              <a:t>Monday, April 13, 2026</a:t>
+              <a:t>Wednesday, April 15, 2026</a:t>
             </a:fld>
             <a:endParaRPr lang="en-US"/>
           </a:p>
@@ -6112,7 +6112,7 @@
           <a:p>
             <a:fld id="{9EE9E0E3-ECF6-4CFE-8698-AEFEBCECC3C0}" type="datetime2">
               <a:rPr lang="en-US" smtClean="0"/>
-              <a:t>Monday, April 13, 2026</a:t>
+              <a:t>Wednesday, April 15, 2026</a:t>
             </a:fld>
             <a:endParaRPr lang="en-US"/>
           </a:p>
@@ -6758,7 +6758,7 @@
           <a:p>
             <a:fld id="{251462FC-960E-4740-921F-B36862979F21}" type="datetime2">
               <a:rPr lang="en-US" smtClean="0"/>
-              <a:t>Monday, April 13, 2026</a:t>
+              <a:t>Wednesday, April 15, 2026</a:t>
             </a:fld>
             <a:endParaRPr lang="en-US"/>
           </a:p>
@@ -7522,7 +7522,7 @@
           <a:p>
             <a:fld id="{E50BC9E2-CB44-4C05-9BB5-496C18A241E0}" type="datetime2">
               <a:rPr lang="en-US" smtClean="0"/>
-              <a:t>Monday, April 13, 2026</a:t>
+              <a:t>Wednesday, April 15, 2026</a:t>
             </a:fld>
             <a:endParaRPr lang="en-US"/>
           </a:p>
@@ -7775,7 +7775,7 @@
           <a:p>
             <a:fld id="{246CB39B-5F4C-4A7E-9BE3-AAFD45576D16}" type="datetime2">
               <a:rPr lang="en-US" smtClean="0"/>
-              <a:t>Monday, April 13, 2026</a:t>
+              <a:t>Wednesday, April 15, 2026</a:t>
             </a:fld>
             <a:endParaRPr lang="en-US" dirty="0"/>
           </a:p>
@@ -8903,7 +8903,7 @@
       </p:pic>
       <p:sp>
         <p:nvSpPr>
-          <p:cNvPr id="26" name="Rectangle 25">
+          <p:cNvPr id="26" name="Rectangle: Rounded Corners 25">
             <a:extLst>
               <a:ext uri="{FF2B5EF4-FFF2-40B4-BE49-F238E27FC236}">
                 <a16:creationId xmlns:a16="http://schemas.microsoft.com/office/drawing/2014/main" id="{E65147BC-9F9D-53BB-6C7E-24E5AD84E084}"/>
@@ -8918,8 +8918,10 @@
             <a:off x="6166884" y="5449632"/>
             <a:ext cx="3732510" cy="2657496"/>
           </a:xfrm>
-          <a:prstGeom prst="rect">
-            <a:avLst/>
+          <a:prstGeom prst="roundRect">
+            <a:avLst>
+              <a:gd name="adj" fmla="val 2992"/>
+            </a:avLst>
           </a:prstGeom>
           <a:solidFill>
             <a:srgbClr val="000000">
@@ -9043,7 +9045,7 @@
       </p:sp>
       <p:sp>
         <p:nvSpPr>
-          <p:cNvPr id="24" name="Rectangle 23">
+          <p:cNvPr id="24" name="Rectangle: Rounded Corners 23">
             <a:extLst>
               <a:ext uri="{FF2B5EF4-FFF2-40B4-BE49-F238E27FC236}">
                 <a16:creationId xmlns:a16="http://schemas.microsoft.com/office/drawing/2014/main" id="{870B11C9-D814-92BC-71D2-515402425ABF}"/>
@@ -9058,8 +9060,10 @@
             <a:off x="3072861" y="2740358"/>
             <a:ext cx="2461845" cy="2647359"/>
           </a:xfrm>
-          <a:prstGeom prst="rect">
-            <a:avLst/>
+          <a:prstGeom prst="roundRect">
+            <a:avLst>
+              <a:gd name="adj" fmla="val 3333"/>
+            </a:avLst>
           </a:prstGeom>
           <a:solidFill>
             <a:srgbClr val="000000">
@@ -9160,7 +9164,7 @@
       </p:sp>
       <p:sp>
         <p:nvSpPr>
-          <p:cNvPr id="38" name="Rectangle 37">
+          <p:cNvPr id="38" name="Rectangle: Rounded Corners 37">
             <a:extLst>
               <a:ext uri="{FF2B5EF4-FFF2-40B4-BE49-F238E27FC236}">
                 <a16:creationId xmlns:a16="http://schemas.microsoft.com/office/drawing/2014/main" id="{A9F7AE95-0423-3232-EBB2-7086B0AA2618}"/>
@@ -9175,8 +9179,10 @@
             <a:off x="5620758" y="2740358"/>
             <a:ext cx="1968197" cy="2647359"/>
           </a:xfrm>
-          <a:prstGeom prst="rect">
-            <a:avLst/>
+          <a:prstGeom prst="roundRect">
+            <a:avLst>
+              <a:gd name="adj" fmla="val 3563"/>
+            </a:avLst>
           </a:prstGeom>
           <a:solidFill>
             <a:srgbClr val="000000">
@@ -9277,7 +9283,7 @@
       </p:sp>
       <p:sp>
         <p:nvSpPr>
-          <p:cNvPr id="39" name="Rectangle 38">
+          <p:cNvPr id="39" name="Rectangle: Rounded Corners 38">
             <a:extLst>
               <a:ext uri="{FF2B5EF4-FFF2-40B4-BE49-F238E27FC236}">
                 <a16:creationId xmlns:a16="http://schemas.microsoft.com/office/drawing/2014/main" id="{297AFF86-F149-0F13-11BF-0D6BEDEE2D5B}"/>
@@ -9290,10 +9296,12 @@
         <p:spPr>
           <a:xfrm>
             <a:off x="7675005" y="2746324"/>
-            <a:ext cx="2578135" cy="2630190"/>
+            <a:ext cx="2221055" cy="2630190"/>
           </a:xfrm>
-          <a:prstGeom prst="rect">
-            <a:avLst/>
+          <a:prstGeom prst="roundRect">
+            <a:avLst>
+              <a:gd name="adj" fmla="val 2944"/>
+            </a:avLst>
           </a:prstGeom>
           <a:solidFill>
             <a:srgbClr val="000000">
@@ -9349,7 +9357,7 @@
         <p:spPr>
           <a:xfrm>
             <a:off x="7738025" y="2827392"/>
-            <a:ext cx="2452094" cy="1719872"/>
+            <a:ext cx="2098929" cy="1719872"/>
           </a:xfrm>
           <a:prstGeom prst="rect">
             <a:avLst/>
@@ -9371,7 +9379,7 @@
         <p:spPr>
           <a:xfrm>
             <a:off x="7678339" y="4564174"/>
-            <a:ext cx="2571465" cy="830997"/>
+            <a:ext cx="2221055" cy="830997"/>
           </a:xfrm>
           <a:prstGeom prst="rect">
             <a:avLst/>
@@ -9394,7 +9402,7 @@
       </p:sp>
       <p:sp>
         <p:nvSpPr>
-          <p:cNvPr id="43" name="Rectangle 42">
+          <p:cNvPr id="43" name="Rectangle: Rounded Corners 42">
             <a:extLst>
               <a:ext uri="{FF2B5EF4-FFF2-40B4-BE49-F238E27FC236}">
                 <a16:creationId xmlns:a16="http://schemas.microsoft.com/office/drawing/2014/main" id="{28180014-961A-3C40-4EF5-B48B34745C55}"/>
@@ -9409,8 +9417,10 @@
             <a:off x="3075465" y="5449631"/>
             <a:ext cx="3042943" cy="2657496"/>
           </a:xfrm>
-          <a:prstGeom prst="rect">
-            <a:avLst/>
+          <a:prstGeom prst="roundRect">
+            <a:avLst>
+              <a:gd name="adj" fmla="val 2992"/>
+            </a:avLst>
           </a:prstGeom>
           <a:solidFill>
             <a:srgbClr val="000000">
@@ -9577,7 +9587,7 @@
       </p:sp>
       <p:sp>
         <p:nvSpPr>
-          <p:cNvPr id="50" name="Rectangle 49">
+          <p:cNvPr id="50" name="Rectangle: Rounded Corners 49">
             <a:extLst>
               <a:ext uri="{FF2B5EF4-FFF2-40B4-BE49-F238E27FC236}">
                 <a16:creationId xmlns:a16="http://schemas.microsoft.com/office/drawing/2014/main" id="{902C15CA-61BF-EE18-9872-B6427FEEB07D}"/>
@@ -9589,11 +9599,13 @@
         </p:nvSpPr>
         <p:spPr>
           <a:xfrm>
-            <a:off x="9961217" y="6268218"/>
-            <a:ext cx="2578135" cy="1826810"/>
+            <a:off x="9961217" y="2746325"/>
+            <a:ext cx="2578135" cy="5348704"/>
           </a:xfrm>
-          <a:prstGeom prst="rect">
-            <a:avLst/>
+          <a:prstGeom prst="roundRect">
+            <a:avLst>
+              <a:gd name="adj" fmla="val 3026"/>
+            </a:avLst>
           </a:prstGeom>
           <a:solidFill>
             <a:srgbClr val="000000">
@@ -9640,8 +9652,8 @@
         </p:nvSpPr>
         <p:spPr>
           <a:xfrm>
-            <a:off x="9967686" y="6263077"/>
-            <a:ext cx="2571666" cy="1815882"/>
+            <a:off x="9964550" y="2746324"/>
+            <a:ext cx="2574801" cy="5262979"/>
           </a:xfrm>
           <a:prstGeom prst="rect">
             <a:avLst/>
@@ -9653,6 +9665,60 @@
             <a:spAutoFit/>
           </a:bodyPr>
           <a:lstStyle/>
+          <a:p>
+            <a:pPr marL="285750" indent="-285750">
+              <a:buFont typeface="Arial" panose="020B0604020202020204" pitchFamily="34" charset="0"/>
+              <a:buChar char="•"/>
+            </a:pPr>
+            <a:r>
+              <a:rPr lang="en-GB" sz="1600"/>
+              <a:t>For gamers of all ages</a:t>
+            </a:r>
+            <a:endParaRPr lang="en-GB" sz="1600" dirty="0"/>
+          </a:p>
+          <a:p>
+            <a:pPr marL="285750" indent="-285750">
+              <a:buFont typeface="Arial" panose="020B0604020202020204" pitchFamily="34" charset="0"/>
+              <a:buChar char="•"/>
+            </a:pPr>
+            <a:endParaRPr lang="en-GB" sz="1600" dirty="0"/>
+          </a:p>
+          <a:p>
+            <a:endParaRPr lang="en-GB" sz="1600" dirty="0"/>
+          </a:p>
+          <a:p>
+            <a:endParaRPr lang="en-GB" sz="1600" dirty="0"/>
+          </a:p>
+          <a:p>
+            <a:endParaRPr lang="en-GB" sz="1600" dirty="0"/>
+          </a:p>
+          <a:p>
+            <a:endParaRPr lang="en-GB" sz="1600" dirty="0"/>
+          </a:p>
+          <a:p>
+            <a:endParaRPr lang="en-GB" sz="1600" dirty="0"/>
+          </a:p>
+          <a:p>
+            <a:endParaRPr lang="en-GB" sz="1600" dirty="0"/>
+          </a:p>
+          <a:p>
+            <a:endParaRPr lang="en-GB" sz="1600" dirty="0"/>
+          </a:p>
+          <a:p>
+            <a:endParaRPr lang="en-GB" sz="1600" dirty="0"/>
+          </a:p>
+          <a:p>
+            <a:endParaRPr lang="en-GB" sz="1600" dirty="0"/>
+          </a:p>
+          <a:p>
+            <a:endParaRPr lang="en-GB" sz="1600" dirty="0"/>
+          </a:p>
+          <a:p>
+            <a:endParaRPr lang="en-GB" sz="1600" dirty="0"/>
+          </a:p>
+          <a:p>
+            <a:endParaRPr lang="en-GB" sz="1600" dirty="0"/>
+          </a:p>
           <a:p>
             <a:r>
               <a:rPr lang="en-GB" sz="1600" dirty="0"/>

</xml_diff>

<commit_message>
Added comments to all scripts and made more progress to the report
</commit_message>
<xml_diff>
--- a/Poster.pptx
+++ b/Poster.pptx
@@ -197,7 +197,7 @@
           <a:p>
             <a:fld id="{F4CF48D3-D0BF-45C1-ADCB-12E0ED15E779}" type="datetimeFigureOut">
               <a:rPr lang="en-GB" smtClean="0"/>
-              <a:t>15/04/2026</a:t>
+              <a:t>18/04/2026</a:t>
             </a:fld>
             <a:endParaRPr lang="en-GB"/>
           </a:p>
@@ -719,7 +719,7 @@
           <a:p>
             <a:fld id="{72EA7947-E287-4738-8C82-07CE4F01EF03}" type="datetime2">
               <a:rPr lang="en-US" smtClean="0"/>
-              <a:t>Wednesday, April 15, 2026</a:t>
+              <a:t>Saturday, April 18, 2026</a:t>
             </a:fld>
             <a:endParaRPr lang="en-US" dirty="0"/>
           </a:p>
@@ -1755,7 +1755,7 @@
           <a:p>
             <a:fld id="{EE2EBD84-71F4-4271-8C46-0D47C0A9B12E}" type="datetime2">
               <a:rPr lang="en-US" smtClean="0"/>
-              <a:t>Wednesday, April 15, 2026</a:t>
+              <a:t>Saturday, April 18, 2026</a:t>
             </a:fld>
             <a:endParaRPr lang="en-US"/>
           </a:p>
@@ -1966,7 +1966,7 @@
           <a:p>
             <a:fld id="{ABAE0CE1-F450-4107-B2CB-17B18F8A3F4A}" type="datetime2">
               <a:rPr lang="en-US" smtClean="0"/>
-              <a:t>Wednesday, April 15, 2026</a:t>
+              <a:t>Saturday, April 18, 2026</a:t>
             </a:fld>
             <a:endParaRPr lang="en-US"/>
           </a:p>
@@ -2631,7 +2631,7 @@
           <a:p>
             <a:fld id="{6FE8C025-CD7A-4966-867E-81CF82B15267}" type="datetime2">
               <a:rPr lang="en-US" smtClean="0"/>
-              <a:t>Wednesday, April 15, 2026</a:t>
+              <a:t>Saturday, April 18, 2026</a:t>
             </a:fld>
             <a:endParaRPr lang="en-US"/>
           </a:p>
@@ -3251,7 +3251,7 @@
           <a:p>
             <a:fld id="{FE809929-0719-4517-94D6-FDF7F99E70F6}" type="datetime2">
               <a:rPr lang="en-US" smtClean="0"/>
-              <a:t>Wednesday, April 15, 2026</a:t>
+              <a:t>Saturday, April 18, 2026</a:t>
             </a:fld>
             <a:endParaRPr lang="en-US"/>
           </a:p>
@@ -4369,7 +4369,7 @@
           <a:p>
             <a:fld id="{20E95673-5512-4AAA-9AEB-E00C61EC65D5}" type="datetime2">
               <a:rPr lang="en-US" smtClean="0"/>
-              <a:t>Wednesday, April 15, 2026</a:t>
+              <a:t>Saturday, April 18, 2026</a:t>
             </a:fld>
             <a:endParaRPr lang="en-US"/>
           </a:p>
@@ -4916,7 +4916,7 @@
           <a:p>
             <a:fld id="{C13138FA-2E87-4873-8BBA-13E447C9A99A}" type="datetime2">
               <a:rPr lang="en-US" smtClean="0"/>
-              <a:t>Wednesday, April 15, 2026</a:t>
+              <a:t>Saturday, April 18, 2026</a:t>
             </a:fld>
             <a:endParaRPr lang="en-US"/>
           </a:p>
@@ -5077,7 +5077,7 @@
           <a:p>
             <a:fld id="{D75BB40A-97BD-4BFB-B639-0BFF95FDE8B7}" type="datetime2">
               <a:rPr lang="en-US" smtClean="0"/>
-              <a:t>Wednesday, April 15, 2026</a:t>
+              <a:t>Saturday, April 18, 2026</a:t>
             </a:fld>
             <a:endParaRPr lang="en-US"/>
           </a:p>
@@ -6112,7 +6112,7 @@
           <a:p>
             <a:fld id="{9EE9E0E3-ECF6-4CFE-8698-AEFEBCECC3C0}" type="datetime2">
               <a:rPr lang="en-US" smtClean="0"/>
-              <a:t>Wednesday, April 15, 2026</a:t>
+              <a:t>Saturday, April 18, 2026</a:t>
             </a:fld>
             <a:endParaRPr lang="en-US"/>
           </a:p>
@@ -6758,7 +6758,7 @@
           <a:p>
             <a:fld id="{251462FC-960E-4740-921F-B36862979F21}" type="datetime2">
               <a:rPr lang="en-US" smtClean="0"/>
-              <a:t>Wednesday, April 15, 2026</a:t>
+              <a:t>Saturday, April 18, 2026</a:t>
             </a:fld>
             <a:endParaRPr lang="en-US"/>
           </a:p>
@@ -7522,7 +7522,7 @@
           <a:p>
             <a:fld id="{E50BC9E2-CB44-4C05-9BB5-496C18A241E0}" type="datetime2">
               <a:rPr lang="en-US" smtClean="0"/>
-              <a:t>Wednesday, April 15, 2026</a:t>
+              <a:t>Saturday, April 18, 2026</a:t>
             </a:fld>
             <a:endParaRPr lang="en-US"/>
           </a:p>
@@ -7775,7 +7775,7 @@
           <a:p>
             <a:fld id="{246CB39B-5F4C-4A7E-9BE3-AAFD45576D16}" type="datetime2">
               <a:rPr lang="en-US" smtClean="0"/>
-              <a:t>Wednesday, April 15, 2026</a:t>
+              <a:t>Saturday, April 18, 2026</a:t>
             </a:fld>
             <a:endParaRPr lang="en-US" dirty="0"/>
           </a:p>
@@ -9671,58 +9671,18 @@
               <a:buChar char="•"/>
             </a:pPr>
             <a:r>
-              <a:rPr lang="en-GB" sz="1600"/>
-              <a:t>For gamers of all ages</a:t>
-            </a:r>
-            <a:endParaRPr lang="en-GB" sz="1600" dirty="0"/>
+              <a:rPr lang="en-GB" sz="1600" dirty="0"/>
+              <a:t>For people of all ages who like games like Cuphead and Hollow Knight</a:t>
+            </a:r>
           </a:p>
           <a:p>
             <a:pPr marL="285750" indent="-285750">
               <a:buFont typeface="Arial" panose="020B0604020202020204" pitchFamily="34" charset="0"/>
               <a:buChar char="•"/>
             </a:pPr>
-            <a:endParaRPr lang="en-GB" sz="1600" dirty="0"/>
-          </a:p>
-          <a:p>
-            <a:endParaRPr lang="en-GB" sz="1600" dirty="0"/>
-          </a:p>
-          <a:p>
-            <a:endParaRPr lang="en-GB" sz="1600" dirty="0"/>
-          </a:p>
-          <a:p>
-            <a:endParaRPr lang="en-GB" sz="1600" dirty="0"/>
-          </a:p>
-          <a:p>
-            <a:endParaRPr lang="en-GB" sz="1600" dirty="0"/>
-          </a:p>
-          <a:p>
-            <a:endParaRPr lang="en-GB" sz="1600" dirty="0"/>
-          </a:p>
-          <a:p>
-            <a:endParaRPr lang="en-GB" sz="1600" dirty="0"/>
-          </a:p>
-          <a:p>
-            <a:endParaRPr lang="en-GB" sz="1600" dirty="0"/>
-          </a:p>
-          <a:p>
-            <a:endParaRPr lang="en-GB" sz="1600" dirty="0"/>
-          </a:p>
-          <a:p>
-            <a:endParaRPr lang="en-GB" sz="1600" dirty="0"/>
-          </a:p>
-          <a:p>
-            <a:endParaRPr lang="en-GB" sz="1600" dirty="0"/>
-          </a:p>
-          <a:p>
-            <a:endParaRPr lang="en-GB" sz="1600" dirty="0"/>
-          </a:p>
-          <a:p>
-            <a:endParaRPr lang="en-GB" sz="1600" dirty="0"/>
-          </a:p>
-          <a:p>
             <a:r>
               <a:rPr lang="en-GB" sz="1600" dirty="0"/>
-              <a:t>Additional features include:</a:t>
+              <a:t>A fishing rod for grappling hook</a:t>
             </a:r>
           </a:p>
           <a:p>
@@ -9732,7 +9692,7 @@
             </a:pPr>
             <a:r>
               <a:rPr lang="en-GB" sz="1600" dirty="0"/>
-              <a:t>Pause “menu”.</a:t>
+              <a:t>Pause menu in the style of a restaurant menu</a:t>
             </a:r>
           </a:p>
           <a:p>
@@ -9742,7 +9702,25 @@
             </a:pPr>
             <a:r>
               <a:rPr lang="en-GB" sz="1600" dirty="0"/>
-              <a:t>Play on pc or controller!</a:t>
+              <a:t>Defeated fish and bosses appear on the menu as food with prices</a:t>
+            </a:r>
+          </a:p>
+          <a:p>
+            <a:endParaRPr lang="en-GB" sz="1600" dirty="0"/>
+          </a:p>
+          <a:p>
+            <a:endParaRPr lang="en-GB" sz="1600" dirty="0"/>
+          </a:p>
+          <a:p>
+            <a:endParaRPr lang="en-GB" sz="1600" dirty="0"/>
+          </a:p>
+          <a:p>
+            <a:endParaRPr lang="en-GB" sz="1600" dirty="0"/>
+          </a:p>
+          <a:p>
+            <a:r>
+              <a:rPr lang="en-GB" sz="1600" dirty="0"/>
+              <a:t>Additional features include:</a:t>
             </a:r>
           </a:p>
           <a:p>
@@ -9752,7 +9730,7 @@
             </a:pPr>
             <a:r>
               <a:rPr lang="en-GB" sz="1600" dirty="0"/>
-              <a:t>Speedrun timer.</a:t>
+              <a:t>Play on pc or controller!</a:t>
             </a:r>
           </a:p>
           <a:p>
@@ -9762,7 +9740,7 @@
             </a:pPr>
             <a:r>
               <a:rPr lang="en-GB" sz="1600" dirty="0"/>
-              <a:t>Data stored locally.</a:t>
+              <a:t>Speedrun timer.</a:t>
             </a:r>
           </a:p>
           <a:p>
@@ -9772,7 +9750,7 @@
             </a:pPr>
             <a:r>
               <a:rPr lang="en-GB" sz="1600" dirty="0"/>
-              <a:t>More levels in the future.</a:t>
+              <a:t>Data stored locally.</a:t>
             </a:r>
           </a:p>
           <a:p>
@@ -9782,7 +9760,17 @@
             </a:pPr>
             <a:r>
               <a:rPr lang="en-GB" sz="1600" dirty="0"/>
-              <a:t>And so much more!</a:t>
+              <a:t>More levels in the future.</a:t>
+            </a:r>
+          </a:p>
+          <a:p>
+            <a:pPr marL="285750" indent="-285750">
+              <a:buFont typeface="Arial" panose="020B0604020202020204" pitchFamily="34" charset="0"/>
+              <a:buChar char="•"/>
+            </a:pPr>
+            <a:r>
+              <a:rPr lang="en-GB" sz="1600" dirty="0"/>
+              <a:t>And much more!</a:t>
             </a:r>
           </a:p>
         </p:txBody>

</xml_diff>